<commit_message>
nightly deck: data through 2026-08-26
</commit_message>
<xml_diff>
--- a/docs/nc-drug-checking-latest.pptx
+++ b/docs/nc-drug-checking-latest.pptx
@@ -2374,6 +2374,55 @@
           </a:p>
         </p:txBody>
       </p:sp>
+      <p:sp>
+        <p:nvSpPr>
+          <p:cNvPr id="4" name=""/>
+          <p:cNvSpPr>
+            <a:spLocks noGrp="1"/>
+          </p:cNvSpPr>
+          <p:nvPr>
+            <p:ph/>
+          </p:nvPr>
+        </p:nvSpPr>
+        <p:spPr>
+          <a:xfrm>
+            <a:off x="698500" y="1511300"/>
+            <a:ext cx="10795000" cy="4584700"/>
+          </a:xfrm>
+        </p:spPr>
+        <p:txBody>
+          <a:bodyPr/>
+          <a:lstStyle/>
+          <a:p>
+            <a:pPr algn="l" marL="0" marR="0">
+              <a:lnSpc>
+                <a:spcPct val="100000"/>
+              </a:lnSpc>
+              <a:spcBef>
+                <a:spcPts val="0"/>
+              </a:spcBef>
+              <a:spcAft>
+                <a:spcPts val="0"/>
+              </a:spcAft>
+              <a:buNone/>
+            </a:pPr>
+            <a:r>
+              <a:rPr cap="none" sz="1400" i="0" b="0" u="none" strike="noStrike">
+                <a:solidFill>
+                  <a:srgbClr val="5B6770">
+                    <a:alpha val="100000"/>
+                  </a:srgbClr>
+                </a:solidFill>
+                <a:latin typeface="Helvetica Neue"/>
+                <a:cs typeface="Helvetica Neue"/>
+                <a:ea typeface="Helvetica Neue"/>
+                <a:sym typeface="Helvetica Neue"/>
+              </a:rPr>
+              <a:t>Generated Wednesday, August 26, 2026 · 5:38 PM ET UNC Street Drug Analysis Lab · OpioidData.org · results.streetsafe.supply Download as PowerPoint</a:t>
+            </a:r>
+          </a:p>
+        </p:txBody>
+      </p:sp>
     </p:spTree>
   </p:cSld>
   <p:clrMapOvr>
@@ -2444,6 +2493,55 @@
                 <a:sym typeface="Helvetica Neue"/>
               </a:rPr>
               <a:t>Coverage Summary</a:t>
+            </a:r>
+          </a:p>
+        </p:txBody>
+      </p:sp>
+      <p:sp>
+        <p:nvSpPr>
+          <p:cNvPr id="3" name=""/>
+          <p:cNvSpPr>
+            <a:spLocks noGrp="1"/>
+          </p:cNvSpPr>
+          <p:nvPr>
+            <p:ph/>
+          </p:nvPr>
+        </p:nvSpPr>
+        <p:spPr>
+          <a:xfrm>
+            <a:off x="698500" y="1511300"/>
+            <a:ext cx="10795000" cy="4584700"/>
+          </a:xfrm>
+        </p:spPr>
+        <p:txBody>
+          <a:bodyPr/>
+          <a:lstStyle/>
+          <a:p>
+            <a:pPr algn="l" marL="0" marR="0">
+              <a:lnSpc>
+                <a:spcPct val="100000"/>
+              </a:lnSpc>
+              <a:spcBef>
+                <a:spcPts val="0"/>
+              </a:spcBef>
+              <a:spcAft>
+                <a:spcPts val="0"/>
+              </a:spcAft>
+              <a:buNone/>
+            </a:pPr>
+            <a:r>
+              <a:rPr cap="none" sz="1400" i="0" b="0" u="none" strike="noStrike">
+                <a:solidFill>
+                  <a:srgbClr val="5B6770">
+                    <a:alpha val="100000"/>
+                  </a:srgbClr>
+                </a:solidFill>
+                <a:latin typeface="Helvetica Neue"/>
+                <a:cs typeface="Helvetica Neue"/>
+                <a:ea typeface="Helvetica Neue"/>
+                <a:sym typeface="Helvetica Neue"/>
+              </a:rPr>
+              <a:t>How much of the state the program sees: statewide totals at a glance, sample volume by quarter, and county-level reach — the denominators behind every rate in this deck.</a:t>
             </a:r>
           </a:p>
         </p:txBody>
@@ -2583,6 +2681,55 @@
         </p:nvSpPr>
         <p:spPr>
           <a:xfrm>
+            <a:off x="698500" y="1511300"/>
+            <a:ext cx="10795000" cy="4584700"/>
+          </a:xfrm>
+        </p:spPr>
+        <p:txBody>
+          <a:bodyPr/>
+          <a:lstStyle/>
+          <a:p>
+            <a:pPr algn="l" marL="0" marR="0">
+              <a:lnSpc>
+                <a:spcPct val="100000"/>
+              </a:lnSpc>
+              <a:spcBef>
+                <a:spcPts val="0"/>
+              </a:spcBef>
+              <a:spcAft>
+                <a:spcPts val="0"/>
+              </a:spcAft>
+              <a:buNone/>
+            </a:pPr>
+            <a:r>
+              <a:rPr cap="none" sz="1400" i="0" b="0" u="none" strike="noStrike">
+                <a:solidFill>
+                  <a:srgbClr val="5B6770">
+                    <a:alpha val="100000"/>
+                  </a:srgbClr>
+                </a:solidFill>
+                <a:latin typeface="Helvetica Neue"/>
+                <a:cs typeface="Helvetica Neue"/>
+                <a:ea typeface="Helvetica Neue"/>
+                <a:sym typeface="Helvetica Neue"/>
+              </a:rPr>
+              <a:t>PLACEHOLDER · figs/stats.json January 2022 to Wednesday, August 26, 2026 N = 2,767 NC samples analyzed Mailed in from 86 harm reduction programs Collected across 57 counties 243 distinct substances detected to date Unique samples = n_distinct(sampleid) · substances from lab_detail.substance · includes samples with date_complete 26 Jan 2022 – 26 Aug 2026 r/build_nightly.R → figs/stats.json</a:t>
+            </a:r>
+          </a:p>
+        </p:txBody>
+      </p:sp>
+      <p:sp>
+        <p:nvSpPr>
+          <p:cNvPr id="5" name=""/>
+          <p:cNvSpPr>
+            <a:spLocks noGrp="1"/>
+          </p:cNvSpPr>
+          <p:nvPr>
+            <p:ph/>
+          </p:nvPr>
+        </p:nvSpPr>
+        <p:spPr>
+          <a:xfrm>
             <a:off x="698500" y="6248400"/>
             <a:ext cx="10795000" cy="381000"/>
           </a:xfrm>
@@ -2615,7 +2762,7 @@
                 <a:ea typeface="Helvetica Neue"/>
                 <a:sym typeface="Helvetica Neue"/>
               </a:rPr>
-              <a:t>Unique samples = n_distinct(sampleid) · substances from lab_detail.substance · includes samples with date_complete {{STAT:first_date}} – {{STAT:latest_date}}</a:t>
+              <a:t>Unique samples = n_distinct(sampleid) · substances from lab_detail.substance · includes samples with date_complete 26 Jan 2022 – 26 Aug 2026</a:t>
             </a:r>
           </a:p>
         </p:txBody>
@@ -3037,7 +3184,7 @@
                 <a:ea typeface="Helvetica Neue"/>
                 <a:sym typeface="Helvetica Neue"/>
               </a:rPr>
-              <a:t>County = samplecounty · left: ≥1 completed analysis ever · right: unique samples per county (sqrt color scale) · all time: {{STAT:first_date}} – {{STAT:latest_date}} · last 12 months: {{STAT:run_date_prior_year}} – {{STAT:latest_date}}* · coverage reflects participation, not prevalence</a:t>
+              <a:t>County = samplecounty · left: ≥1 completed analysis ever · right: unique samples per county (sqrt color scale) · all time: 26 Jan 2022 – 26 Aug 2026 · last 12 months: 26 Aug 2025 – 26 Aug 2026* · coverage reflects participation, not prevalence</a:t>
             </a:r>
           </a:p>
         </p:txBody>
@@ -3112,6 +3259,55 @@
                 <a:sym typeface="Helvetica Neue"/>
               </a:rPr>
               <a:t>What the Card Tells Us</a:t>
+            </a:r>
+          </a:p>
+        </p:txBody>
+      </p:sp>
+      <p:sp>
+        <p:nvSpPr>
+          <p:cNvPr id="3" name=""/>
+          <p:cNvSpPr>
+            <a:spLocks noGrp="1"/>
+          </p:cNvSpPr>
+          <p:nvPr>
+            <p:ph/>
+          </p:nvPr>
+        </p:nvSpPr>
+        <p:spPr>
+          <a:xfrm>
+            <a:off x="698500" y="1511300"/>
+            <a:ext cx="10795000" cy="4584700"/>
+          </a:xfrm>
+        </p:spPr>
+        <p:txBody>
+          <a:bodyPr/>
+          <a:lstStyle/>
+          <a:p>
+            <a:pPr algn="l" marL="0" marR="0">
+              <a:lnSpc>
+                <a:spcPct val="100000"/>
+              </a:lnSpc>
+              <a:spcBef>
+                <a:spcPts val="0"/>
+              </a:spcBef>
+              <a:spcAft>
+                <a:spcPts val="0"/>
+              </a:spcAft>
+              <a:buNone/>
+            </a:pPr>
+            <a:r>
+              <a:rPr cap="none" sz="1400" i="0" b="0" u="none" strike="noStrike">
+                <a:solidFill>
+                  <a:srgbClr val="5B6770">
+                    <a:alpha val="100000"/>
+                  </a:srgbClr>
+                </a:solidFill>
+                <a:latin typeface="Helvetica Neue"/>
+                <a:cs typeface="Helvetica Neue"/>
+                <a:ea typeface="Helvetica Neue"/>
+                <a:sym typeface="Helvetica Neue"/>
+              </a:rPr>
+              <a:t>Donor-reported context collected with every sample: what they expected, how it felt, how it looked, and whether an overdose was involved.</a:t>
             </a:r>
           </a:p>
         </p:txBody>
@@ -3309,7 +3505,7 @@
                 <a:ea typeface="Helvetica Neue"/>
                 <a:sym typeface="Helvetica Neue"/>
               </a:rPr>
-              <a:t>expectedsubstance (verbatim card write-in, semicolon lists split) · derived flags: expect_opioid, expect_fentanyl, expect_meth, expect_cocaine, expect_stimulant… · includes samples with date_complete {{STAT:first_date}} – {{STAT:latest_date}} · data table: Appendix A2</a:t>
+              <a:t>expectedsubstance (verbatim card write-in, semicolon lists split) · derived flags: expect_opioid, expect_fentanyl, expect_meth, expect_cocaine, expect_stimulant… · includes samples with date_complete 26 Jan 2022 – 26 Aug 2026 · data table: Appendix A2</a:t>
             </a:r>
           </a:p>
         </p:txBody>
@@ -3507,7 +3703,7 @@
                 <a:ea typeface="Helvetica Neue"/>
                 <a:sym typeface="Helvetica Neue"/>
               </a:rPr>
-              <a:t>Numerator uses lab_*_any (primary or trace) among samples with expect_* = 1 · includes samples with date_complete {{STAT:first_date}} – {{STAT:latest_date}} · data table: Appendix A3</a:t>
+              <a:t>Numerator uses lab_*_any (primary or trace) among samples with expect_* = 1 · includes samples with date_complete 26 Jan 2022 – 26 Aug 2026 · data table: Appendix A3</a:t>
             </a:r>
           </a:p>
         </p:txBody>
@@ -3705,7 +3901,7 @@
                 <a:ea typeface="Helvetica Neue"/>
                 <a:sym typeface="Helvetica Neue"/>
               </a:rPr>
-              <a:t>sensations (circled on card, semicolon lists split) · post-consumption samples only (consumed = 1) · includes samples with date_complete {{STAT:first_date}} – {{STAT:latest_date}}</a:t>
+              <a:t>sensations (circled on card, semicolon lists split) · post-consumption samples only (consumed = 1) · includes samples with date_complete 26 Jan 2022 – 26 Aug 2026</a:t>
             </a:r>
           </a:p>
         </p:txBody>
@@ -3929,7 +4125,7 @@
                 <a:ea typeface="Helvetica Neue"/>
                 <a:sym typeface="Helvetica Neue"/>
               </a:rPr>
-              <a:t>sensations semicolon lists parsed per report · consumed = 1 only · denominator: consumed samples with lab_*_any = 1 · includes samples with date_complete {{STAT:first_date}} – {{STAT:latest_date}}</a:t>
+              <a:t>sensations semicolon lists parsed per report · consumed = 1 only · denominator: consumed samples with lab_*_any = 1 · includes samples with date_complete 26 Jan 2022 – 26 Aug 2026</a:t>
             </a:r>
           </a:p>
         </p:txBody>
@@ -4127,7 +4323,7 @@
                 <a:ea typeface="Helvetica Neue"/>
                 <a:sym typeface="Helvetica Neue"/>
               </a:rPr>
-              <a:t>Samples with methamphetamine or cocaine detected (any abundance); samples in both classes appear on both slides · sensations semicolon lists parsed + sen_strength (own denominator) · consumed = 1 only · before: {{STAT:first_date}} – {{STAT:latest_date_prior_year}} · past 12 months: {{STAT:run_date_prior_year}} – {{STAT:latest_date}}* · Δ in percentage points</a:t>
+              <a:t>Samples with methamphetamine or cocaine detected (any abundance); samples in both classes appear on both slides · sensations semicolon lists parsed + sen_strength (own denominator) · consumed = 1 only · before: 26 Jan 2022 – 26 Aug 2025 · past 12 months: 26 Aug 2025 – 26 Aug 2026* · Δ in percentage points</a:t>
             </a:r>
           </a:p>
         </p:txBody>
@@ -4258,6 +4454,55 @@
       <p:sp>
         <p:nvSpPr>
           <p:cNvPr id="4" name=""/>
+          <p:cNvSpPr>
+            <a:spLocks noGrp="1"/>
+          </p:cNvSpPr>
+          <p:nvPr>
+            <p:ph/>
+          </p:nvPr>
+        </p:nvSpPr>
+        <p:spPr>
+          <a:xfrm>
+            <a:off x="698500" y="1511300"/>
+            <a:ext cx="10795000" cy="4584700"/>
+          </a:xfrm>
+        </p:spPr>
+        <p:txBody>
+          <a:bodyPr/>
+          <a:lstStyle/>
+          <a:p>
+            <a:pPr algn="l" marL="0" marR="0">
+              <a:lnSpc>
+                <a:spcPct val="100000"/>
+              </a:lnSpc>
+              <a:spcBef>
+                <a:spcPts val="0"/>
+              </a:spcBef>
+              <a:spcAft>
+                <a:spcPts val="0"/>
+              </a:spcAft>
+              <a:buNone/>
+            </a:pPr>
+            <a:r>
+              <a:rPr cap="none" sz="1400" i="0" b="0" u="none" strike="noStrike">
+                <a:solidFill>
+                  <a:srgbClr val="5B6770">
+                    <a:alpha val="100000"/>
+                  </a:srgbClr>
+                </a:solidFill>
+                <a:latin typeface="Helvetica Neue"/>
+                <a:cs typeface="Helvetica Neue"/>
+                <a:ea typeface="Helvetica Neue"/>
+                <a:sym typeface="Helvetica Neue"/>
+              </a:rPr>
+              <a:t>Rebuilt every night from the daily North Carolina extracts of the UNC drug checking datasets. Designed for public health officials and researchers — every figure names the exact variables behind it. Rates are per 1,000 unique samples completed per unit time; the month/current quarter is labeled partial. Charts state whether substance detections counts are in primary or trace abundance. All slides in this deck are made placed in public domain and available for public reuse without any additional permission. Nightly pipeline 1 Upstream CSVs refresh daily 2 Rscript r/build_nightly.R at 2:30 AM 3 ggplot2 figures + stats land in figs/ 4 This deck re-renders with fresh numbers Every figure and statistic is rebuilt from the live extract on each nightly run. r/build_nightly.R</a:t>
+            </a:r>
+          </a:p>
+        </p:txBody>
+      </p:sp>
+      <p:sp>
+        <p:nvSpPr>
+          <p:cNvPr id="5" name=""/>
           <p:cNvSpPr>
             <a:spLocks noGrp="1"/>
           </p:cNvSpPr>
@@ -4497,7 +4742,7 @@
                 <a:ea typeface="Helvetica Neue"/>
                 <a:sym typeface="Helvetica Neue"/>
               </a:rPr>
-              <a:t>Samples with an opioid (fentanyl, heroin) or benzodiazepine detected (any abundance); samples in both classes appear on both slides · sensations semicolon lists parsed + sen_strength (own denominator) · consumed = 1 only · before: {{STAT:first_date}} – {{STAT:latest_date_prior_year}} · past 12 months: {{STAT:run_date_prior_year}} – {{STAT:latest_date}}* · Δ in percentage points</a:t>
+              <a:t>Samples with an opioid (fentanyl, heroin) or benzodiazepine detected (any abundance); samples in both classes appear on both slides · sensations semicolon lists parsed + sen_strength (own denominator) · consumed = 1 only · before: 26 Jan 2022 – 26 Aug 2025 · past 12 months: 26 Aug 2025 – 26 Aug 2026* · Δ in percentage points</a:t>
             </a:r>
           </a:p>
         </p:txBody>
@@ -4893,7 +5138,7 @@
                 <a:ea typeface="Helvetica Neue"/>
                 <a:sym typeface="Helvetica Neue"/>
               </a:rPr>
-              <a:t>color, texture (card v3+, semicolon lists split) · derived: bright_color excludes white/tan/brown family — orange bar above · includes samples with date_complete {{STAT:first_date}} – {{STAT:latest_date}}</a:t>
+              <a:t>color, texture (card v3+, semicolon lists split) · derived: bright_color excludes white/tan/brown family — orange bar above · includes samples with date_complete 26 Jan 2022 – 26 Aug 2026</a:t>
             </a:r>
           </a:p>
         </p:txBody>
@@ -4968,6 +5213,55 @@
                 <a:sym typeface="Helvetica Neue"/>
               </a:rPr>
               <a:t>What the Lab Detects</a:t>
+            </a:r>
+          </a:p>
+        </p:txBody>
+      </p:sp>
+      <p:sp>
+        <p:nvSpPr>
+          <p:cNvPr id="3" name=""/>
+          <p:cNvSpPr>
+            <a:spLocks noGrp="1"/>
+          </p:cNvSpPr>
+          <p:nvPr>
+            <p:ph/>
+          </p:nvPr>
+        </p:nvSpPr>
+        <p:spPr>
+          <a:xfrm>
+            <a:off x="698500" y="1511300"/>
+            <a:ext cx="10795000" cy="4584700"/>
+          </a:xfrm>
+        </p:spPr>
+        <p:txBody>
+          <a:bodyPr/>
+          <a:lstStyle/>
+          <a:p>
+            <a:pPr algn="l" marL="0" marR="0">
+              <a:lnSpc>
+                <a:spcPct val="100000"/>
+              </a:lnSpc>
+              <a:spcBef>
+                <a:spcPts val="0"/>
+              </a:spcBef>
+              <a:spcAft>
+                <a:spcPts val="0"/>
+              </a:spcAft>
+              <a:buNone/>
+            </a:pPr>
+            <a:r>
+              <a:rPr cap="none" sz="1400" i="0" b="0" u="none" strike="noStrike">
+                <a:solidFill>
+                  <a:srgbClr val="5B6770">
+                    <a:alpha val="100000"/>
+                  </a:srgbClr>
+                </a:solidFill>
+                <a:latin typeface="Helvetica Neue"/>
+                <a:cs typeface="Helvetica Neue"/>
+                <a:ea typeface="Helvetica Neue"/>
+                <a:sym typeface="Helvetica Neue"/>
+              </a:rPr>
+              <a:t>GCMS results as quarterly rates per 1,000 samples — stacked primary (solid) + trace-only (light) for nine priority substances.</a:t>
             </a:r>
           </a:p>
         </p:txBody>
@@ -5165,7 +5459,7 @@
                 <a:ea typeface="Helvetica Neue"/>
                 <a:sym typeface="Helvetica Neue"/>
               </a:rPr>
-              <a:t>Distribution of substances detected per sample, both definitions shown side by side · includes samples with date_complete {{STAT:first_date}} – {{STAT:latest_date}}</a:t>
+              <a:t>Distribution of substances detected per sample, both definitions shown side by side · includes samples with date_complete 26 Jan 2022 – 26 Aug 2026</a:t>
             </a:r>
           </a:p>
         </p:txBody>
@@ -5363,7 +5657,7 @@
                 <a:ea typeface="Helvetica Neue"/>
                 <a:sym typeface="Helvetica Neue"/>
               </a:rPr>
-              <a:t>lab_detail.substance counts · solid = primary abundance, light = trace · standardized names (PubChem-linked) · includes samples with date_complete {{STAT:first_date}} – {{STAT:latest_date}}</a:t>
+              <a:t>lab_detail.substance counts · solid = primary abundance, light = trace · standardized names (PubChem-linked) · includes samples with date_complete 26 Jan 2022 – 26 Aug 2026</a:t>
             </a:r>
           </a:p>
         </p:txBody>
@@ -5561,7 +5855,7 @@
                 <a:ea typeface="Helvetica Neue"/>
                 <a:sym typeface="Helvetica Neue"/>
               </a:rPr>
-              <a:t>lab_detail.substance counts · solid = primary abundance, light = trace · standardized names (PubChem-linked) · window: date_complete {{STAT:run_date_prior_year}} – {{STAT:latest_date}}* (trailing 12 months, current month partial)</a:t>
+              <a:t>lab_detail.substance counts · solid = primary abundance, light = trace · standardized names (PubChem-linked) · window: date_complete 26 Aug 2025 – 26 Aug 2026* (trailing 12 months, current month partial)</a:t>
             </a:r>
           </a:p>
         </p:txBody>
@@ -5759,7 +6053,7 @@
                 <a:ea typeface="Helvetica Neue"/>
                 <a:sym typeface="Helvetica Neue"/>
               </a:rPr>
-              <a:t>Distribution of substances detected per sample, both definitions shown side by side · window: date_complete {{STAT:run_date_prior_year}} – {{STAT:latest_date}}* (trailing 12 months, current month partial)</a:t>
+              <a:t>Distribution of substances detected per sample, both definitions shown side by side · window: date_complete 26 Aug 2025 – 26 Aug 2026* (trailing 12 months, current month partial)</a:t>
             </a:r>
           </a:p>
         </p:txBody>
@@ -6234,6 +6528,55 @@
           </a:p>
         </p:txBody>
       </p:sp>
+      <p:sp>
+        <p:nvSpPr>
+          <p:cNvPr id="3" name=""/>
+          <p:cNvSpPr>
+            <a:spLocks noGrp="1"/>
+          </p:cNvSpPr>
+          <p:nvPr>
+            <p:ph/>
+          </p:nvPr>
+        </p:nvSpPr>
+        <p:spPr>
+          <a:xfrm>
+            <a:off x="698500" y="1511300"/>
+            <a:ext cx="10795000" cy="4584700"/>
+          </a:xfrm>
+        </p:spPr>
+        <p:txBody>
+          <a:bodyPr/>
+          <a:lstStyle/>
+          <a:p>
+            <a:pPr algn="l" marL="0" marR="0">
+              <a:lnSpc>
+                <a:spcPct val="100000"/>
+              </a:lnSpc>
+              <a:spcBef>
+                <a:spcPts val="0"/>
+              </a:spcBef>
+              <a:spcAft>
+                <a:spcPts val="0"/>
+              </a:spcAft>
+              <a:buNone/>
+            </a:pPr>
+            <a:r>
+              <a:rPr cap="none" sz="1400" i="0" b="0" u="none" strike="noStrike">
+                <a:solidFill>
+                  <a:srgbClr val="5B6770">
+                    <a:alpha val="100000"/>
+                  </a:srgbClr>
+                </a:solidFill>
+                <a:latin typeface="Helvetica Neue"/>
+                <a:cs typeface="Helvetica Neue"/>
+                <a:ea typeface="Helvetica Neue"/>
+                <a:sym typeface="Helvetica Neue"/>
+              </a:rPr>
+              <a:t>How samples are collected and shipped, how the lab analyzes them, and how results become the two public datasets — the ground rules behind every chart that follows.</a:t>
+            </a:r>
+          </a:p>
+        </p:txBody>
+      </p:sp>
     </p:spTree>
   </p:cSld>
   <p:clrMapOvr>
@@ -7953,1494 +8296,6 @@
         </p:nvSpPr>
         <p:spPr>
           <a:xfrm>
-            <a:off x="698500" y="1511300"/>
-            <a:ext cx="2603500" cy="190500"/>
-          </a:xfrm>
-        </p:spPr>
-        <p:txBody>
-          <a:bodyPr/>
-          <a:lstStyle/>
-          <a:p>
-            <a:pPr algn="l" marL="0" marR="0">
-              <a:lnSpc>
-                <a:spcPct val="100000"/>
-              </a:lnSpc>
-              <a:spcBef>
-                <a:spcPts val="0"/>
-              </a:spcBef>
-              <a:spcAft>
-                <a:spcPts val="0"/>
-              </a:spcAft>
-              <a:buNone/>
-            </a:pPr>
-            <a:r>
-              <a:rPr cap="none" sz="900" i="0" b="1" u="none" strike="noStrike">
-                <a:solidFill>
-                  <a:srgbClr val="667180">
-                    <a:alpha val="100000"/>
-                  </a:srgbClr>
-                </a:solidFill>
-                <a:latin typeface="Helvetica Neue"/>
-                <a:cs typeface="Helvetica Neue"/>
-                <a:ea typeface="Helvetica Neue"/>
-                <a:sym typeface="Helvetica Neue"/>
-              </a:rPr>
-              <a:t>SAMPLES COMPLETED</a:t>
-            </a:r>
-          </a:p>
-        </p:txBody>
-      </p:sp>
-      <p:sp>
-        <p:nvSpPr>
-          <p:cNvPr id="5" name=""/>
-          <p:cNvSpPr>
-            <a:spLocks noGrp="1"/>
-          </p:cNvSpPr>
-          <p:nvPr>
-            <p:ph/>
-          </p:nvPr>
-        </p:nvSpPr>
-        <p:spPr>
-          <a:xfrm>
-            <a:off x="698500" y="1701800"/>
-            <a:ext cx="2603500" cy="292100"/>
-          </a:xfrm>
-        </p:spPr>
-        <p:txBody>
-          <a:bodyPr/>
-          <a:lstStyle/>
-          <a:p>
-            <a:pPr algn="l" marL="0" marR="0">
-              <a:lnSpc>
-                <a:spcPct val="100000"/>
-              </a:lnSpc>
-              <a:spcBef>
-                <a:spcPts val="0"/>
-              </a:spcBef>
-              <a:spcAft>
-                <a:spcPts val="0"/>
-              </a:spcAft>
-              <a:buNone/>
-            </a:pPr>
-            <a:r>
-              <a:rPr cap="none" sz="1600" i="0" b="1" u="none" strike="noStrike">
-                <a:solidFill>
-                  <a:srgbClr val="13294B">
-                    <a:alpha val="100000"/>
-                  </a:srgbClr>
-                </a:solidFill>
-                <a:latin typeface="Helvetica Neue"/>
-                <a:cs typeface="Helvetica Neue"/>
-                <a:ea typeface="Helvetica Neue"/>
-                <a:sym typeface="Helvetica Neue"/>
-              </a:rPr>
-              <a:t>167 / month</a:t>
-            </a:r>
-          </a:p>
-        </p:txBody>
-      </p:sp>
-      <p:pic>
-        <p:nvPicPr>
-          <p:cNvPr id="6" name="" descr=""/>
-          <p:cNvPicPr>
-            <a:picLocks noGrp="1"/>
-          </p:cNvPicPr>
-          <p:nvPr>
-            <p:ph/>
-          </p:nvPr>
-        </p:nvPicPr>
-        <p:blipFill>
-          <a:blip r:embed="rId2"/>
-          <a:stretch>
-            <a:fillRect/>
-          </a:stretch>
-        </p:blipFill>
-        <p:spPr>
-          <a:xfrm>
-            <a:off x="698500" y="1993900"/>
-            <a:ext cx="2603500" cy="960967"/>
-          </a:xfrm>
-          <a:prstGeom prst="rect">
-            <a:avLst/>
-          </a:prstGeom>
-        </p:spPr>
-      </p:pic>
-      <p:sp>
-        <p:nvSpPr>
-          <p:cNvPr id="7" name=""/>
-          <p:cNvSpPr>
-            <a:spLocks noGrp="1"/>
-          </p:cNvSpPr>
-          <p:nvPr>
-            <p:ph/>
-          </p:nvPr>
-        </p:nvSpPr>
-        <p:spPr>
-          <a:xfrm>
-            <a:off x="3429000" y="1511300"/>
-            <a:ext cx="2603500" cy="190500"/>
-          </a:xfrm>
-        </p:spPr>
-        <p:txBody>
-          <a:bodyPr/>
-          <a:lstStyle/>
-          <a:p>
-            <a:pPr algn="l" marL="0" marR="0">
-              <a:lnSpc>
-                <a:spcPct val="100000"/>
-              </a:lnSpc>
-              <a:spcBef>
-                <a:spcPts val="0"/>
-              </a:spcBef>
-              <a:spcAft>
-                <a:spcPts val="0"/>
-              </a:spcAft>
-              <a:buNone/>
-            </a:pPr>
-            <a:r>
-              <a:rPr cap="none" sz="900" i="0" b="1" u="none" strike="noStrike">
-                <a:solidFill>
-                  <a:srgbClr val="667180">
-                    <a:alpha val="100000"/>
-                  </a:srgbClr>
-                </a:solidFill>
-                <a:latin typeface="Helvetica Neue"/>
-                <a:cs typeface="Helvetica Neue"/>
-                <a:ea typeface="Helvetica Neue"/>
-                <a:sym typeface="Helvetica Neue"/>
-              </a:rPr>
-              <a:t>FENTANYL (ANY)</a:t>
-            </a:r>
-          </a:p>
-        </p:txBody>
-      </p:sp>
-      <p:sp>
-        <p:nvSpPr>
-          <p:cNvPr id="8" name=""/>
-          <p:cNvSpPr>
-            <a:spLocks noGrp="1"/>
-          </p:cNvSpPr>
-          <p:nvPr>
-            <p:ph/>
-          </p:nvPr>
-        </p:nvSpPr>
-        <p:spPr>
-          <a:xfrm>
-            <a:off x="3429000" y="1701800"/>
-            <a:ext cx="2603500" cy="292100"/>
-          </a:xfrm>
-        </p:spPr>
-        <p:txBody>
-          <a:bodyPr/>
-          <a:lstStyle/>
-          <a:p>
-            <a:pPr algn="l" marL="0" marR="0">
-              <a:lnSpc>
-                <a:spcPct val="100000"/>
-              </a:lnSpc>
-              <a:spcBef>
-                <a:spcPts val="0"/>
-              </a:spcBef>
-              <a:spcAft>
-                <a:spcPts val="0"/>
-              </a:spcAft>
-              <a:buNone/>
-            </a:pPr>
-            <a:r>
-              <a:rPr cap="none" sz="1600" i="0" b="1" u="none" strike="noStrike">
-                <a:solidFill>
-                  <a:srgbClr val="13294B">
-                    <a:alpha val="100000"/>
-                  </a:srgbClr>
-                </a:solidFill>
-                <a:latin typeface="Helvetica Neue"/>
-                <a:cs typeface="Helvetica Neue"/>
-                <a:ea typeface="Helvetica Neue"/>
-                <a:sym typeface="Helvetica Neue"/>
-              </a:rPr>
-              <a:t>665 per 1,000</a:t>
-            </a:r>
-          </a:p>
-        </p:txBody>
-      </p:sp>
-      <p:pic>
-        <p:nvPicPr>
-          <p:cNvPr id="9" name="" descr=""/>
-          <p:cNvPicPr>
-            <a:picLocks noGrp="1"/>
-          </p:cNvPicPr>
-          <p:nvPr>
-            <p:ph/>
-          </p:nvPr>
-        </p:nvPicPr>
-        <p:blipFill>
-          <a:blip r:embed="rId3"/>
-          <a:stretch>
-            <a:fillRect/>
-          </a:stretch>
-        </p:blipFill>
-        <p:spPr>
-          <a:xfrm>
-            <a:off x="3429000" y="1993900"/>
-            <a:ext cx="2603500" cy="960967"/>
-          </a:xfrm>
-          <a:prstGeom prst="rect">
-            <a:avLst/>
-          </a:prstGeom>
-        </p:spPr>
-      </p:pic>
-      <p:sp>
-        <p:nvSpPr>
-          <p:cNvPr id="10" name=""/>
-          <p:cNvSpPr>
-            <a:spLocks noGrp="1"/>
-          </p:cNvSpPr>
-          <p:nvPr>
-            <p:ph/>
-          </p:nvPr>
-        </p:nvSpPr>
-        <p:spPr>
-          <a:xfrm>
-            <a:off x="6159500" y="1511300"/>
-            <a:ext cx="2603500" cy="190500"/>
-          </a:xfrm>
-        </p:spPr>
-        <p:txBody>
-          <a:bodyPr/>
-          <a:lstStyle/>
-          <a:p>
-            <a:pPr algn="l" marL="0" marR="0">
-              <a:lnSpc>
-                <a:spcPct val="100000"/>
-              </a:lnSpc>
-              <a:spcBef>
-                <a:spcPts val="0"/>
-              </a:spcBef>
-              <a:spcAft>
-                <a:spcPts val="0"/>
-              </a:spcAft>
-              <a:buNone/>
-            </a:pPr>
-            <a:r>
-              <a:rPr cap="none" sz="900" i="0" b="1" u="none" strike="noStrike">
-                <a:solidFill>
-                  <a:srgbClr val="667180">
-                    <a:alpha val="100000"/>
-                  </a:srgbClr>
-                </a:solidFill>
-                <a:latin typeface="Helvetica Neue"/>
-                <a:cs typeface="Helvetica Neue"/>
-                <a:ea typeface="Helvetica Neue"/>
-                <a:sym typeface="Helvetica Neue"/>
-              </a:rPr>
-              <a:t>FENTANYL IMPURITIES (ANY)</a:t>
-            </a:r>
-          </a:p>
-        </p:txBody>
-      </p:sp>
-      <p:sp>
-        <p:nvSpPr>
-          <p:cNvPr id="11" name=""/>
-          <p:cNvSpPr>
-            <a:spLocks noGrp="1"/>
-          </p:cNvSpPr>
-          <p:nvPr>
-            <p:ph/>
-          </p:nvPr>
-        </p:nvSpPr>
-        <p:spPr>
-          <a:xfrm>
-            <a:off x="6159500" y="1701800"/>
-            <a:ext cx="2603500" cy="292100"/>
-          </a:xfrm>
-        </p:spPr>
-        <p:txBody>
-          <a:bodyPr/>
-          <a:lstStyle/>
-          <a:p>
-            <a:pPr algn="l" marL="0" marR="0">
-              <a:lnSpc>
-                <a:spcPct val="100000"/>
-              </a:lnSpc>
-              <a:spcBef>
-                <a:spcPts val="0"/>
-              </a:spcBef>
-              <a:spcAft>
-                <a:spcPts val="0"/>
-              </a:spcAft>
-              <a:buNone/>
-            </a:pPr>
-            <a:r>
-              <a:rPr cap="none" sz="1600" i="0" b="1" u="none" strike="noStrike">
-                <a:solidFill>
-                  <a:srgbClr val="13294B">
-                    <a:alpha val="100000"/>
-                  </a:srgbClr>
-                </a:solidFill>
-                <a:latin typeface="Helvetica Neue"/>
-                <a:cs typeface="Helvetica Neue"/>
-                <a:ea typeface="Helvetica Neue"/>
-                <a:sym typeface="Helvetica Neue"/>
-              </a:rPr>
-              <a:t>605 per 1,000</a:t>
-            </a:r>
-          </a:p>
-        </p:txBody>
-      </p:sp>
-      <p:pic>
-        <p:nvPicPr>
-          <p:cNvPr id="12" name="" descr=""/>
-          <p:cNvPicPr>
-            <a:picLocks noGrp="1"/>
-          </p:cNvPicPr>
-          <p:nvPr>
-            <p:ph/>
-          </p:nvPr>
-        </p:nvPicPr>
-        <p:blipFill>
-          <a:blip r:embed="rId4"/>
-          <a:stretch>
-            <a:fillRect/>
-          </a:stretch>
-        </p:blipFill>
-        <p:spPr>
-          <a:xfrm>
-            <a:off x="6159500" y="1993900"/>
-            <a:ext cx="2603500" cy="960967"/>
-          </a:xfrm>
-          <a:prstGeom prst="rect">
-            <a:avLst/>
-          </a:prstGeom>
-        </p:spPr>
-      </p:pic>
-      <p:sp>
-        <p:nvSpPr>
-          <p:cNvPr id="13" name=""/>
-          <p:cNvSpPr>
-            <a:spLocks noGrp="1"/>
-          </p:cNvSpPr>
-          <p:nvPr>
-            <p:ph/>
-          </p:nvPr>
-        </p:nvSpPr>
-        <p:spPr>
-          <a:xfrm>
-            <a:off x="8890000" y="1511300"/>
-            <a:ext cx="2603500" cy="190500"/>
-          </a:xfrm>
-        </p:spPr>
-        <p:txBody>
-          <a:bodyPr/>
-          <a:lstStyle/>
-          <a:p>
-            <a:pPr algn="l" marL="0" marR="0">
-              <a:lnSpc>
-                <a:spcPct val="100000"/>
-              </a:lnSpc>
-              <a:spcBef>
-                <a:spcPts val="0"/>
-              </a:spcBef>
-              <a:spcAft>
-                <a:spcPts val="0"/>
-              </a:spcAft>
-              <a:buNone/>
-            </a:pPr>
-            <a:r>
-              <a:rPr cap="none" sz="900" i="0" b="1" u="none" strike="noStrike">
-                <a:solidFill>
-                  <a:srgbClr val="667180">
-                    <a:alpha val="100000"/>
-                  </a:srgbClr>
-                </a:solidFill>
-                <a:latin typeface="Helvetica Neue"/>
-                <a:cs typeface="Helvetica Neue"/>
-                <a:ea typeface="Helvetica Neue"/>
-                <a:sym typeface="Helvetica Neue"/>
-              </a:rPr>
-              <a:t>XYLAZINE (ANY)</a:t>
-            </a:r>
-          </a:p>
-        </p:txBody>
-      </p:sp>
-      <p:sp>
-        <p:nvSpPr>
-          <p:cNvPr id="14" name=""/>
-          <p:cNvSpPr>
-            <a:spLocks noGrp="1"/>
-          </p:cNvSpPr>
-          <p:nvPr>
-            <p:ph/>
-          </p:nvPr>
-        </p:nvSpPr>
-        <p:spPr>
-          <a:xfrm>
-            <a:off x="8890000" y="1701800"/>
-            <a:ext cx="2603500" cy="292100"/>
-          </a:xfrm>
-        </p:spPr>
-        <p:txBody>
-          <a:bodyPr/>
-          <a:lstStyle/>
-          <a:p>
-            <a:pPr algn="l" marL="0" marR="0">
-              <a:lnSpc>
-                <a:spcPct val="100000"/>
-              </a:lnSpc>
-              <a:spcBef>
-                <a:spcPts val="0"/>
-              </a:spcBef>
-              <a:spcAft>
-                <a:spcPts val="0"/>
-              </a:spcAft>
-              <a:buNone/>
-            </a:pPr>
-            <a:r>
-              <a:rPr cap="none" sz="1600" i="0" b="1" u="none" strike="noStrike">
-                <a:solidFill>
-                  <a:srgbClr val="13294B">
-                    <a:alpha val="100000"/>
-                  </a:srgbClr>
-                </a:solidFill>
-                <a:latin typeface="Helvetica Neue"/>
-                <a:cs typeface="Helvetica Neue"/>
-                <a:ea typeface="Helvetica Neue"/>
-                <a:sym typeface="Helvetica Neue"/>
-              </a:rPr>
-              <a:t>60 per 1,000</a:t>
-            </a:r>
-          </a:p>
-        </p:txBody>
-      </p:sp>
-      <p:pic>
-        <p:nvPicPr>
-          <p:cNvPr id="15" name="" descr=""/>
-          <p:cNvPicPr>
-            <a:picLocks noGrp="1"/>
-          </p:cNvPicPr>
-          <p:nvPr>
-            <p:ph/>
-          </p:nvPr>
-        </p:nvPicPr>
-        <p:blipFill>
-          <a:blip r:embed="rId5"/>
-          <a:stretch>
-            <a:fillRect/>
-          </a:stretch>
-        </p:blipFill>
-        <p:spPr>
-          <a:xfrm>
-            <a:off x="8890000" y="1993900"/>
-            <a:ext cx="2603500" cy="960967"/>
-          </a:xfrm>
-          <a:prstGeom prst="rect">
-            <a:avLst/>
-          </a:prstGeom>
-        </p:spPr>
-      </p:pic>
-      <p:sp>
-        <p:nvSpPr>
-          <p:cNvPr id="16" name=""/>
-          <p:cNvSpPr>
-            <a:spLocks noGrp="1"/>
-          </p:cNvSpPr>
-          <p:nvPr>
-            <p:ph/>
-          </p:nvPr>
-        </p:nvSpPr>
-        <p:spPr>
-          <a:xfrm>
-            <a:off x="698500" y="3081867"/>
-            <a:ext cx="2603500" cy="190500"/>
-          </a:xfrm>
-        </p:spPr>
-        <p:txBody>
-          <a:bodyPr/>
-          <a:lstStyle/>
-          <a:p>
-            <a:pPr algn="l" marL="0" marR="0">
-              <a:lnSpc>
-                <a:spcPct val="100000"/>
-              </a:lnSpc>
-              <a:spcBef>
-                <a:spcPts val="0"/>
-              </a:spcBef>
-              <a:spcAft>
-                <a:spcPts val="0"/>
-              </a:spcAft>
-              <a:buNone/>
-            </a:pPr>
-            <a:r>
-              <a:rPr cap="none" sz="900" i="0" b="1" u="none" strike="noStrike">
-                <a:solidFill>
-                  <a:srgbClr val="667180">
-                    <a:alpha val="100000"/>
-                  </a:srgbClr>
-                </a:solidFill>
-                <a:latin typeface="Helvetica Neue"/>
-                <a:cs typeface="Helvetica Neue"/>
-                <a:ea typeface="Helvetica Neue"/>
-                <a:sym typeface="Helvetica Neue"/>
-              </a:rPr>
-              <a:t>MEDETOMIDINE (ANY)</a:t>
-            </a:r>
-          </a:p>
-        </p:txBody>
-      </p:sp>
-      <p:sp>
-        <p:nvSpPr>
-          <p:cNvPr id="17" name=""/>
-          <p:cNvSpPr>
-            <a:spLocks noGrp="1"/>
-          </p:cNvSpPr>
-          <p:nvPr>
-            <p:ph/>
-          </p:nvPr>
-        </p:nvSpPr>
-        <p:spPr>
-          <a:xfrm>
-            <a:off x="698500" y="3272367"/>
-            <a:ext cx="2603500" cy="292100"/>
-          </a:xfrm>
-        </p:spPr>
-        <p:txBody>
-          <a:bodyPr/>
-          <a:lstStyle/>
-          <a:p>
-            <a:pPr algn="l" marL="0" marR="0">
-              <a:lnSpc>
-                <a:spcPct val="100000"/>
-              </a:lnSpc>
-              <a:spcBef>
-                <a:spcPts val="0"/>
-              </a:spcBef>
-              <a:spcAft>
-                <a:spcPts val="0"/>
-              </a:spcAft>
-              <a:buNone/>
-            </a:pPr>
-            <a:r>
-              <a:rPr cap="none" sz="1600" i="0" b="1" u="none" strike="noStrike">
-                <a:solidFill>
-                  <a:srgbClr val="13294B">
-                    <a:alpha val="100000"/>
-                  </a:srgbClr>
-                </a:solidFill>
-                <a:latin typeface="Helvetica Neue"/>
-                <a:cs typeface="Helvetica Neue"/>
-                <a:ea typeface="Helvetica Neue"/>
-                <a:sym typeface="Helvetica Neue"/>
-              </a:rPr>
-              <a:t>90 per 1,000</a:t>
-            </a:r>
-          </a:p>
-        </p:txBody>
-      </p:sp>
-      <p:pic>
-        <p:nvPicPr>
-          <p:cNvPr id="18" name="" descr=""/>
-          <p:cNvPicPr>
-            <a:picLocks noGrp="1"/>
-          </p:cNvPicPr>
-          <p:nvPr>
-            <p:ph/>
-          </p:nvPr>
-        </p:nvPicPr>
-        <p:blipFill>
-          <a:blip r:embed="rId6"/>
-          <a:stretch>
-            <a:fillRect/>
-          </a:stretch>
-        </p:blipFill>
-        <p:spPr>
-          <a:xfrm>
-            <a:off x="698500" y="3564467"/>
-            <a:ext cx="2603500" cy="960967"/>
-          </a:xfrm>
-          <a:prstGeom prst="rect">
-            <a:avLst/>
-          </a:prstGeom>
-        </p:spPr>
-      </p:pic>
-      <p:sp>
-        <p:nvSpPr>
-          <p:cNvPr id="19" name=""/>
-          <p:cNvSpPr>
-            <a:spLocks noGrp="1"/>
-          </p:cNvSpPr>
-          <p:nvPr>
-            <p:ph/>
-          </p:nvPr>
-        </p:nvSpPr>
-        <p:spPr>
-          <a:xfrm>
-            <a:off x="3429000" y="3081867"/>
-            <a:ext cx="2603500" cy="190500"/>
-          </a:xfrm>
-        </p:spPr>
-        <p:txBody>
-          <a:bodyPr/>
-          <a:lstStyle/>
-          <a:p>
-            <a:pPr algn="l" marL="0" marR="0">
-              <a:lnSpc>
-                <a:spcPct val="100000"/>
-              </a:lnSpc>
-              <a:spcBef>
-                <a:spcPts val="0"/>
-              </a:spcBef>
-              <a:spcAft>
-                <a:spcPts val="0"/>
-              </a:spcAft>
-              <a:buNone/>
-            </a:pPr>
-            <a:r>
-              <a:rPr cap="none" sz="900" i="0" b="1" u="none" strike="noStrike">
-                <a:solidFill>
-                  <a:srgbClr val="667180">
-                    <a:alpha val="100000"/>
-                  </a:srgbClr>
-                </a:solidFill>
-                <a:latin typeface="Helvetica Neue"/>
-                <a:cs typeface="Helvetica Neue"/>
-                <a:ea typeface="Helvetica Neue"/>
-                <a:sym typeface="Helvetica Neue"/>
-              </a:rPr>
-              <a:t>METHAMPHETAMINE (ANY)</a:t>
-            </a:r>
-          </a:p>
-        </p:txBody>
-      </p:sp>
-      <p:sp>
-        <p:nvSpPr>
-          <p:cNvPr id="20" name=""/>
-          <p:cNvSpPr>
-            <a:spLocks noGrp="1"/>
-          </p:cNvSpPr>
-          <p:nvPr>
-            <p:ph/>
-          </p:nvPr>
-        </p:nvSpPr>
-        <p:spPr>
-          <a:xfrm>
-            <a:off x="3429000" y="3272367"/>
-            <a:ext cx="2603500" cy="292100"/>
-          </a:xfrm>
-        </p:spPr>
-        <p:txBody>
-          <a:bodyPr/>
-          <a:lstStyle/>
-          <a:p>
-            <a:pPr algn="l" marL="0" marR="0">
-              <a:lnSpc>
-                <a:spcPct val="100000"/>
-              </a:lnSpc>
-              <a:spcBef>
-                <a:spcPts val="0"/>
-              </a:spcBef>
-              <a:spcAft>
-                <a:spcPts val="0"/>
-              </a:spcAft>
-              <a:buNone/>
-            </a:pPr>
-            <a:r>
-              <a:rPr cap="none" sz="1600" i="0" b="1" u="none" strike="noStrike">
-                <a:solidFill>
-                  <a:srgbClr val="13294B">
-                    <a:alpha val="100000"/>
-                  </a:srgbClr>
-                </a:solidFill>
-                <a:latin typeface="Helvetica Neue"/>
-                <a:cs typeface="Helvetica Neue"/>
-                <a:ea typeface="Helvetica Neue"/>
-                <a:sym typeface="Helvetica Neue"/>
-              </a:rPr>
-              <a:t>287 per 1,000</a:t>
-            </a:r>
-          </a:p>
-        </p:txBody>
-      </p:sp>
-      <p:pic>
-        <p:nvPicPr>
-          <p:cNvPr id="21" name="" descr=""/>
-          <p:cNvPicPr>
-            <a:picLocks noGrp="1"/>
-          </p:cNvPicPr>
-          <p:nvPr>
-            <p:ph/>
-          </p:nvPr>
-        </p:nvPicPr>
-        <p:blipFill>
-          <a:blip r:embed="rId7"/>
-          <a:stretch>
-            <a:fillRect/>
-          </a:stretch>
-        </p:blipFill>
-        <p:spPr>
-          <a:xfrm>
-            <a:off x="3429000" y="3564467"/>
-            <a:ext cx="2603500" cy="960967"/>
-          </a:xfrm>
-          <a:prstGeom prst="rect">
-            <a:avLst/>
-          </a:prstGeom>
-        </p:spPr>
-      </p:pic>
-      <p:sp>
-        <p:nvSpPr>
-          <p:cNvPr id="22" name=""/>
-          <p:cNvSpPr>
-            <a:spLocks noGrp="1"/>
-          </p:cNvSpPr>
-          <p:nvPr>
-            <p:ph/>
-          </p:nvPr>
-        </p:nvSpPr>
-        <p:spPr>
-          <a:xfrm>
-            <a:off x="6159500" y="3081867"/>
-            <a:ext cx="2603500" cy="190500"/>
-          </a:xfrm>
-        </p:spPr>
-        <p:txBody>
-          <a:bodyPr/>
-          <a:lstStyle/>
-          <a:p>
-            <a:pPr algn="l" marL="0" marR="0">
-              <a:lnSpc>
-                <a:spcPct val="100000"/>
-              </a:lnSpc>
-              <a:spcBef>
-                <a:spcPts val="0"/>
-              </a:spcBef>
-              <a:spcAft>
-                <a:spcPts val="0"/>
-              </a:spcAft>
-              <a:buNone/>
-            </a:pPr>
-            <a:r>
-              <a:rPr cap="none" sz="900" i="0" b="1" u="none" strike="noStrike">
-                <a:solidFill>
-                  <a:srgbClr val="667180">
-                    <a:alpha val="100000"/>
-                  </a:srgbClr>
-                </a:solidFill>
-                <a:latin typeface="Helvetica Neue"/>
-                <a:cs typeface="Helvetica Neue"/>
-                <a:ea typeface="Helvetica Neue"/>
-                <a:sym typeface="Helvetica Neue"/>
-              </a:rPr>
-              <a:t>COCAINE (ANY)</a:t>
-            </a:r>
-          </a:p>
-        </p:txBody>
-      </p:sp>
-      <p:sp>
-        <p:nvSpPr>
-          <p:cNvPr id="23" name=""/>
-          <p:cNvSpPr>
-            <a:spLocks noGrp="1"/>
-          </p:cNvSpPr>
-          <p:nvPr>
-            <p:ph/>
-          </p:nvPr>
-        </p:nvSpPr>
-        <p:spPr>
-          <a:xfrm>
-            <a:off x="6159500" y="3272367"/>
-            <a:ext cx="2603500" cy="292100"/>
-          </a:xfrm>
-        </p:spPr>
-        <p:txBody>
-          <a:bodyPr/>
-          <a:lstStyle/>
-          <a:p>
-            <a:pPr algn="l" marL="0" marR="0">
-              <a:lnSpc>
-                <a:spcPct val="100000"/>
-              </a:lnSpc>
-              <a:spcBef>
-                <a:spcPts val="0"/>
-              </a:spcBef>
-              <a:spcAft>
-                <a:spcPts val="0"/>
-              </a:spcAft>
-              <a:buNone/>
-            </a:pPr>
-            <a:r>
-              <a:rPr cap="none" sz="1600" i="0" b="1" u="none" strike="noStrike">
-                <a:solidFill>
-                  <a:srgbClr val="13294B">
-                    <a:alpha val="100000"/>
-                  </a:srgbClr>
-                </a:solidFill>
-                <a:latin typeface="Helvetica Neue"/>
-                <a:cs typeface="Helvetica Neue"/>
-                <a:ea typeface="Helvetica Neue"/>
-                <a:sym typeface="Helvetica Neue"/>
-              </a:rPr>
-              <a:t>102 per 1,000</a:t>
-            </a:r>
-          </a:p>
-        </p:txBody>
-      </p:sp>
-      <p:pic>
-        <p:nvPicPr>
-          <p:cNvPr id="24" name="" descr=""/>
-          <p:cNvPicPr>
-            <a:picLocks noGrp="1"/>
-          </p:cNvPicPr>
-          <p:nvPr>
-            <p:ph/>
-          </p:nvPr>
-        </p:nvPicPr>
-        <p:blipFill>
-          <a:blip r:embed="rId8"/>
-          <a:stretch>
-            <a:fillRect/>
-          </a:stretch>
-        </p:blipFill>
-        <p:spPr>
-          <a:xfrm>
-            <a:off x="6159500" y="3564467"/>
-            <a:ext cx="2603500" cy="960967"/>
-          </a:xfrm>
-          <a:prstGeom prst="rect">
-            <a:avLst/>
-          </a:prstGeom>
-        </p:spPr>
-      </p:pic>
-      <p:sp>
-        <p:nvSpPr>
-          <p:cNvPr id="25" name=""/>
-          <p:cNvSpPr>
-            <a:spLocks noGrp="1"/>
-          </p:cNvSpPr>
-          <p:nvPr>
-            <p:ph/>
-          </p:nvPr>
-        </p:nvSpPr>
-        <p:spPr>
-          <a:xfrm>
-            <a:off x="8890000" y="3081867"/>
-            <a:ext cx="2603500" cy="190500"/>
-          </a:xfrm>
-        </p:spPr>
-        <p:txBody>
-          <a:bodyPr/>
-          <a:lstStyle/>
-          <a:p>
-            <a:pPr algn="l" marL="0" marR="0">
-              <a:lnSpc>
-                <a:spcPct val="100000"/>
-              </a:lnSpc>
-              <a:spcBef>
-                <a:spcPts val="0"/>
-              </a:spcBef>
-              <a:spcAft>
-                <a:spcPts val="0"/>
-              </a:spcAft>
-              <a:buNone/>
-            </a:pPr>
-            <a:r>
-              <a:rPr cap="none" sz="900" i="0" b="1" u="none" strike="noStrike">
-                <a:solidFill>
-                  <a:srgbClr val="667180">
-                    <a:alpha val="100000"/>
-                  </a:srgbClr>
-                </a:solidFill>
-                <a:latin typeface="Helvetica Neue"/>
-                <a:cs typeface="Helvetica Neue"/>
-                <a:ea typeface="Helvetica Neue"/>
-                <a:sym typeface="Helvetica Neue"/>
-              </a:rPr>
-              <a:t>LEVAMISOLE (ANY)</a:t>
-            </a:r>
-          </a:p>
-        </p:txBody>
-      </p:sp>
-      <p:sp>
-        <p:nvSpPr>
-          <p:cNvPr id="26" name=""/>
-          <p:cNvSpPr>
-            <a:spLocks noGrp="1"/>
-          </p:cNvSpPr>
-          <p:nvPr>
-            <p:ph/>
-          </p:nvPr>
-        </p:nvSpPr>
-        <p:spPr>
-          <a:xfrm>
-            <a:off x="8890000" y="3272367"/>
-            <a:ext cx="2603500" cy="292100"/>
-          </a:xfrm>
-        </p:spPr>
-        <p:txBody>
-          <a:bodyPr/>
-          <a:lstStyle/>
-          <a:p>
-            <a:pPr algn="l" marL="0" marR="0">
-              <a:lnSpc>
-                <a:spcPct val="100000"/>
-              </a:lnSpc>
-              <a:spcBef>
-                <a:spcPts val="0"/>
-              </a:spcBef>
-              <a:spcAft>
-                <a:spcPts val="0"/>
-              </a:spcAft>
-              <a:buNone/>
-            </a:pPr>
-            <a:r>
-              <a:rPr cap="none" sz="1600" i="0" b="1" u="none" strike="noStrike">
-                <a:solidFill>
-                  <a:srgbClr val="13294B">
-                    <a:alpha val="100000"/>
-                  </a:srgbClr>
-                </a:solidFill>
-                <a:latin typeface="Helvetica Neue"/>
-                <a:cs typeface="Helvetica Neue"/>
-                <a:ea typeface="Helvetica Neue"/>
-                <a:sym typeface="Helvetica Neue"/>
-              </a:rPr>
-              <a:t>0 per 1,000</a:t>
-            </a:r>
-          </a:p>
-        </p:txBody>
-      </p:sp>
-      <p:pic>
-        <p:nvPicPr>
-          <p:cNvPr id="27" name="" descr=""/>
-          <p:cNvPicPr>
-            <a:picLocks noGrp="1"/>
-          </p:cNvPicPr>
-          <p:nvPr>
-            <p:ph/>
-          </p:nvPr>
-        </p:nvPicPr>
-        <p:blipFill>
-          <a:blip r:embed="rId9"/>
-          <a:stretch>
-            <a:fillRect/>
-          </a:stretch>
-        </p:blipFill>
-        <p:spPr>
-          <a:xfrm>
-            <a:off x="8890000" y="3564467"/>
-            <a:ext cx="2603500" cy="960967"/>
-          </a:xfrm>
-          <a:prstGeom prst="rect">
-            <a:avLst/>
-          </a:prstGeom>
-        </p:spPr>
-      </p:pic>
-      <p:sp>
-        <p:nvSpPr>
-          <p:cNvPr id="28" name=""/>
-          <p:cNvSpPr>
-            <a:spLocks noGrp="1"/>
-          </p:cNvSpPr>
-          <p:nvPr>
-            <p:ph/>
-          </p:nvPr>
-        </p:nvSpPr>
-        <p:spPr>
-          <a:xfrm>
-            <a:off x="698500" y="4652433"/>
-            <a:ext cx="2603500" cy="190500"/>
-          </a:xfrm>
-        </p:spPr>
-        <p:txBody>
-          <a:bodyPr/>
-          <a:lstStyle/>
-          <a:p>
-            <a:pPr algn="l" marL="0" marR="0">
-              <a:lnSpc>
-                <a:spcPct val="100000"/>
-              </a:lnSpc>
-              <a:spcBef>
-                <a:spcPts val="0"/>
-              </a:spcBef>
-              <a:spcAft>
-                <a:spcPts val="0"/>
-              </a:spcAft>
-              <a:buNone/>
-            </a:pPr>
-            <a:r>
-              <a:rPr cap="none" sz="900" i="0" b="1" u="none" strike="noStrike">
-                <a:solidFill>
-                  <a:srgbClr val="667180">
-                    <a:alpha val="100000"/>
-                  </a:srgbClr>
-                </a:solidFill>
-                <a:latin typeface="Helvetica Neue"/>
-                <a:cs typeface="Helvetica Neue"/>
-                <a:ea typeface="Helvetica Neue"/>
-                <a:sym typeface="Helvetica Neue"/>
-              </a:rPr>
-              <a:t>CARFENTANIL (ANY)</a:t>
-            </a:r>
-          </a:p>
-        </p:txBody>
-      </p:sp>
-      <p:sp>
-        <p:nvSpPr>
-          <p:cNvPr id="29" name=""/>
-          <p:cNvSpPr>
-            <a:spLocks noGrp="1"/>
-          </p:cNvSpPr>
-          <p:nvPr>
-            <p:ph/>
-          </p:nvPr>
-        </p:nvSpPr>
-        <p:spPr>
-          <a:xfrm>
-            <a:off x="698500" y="4842933"/>
-            <a:ext cx="2603500" cy="292100"/>
-          </a:xfrm>
-        </p:spPr>
-        <p:txBody>
-          <a:bodyPr/>
-          <a:lstStyle/>
-          <a:p>
-            <a:pPr algn="l" marL="0" marR="0">
-              <a:lnSpc>
-                <a:spcPct val="100000"/>
-              </a:lnSpc>
-              <a:spcBef>
-                <a:spcPts val="0"/>
-              </a:spcBef>
-              <a:spcAft>
-                <a:spcPts val="0"/>
-              </a:spcAft>
-              <a:buNone/>
-            </a:pPr>
-            <a:r>
-              <a:rPr cap="none" sz="1600" i="0" b="1" u="none" strike="noStrike">
-                <a:solidFill>
-                  <a:srgbClr val="13294B">
-                    <a:alpha val="100000"/>
-                  </a:srgbClr>
-                </a:solidFill>
-                <a:latin typeface="Helvetica Neue"/>
-                <a:cs typeface="Helvetica Neue"/>
-                <a:ea typeface="Helvetica Neue"/>
-                <a:sym typeface="Helvetica Neue"/>
-              </a:rPr>
-              <a:t>0 per 1,000</a:t>
-            </a:r>
-          </a:p>
-        </p:txBody>
-      </p:sp>
-      <p:pic>
-        <p:nvPicPr>
-          <p:cNvPr id="30" name="" descr=""/>
-          <p:cNvPicPr>
-            <a:picLocks noGrp="1"/>
-          </p:cNvPicPr>
-          <p:nvPr>
-            <p:ph/>
-          </p:nvPr>
-        </p:nvPicPr>
-        <p:blipFill>
-          <a:blip r:embed="rId10"/>
-          <a:stretch>
-            <a:fillRect/>
-          </a:stretch>
-        </p:blipFill>
-        <p:spPr>
-          <a:xfrm>
-            <a:off x="698500" y="5135033"/>
-            <a:ext cx="2603500" cy="960967"/>
-          </a:xfrm>
-          <a:prstGeom prst="rect">
-            <a:avLst/>
-          </a:prstGeom>
-        </p:spPr>
-      </p:pic>
-      <p:sp>
-        <p:nvSpPr>
-          <p:cNvPr id="31" name=""/>
-          <p:cNvSpPr>
-            <a:spLocks noGrp="1"/>
-          </p:cNvSpPr>
-          <p:nvPr>
-            <p:ph/>
-          </p:nvPr>
-        </p:nvSpPr>
-        <p:spPr>
-          <a:xfrm>
-            <a:off x="3429000" y="4652433"/>
-            <a:ext cx="2603500" cy="190500"/>
-          </a:xfrm>
-        </p:spPr>
-        <p:txBody>
-          <a:bodyPr/>
-          <a:lstStyle/>
-          <a:p>
-            <a:pPr algn="l" marL="0" marR="0">
-              <a:lnSpc>
-                <a:spcPct val="100000"/>
-              </a:lnSpc>
-              <a:spcBef>
-                <a:spcPts val="0"/>
-              </a:spcBef>
-              <a:spcAft>
-                <a:spcPts val="0"/>
-              </a:spcAft>
-              <a:buNone/>
-            </a:pPr>
-            <a:r>
-              <a:rPr cap="none" sz="900" i="0" b="1" u="none" strike="noStrike">
-                <a:solidFill>
-                  <a:srgbClr val="667180">
-                    <a:alpha val="100000"/>
-                  </a:srgbClr>
-                </a:solidFill>
-                <a:latin typeface="Helvetica Neue"/>
-                <a:cs typeface="Helvetica Neue"/>
-                <a:ea typeface="Helvetica Neue"/>
-                <a:sym typeface="Helvetica Neue"/>
-              </a:rPr>
-              <a:t>NITAZENES (ANY)</a:t>
-            </a:r>
-          </a:p>
-        </p:txBody>
-      </p:sp>
-      <p:sp>
-        <p:nvSpPr>
-          <p:cNvPr id="32" name=""/>
-          <p:cNvSpPr>
-            <a:spLocks noGrp="1"/>
-          </p:cNvSpPr>
-          <p:nvPr>
-            <p:ph/>
-          </p:nvPr>
-        </p:nvSpPr>
-        <p:spPr>
-          <a:xfrm>
-            <a:off x="3429000" y="4842933"/>
-            <a:ext cx="2603500" cy="292100"/>
-          </a:xfrm>
-        </p:spPr>
-        <p:txBody>
-          <a:bodyPr/>
-          <a:lstStyle/>
-          <a:p>
-            <a:pPr algn="l" marL="0" marR="0">
-              <a:lnSpc>
-                <a:spcPct val="100000"/>
-              </a:lnSpc>
-              <a:spcBef>
-                <a:spcPts val="0"/>
-              </a:spcBef>
-              <a:spcAft>
-                <a:spcPts val="0"/>
-              </a:spcAft>
-              <a:buNone/>
-            </a:pPr>
-            <a:r>
-              <a:rPr cap="none" sz="1600" i="0" b="1" u="none" strike="noStrike">
-                <a:solidFill>
-                  <a:srgbClr val="13294B">
-                    <a:alpha val="100000"/>
-                  </a:srgbClr>
-                </a:solidFill>
-                <a:latin typeface="Helvetica Neue"/>
-                <a:cs typeface="Helvetica Neue"/>
-                <a:ea typeface="Helvetica Neue"/>
-                <a:sym typeface="Helvetica Neue"/>
-              </a:rPr>
-              <a:t>0 per 1,000</a:t>
-            </a:r>
-          </a:p>
-        </p:txBody>
-      </p:sp>
-      <p:pic>
-        <p:nvPicPr>
-          <p:cNvPr id="33" name="" descr=""/>
-          <p:cNvPicPr>
-            <a:picLocks noGrp="1"/>
-          </p:cNvPicPr>
-          <p:nvPr>
-            <p:ph/>
-          </p:nvPr>
-        </p:nvPicPr>
-        <p:blipFill>
-          <a:blip r:embed="rId11"/>
-          <a:stretch>
-            <a:fillRect/>
-          </a:stretch>
-        </p:blipFill>
-        <p:spPr>
-          <a:xfrm>
-            <a:off x="3429000" y="5135033"/>
-            <a:ext cx="2603500" cy="960967"/>
-          </a:xfrm>
-          <a:prstGeom prst="rect">
-            <a:avLst/>
-          </a:prstGeom>
-        </p:spPr>
-      </p:pic>
-      <p:sp>
-        <p:nvSpPr>
-          <p:cNvPr id="34" name=""/>
-          <p:cNvSpPr>
-            <a:spLocks noGrp="1"/>
-          </p:cNvSpPr>
-          <p:nvPr>
-            <p:ph/>
-          </p:nvPr>
-        </p:nvSpPr>
-        <p:spPr>
-          <a:xfrm>
-            <a:off x="6159500" y="4652433"/>
-            <a:ext cx="2603500" cy="190500"/>
-          </a:xfrm>
-        </p:spPr>
-        <p:txBody>
-          <a:bodyPr/>
-          <a:lstStyle/>
-          <a:p>
-            <a:pPr algn="l" marL="0" marR="0">
-              <a:lnSpc>
-                <a:spcPct val="100000"/>
-              </a:lnSpc>
-              <a:spcBef>
-                <a:spcPts val="0"/>
-              </a:spcBef>
-              <a:spcAft>
-                <a:spcPts val="0"/>
-              </a:spcAft>
-              <a:buNone/>
-            </a:pPr>
-            <a:r>
-              <a:rPr cap="none" sz="900" i="0" b="1" u="none" strike="noStrike">
-                <a:solidFill>
-                  <a:srgbClr val="667180">
-                    <a:alpha val="100000"/>
-                  </a:srgbClr>
-                </a:solidFill>
-                <a:latin typeface="Helvetica Neue"/>
-                <a:cs typeface="Helvetica Neue"/>
-                <a:ea typeface="Helvetica Neue"/>
-                <a:sym typeface="Helvetica Neue"/>
-              </a:rPr>
-              <a:t>BTMPS (ANY)</a:t>
-            </a:r>
-          </a:p>
-        </p:txBody>
-      </p:sp>
-      <p:sp>
-        <p:nvSpPr>
-          <p:cNvPr id="35" name=""/>
-          <p:cNvSpPr>
-            <a:spLocks noGrp="1"/>
-          </p:cNvSpPr>
-          <p:nvPr>
-            <p:ph/>
-          </p:nvPr>
-        </p:nvSpPr>
-        <p:spPr>
-          <a:xfrm>
-            <a:off x="6159500" y="4842933"/>
-            <a:ext cx="2603500" cy="292100"/>
-          </a:xfrm>
-        </p:spPr>
-        <p:txBody>
-          <a:bodyPr/>
-          <a:lstStyle/>
-          <a:p>
-            <a:pPr algn="l" marL="0" marR="0">
-              <a:lnSpc>
-                <a:spcPct val="100000"/>
-              </a:lnSpc>
-              <a:spcBef>
-                <a:spcPts val="0"/>
-              </a:spcBef>
-              <a:spcAft>
-                <a:spcPts val="0"/>
-              </a:spcAft>
-              <a:buNone/>
-            </a:pPr>
-            <a:r>
-              <a:rPr cap="none" sz="1600" i="0" b="1" u="none" strike="noStrike">
-                <a:solidFill>
-                  <a:srgbClr val="13294B">
-                    <a:alpha val="100000"/>
-                  </a:srgbClr>
-                </a:solidFill>
-                <a:latin typeface="Helvetica Neue"/>
-                <a:cs typeface="Helvetica Neue"/>
-                <a:ea typeface="Helvetica Neue"/>
-                <a:sym typeface="Helvetica Neue"/>
-              </a:rPr>
-              <a:t>18 per 1,000</a:t>
-            </a:r>
-          </a:p>
-        </p:txBody>
-      </p:sp>
-      <p:pic>
-        <p:nvPicPr>
-          <p:cNvPr id="36" name="" descr=""/>
-          <p:cNvPicPr>
-            <a:picLocks noGrp="1"/>
-          </p:cNvPicPr>
-          <p:nvPr>
-            <p:ph/>
-          </p:nvPr>
-        </p:nvPicPr>
-        <p:blipFill>
-          <a:blip r:embed="rId12"/>
-          <a:stretch>
-            <a:fillRect/>
-          </a:stretch>
-        </p:blipFill>
-        <p:spPr>
-          <a:xfrm>
-            <a:off x="6159500" y="5135033"/>
-            <a:ext cx="2603500" cy="960967"/>
-          </a:xfrm>
-          <a:prstGeom prst="rect">
-            <a:avLst/>
-          </a:prstGeom>
-        </p:spPr>
-      </p:pic>
-      <p:sp>
-        <p:nvSpPr>
-          <p:cNvPr id="37" name=""/>
-          <p:cNvSpPr>
-            <a:spLocks noGrp="1"/>
-          </p:cNvSpPr>
-          <p:nvPr>
-            <p:ph/>
-          </p:nvPr>
-        </p:nvSpPr>
-        <p:spPr>
-          <a:xfrm>
-            <a:off x="8890000" y="4652433"/>
-            <a:ext cx="2603500" cy="190500"/>
-          </a:xfrm>
-        </p:spPr>
-        <p:txBody>
-          <a:bodyPr/>
-          <a:lstStyle/>
-          <a:p>
-            <a:pPr algn="l" marL="0" marR="0">
-              <a:lnSpc>
-                <a:spcPct val="100000"/>
-              </a:lnSpc>
-              <a:spcBef>
-                <a:spcPts val="0"/>
-              </a:spcBef>
-              <a:spcAft>
-                <a:spcPts val="0"/>
-              </a:spcAft>
-              <a:buNone/>
-            </a:pPr>
-            <a:r>
-              <a:rPr cap="none" sz="900" i="0" b="1" u="none" strike="noStrike">
-                <a:solidFill>
-                  <a:srgbClr val="667180">
-                    <a:alpha val="100000"/>
-                  </a:srgbClr>
-                </a:solidFill>
-                <a:latin typeface="Helvetica Neue"/>
-                <a:cs typeface="Helvetica Neue"/>
-                <a:ea typeface="Helvetica Neue"/>
-                <a:sym typeface="Helvetica Neue"/>
-              </a:rPr>
-              <a:t>OVERDOSE-INVOLVED</a:t>
-            </a:r>
-          </a:p>
-        </p:txBody>
-      </p:sp>
-      <p:sp>
-        <p:nvSpPr>
-          <p:cNvPr id="38" name=""/>
-          <p:cNvSpPr>
-            <a:spLocks noGrp="1"/>
-          </p:cNvSpPr>
-          <p:nvPr>
-            <p:ph/>
-          </p:nvPr>
-        </p:nvSpPr>
-        <p:spPr>
-          <a:xfrm>
-            <a:off x="8890000" y="4842933"/>
-            <a:ext cx="2603500" cy="292100"/>
-          </a:xfrm>
-        </p:spPr>
-        <p:txBody>
-          <a:bodyPr/>
-          <a:lstStyle/>
-          <a:p>
-            <a:pPr algn="l" marL="0" marR="0">
-              <a:lnSpc>
-                <a:spcPct val="100000"/>
-              </a:lnSpc>
-              <a:spcBef>
-                <a:spcPts val="0"/>
-              </a:spcBef>
-              <a:spcAft>
-                <a:spcPts val="0"/>
-              </a:spcAft>
-              <a:buNone/>
-            </a:pPr>
-            <a:r>
-              <a:rPr cap="none" sz="1600" i="0" b="1" u="none" strike="noStrike">
-                <a:solidFill>
-                  <a:srgbClr val="13294B">
-                    <a:alpha val="100000"/>
-                  </a:srgbClr>
-                </a:solidFill>
-                <a:latin typeface="Helvetica Neue"/>
-                <a:cs typeface="Helvetica Neue"/>
-                <a:ea typeface="Helvetica Neue"/>
-                <a:sym typeface="Helvetica Neue"/>
-              </a:rPr>
-              <a:t>50 per 1,000</a:t>
-            </a:r>
-          </a:p>
-        </p:txBody>
-      </p:sp>
-      <p:pic>
-        <p:nvPicPr>
-          <p:cNvPr id="39" name="" descr=""/>
-          <p:cNvPicPr>
-            <a:picLocks noGrp="1"/>
-          </p:cNvPicPr>
-          <p:nvPr>
-            <p:ph/>
-          </p:nvPr>
-        </p:nvPicPr>
-        <p:blipFill>
-          <a:blip r:embed="rId13"/>
-          <a:stretch>
-            <a:fillRect/>
-          </a:stretch>
-        </p:blipFill>
-        <p:spPr>
-          <a:xfrm>
-            <a:off x="8890000" y="5135033"/>
-            <a:ext cx="2603500" cy="960967"/>
-          </a:xfrm>
-          <a:prstGeom prst="rect">
-            <a:avLst/>
-          </a:prstGeom>
-        </p:spPr>
-      </p:pic>
-      <p:sp>
-        <p:nvSpPr>
-          <p:cNvPr id="40" name=""/>
-          <p:cNvSpPr>
-            <a:spLocks noGrp="1"/>
-          </p:cNvSpPr>
-          <p:nvPr>
-            <p:ph/>
-          </p:nvPr>
-        </p:nvSpPr>
-        <p:spPr>
-          <a:xfrm>
             <a:off x="698500" y="6248400"/>
             <a:ext cx="10795000" cy="381000"/>
           </a:xfrm>
@@ -9811,6 +8666,55 @@
         </p:nvSpPr>
         <p:spPr>
           <a:xfrm>
+            <a:off x="698500" y="1511300"/>
+            <a:ext cx="10795000" cy="4584700"/>
+          </a:xfrm>
+        </p:spPr>
+        <p:txBody>
+          <a:bodyPr/>
+          <a:lstStyle/>
+          <a:p>
+            <a:pPr algn="l" marL="0" marR="0">
+              <a:lnSpc>
+                <a:spcPct val="100000"/>
+              </a:lnSpc>
+              <a:spcBef>
+                <a:spcPts val="0"/>
+              </a:spcBef>
+              <a:spcAft>
+                <a:spcPts val="0"/>
+              </a:spcAft>
+              <a:buNone/>
+            </a:pPr>
+            <a:r>
+              <a:rPr cap="none" sz="1400" i="0" b="0" u="none" strike="noStrike">
+                <a:solidFill>
+                  <a:srgbClr val="5B6770">
+                    <a:alpha val="100000"/>
+                  </a:srgbClr>
+                </a:solidFill>
+                <a:latin typeface="Helvetica Neue"/>
+                <a:cs typeface="Helvetica Neue"/>
+                <a:ea typeface="Helvetica Neue"/>
+                <a:sym typeface="Helvetica Neue"/>
+              </a:rPr>
+              <a:t>alt="The UNC Street Drug Analysis Lab logo banner." style="width:1240px;align-self:center;margin:56px 0 40px"&gt; 1 · CollectResidue on a card with what the donor expected, felt, and saw 2 · MailAnonymous samples mailed from harm reduction programs statewide 3 · AnalyzeGCMS identifies each substance and flags primary vs. trace abundance 4 · PublishResults posted publicly and folded into these two datasets daily Sample-level records: results.streetsafe.supply/sample/&amp;lt;sampleid&amp;gt;</a:t>
+            </a:r>
+          </a:p>
+        </p:txBody>
+      </p:sp>
+      <p:sp>
+        <p:nvSpPr>
+          <p:cNvPr id="5" name=""/>
+          <p:cNvSpPr>
+            <a:spLocks noGrp="1"/>
+          </p:cNvSpPr>
+          <p:nvPr>
+            <p:ph/>
+          </p:nvPr>
+        </p:nvSpPr>
+        <p:spPr>
+          <a:xfrm>
             <a:off x="698500" y="6248400"/>
             <a:ext cx="10795000" cy="381000"/>
           </a:xfrm>
@@ -9922,6 +8826,55 @@
           </a:p>
         </p:txBody>
       </p:sp>
+      <p:sp>
+        <p:nvSpPr>
+          <p:cNvPr id="3" name=""/>
+          <p:cNvSpPr>
+            <a:spLocks noGrp="1"/>
+          </p:cNvSpPr>
+          <p:nvPr>
+            <p:ph/>
+          </p:nvPr>
+        </p:nvSpPr>
+        <p:spPr>
+          <a:xfrm>
+            <a:off x="698500" y="1511300"/>
+            <a:ext cx="10795000" cy="4584700"/>
+          </a:xfrm>
+        </p:spPr>
+        <p:txBody>
+          <a:bodyPr/>
+          <a:lstStyle/>
+          <a:p>
+            <a:pPr algn="l" marL="0" marR="0">
+              <a:lnSpc>
+                <a:spcPct val="100000"/>
+              </a:lnSpc>
+              <a:spcBef>
+                <a:spcPts val="0"/>
+              </a:spcBef>
+              <a:spcAft>
+                <a:spcPts val="0"/>
+              </a:spcAft>
+              <a:buNone/>
+            </a:pPr>
+            <a:r>
+              <a:rPr cap="none" sz="1400" i="0" b="0" u="none" strike="noStrike">
+                <a:solidFill>
+                  <a:srgbClr val="5B6770">
+                    <a:alpha val="100000"/>
+                  </a:srgbClr>
+                </a:solidFill>
+                <a:latin typeface="Helvetica Neue"/>
+                <a:cs typeface="Helvetica Neue"/>
+                <a:ea typeface="Helvetica Neue"/>
+                <a:sym typeface="Helvetica Neue"/>
+              </a:rPr>
+              <a:t>Key substances in the legacy OCME dashboard format the state expects — headline month comparison, month-to-month lines, year-to-year YTD bars, and the co-detection mix — computed from drug checking samples instead of death records.</a:t>
+            </a:r>
+          </a:p>
+        </p:txBody>
+      </p:sp>
     </p:spTree>
   </p:cSld>
   <p:clrMapOvr>
@@ -9991,7 +8944,7 @@
                 <a:ea typeface="Helvetica Neue"/>
                 <a:sym typeface="Helvetica Neue"/>
               </a:rPr>
-              <a:t>Fentanyl-Positive Samples, UNC Street Drug Analysis Lab (Drug Checking) Data: {{STAT:latest_month}}*</a:t>
+              <a:t>Fentanyl-Positive Samples, UNC Street Drug Analysis Lab (Drug Checking) Data: Aug 2026*</a:t>
             </a:r>
           </a:p>
         </p:txBody>
@@ -10117,7 +9070,7 @@
                 <a:ea typeface="Helvetica Neue"/>
                 <a:sym typeface="Helvetica Neue"/>
               </a:rPr>
-              <a:t>Xylazine-Positive Samples, UNC Street Drug Analysis Lab (Drug Checking) Data: {{STAT:latest_month}}*</a:t>
+              <a:t>Xylazine-Positive Samples, UNC Street Drug Analysis Lab (Drug Checking) Data: Aug 2026*</a:t>
             </a:r>
           </a:p>
         </p:txBody>
@@ -10243,7 +9196,7 @@
                 <a:ea typeface="Helvetica Neue"/>
                 <a:sym typeface="Helvetica Neue"/>
               </a:rPr>
-              <a:t>Methamphetamine-Positive Samples, UNC Street Drug Analysis Lab (Drug Checking) Data: {{STAT:latest_month}}*</a:t>
+              <a:t>Methamphetamine-Positive Samples, UNC Street Drug Analysis Lab (Drug Checking) Data: Aug 2026*</a:t>
             </a:r>
           </a:p>
         </p:txBody>
@@ -10369,7 +9322,7 @@
                 <a:ea typeface="Helvetica Neue"/>
                 <a:sym typeface="Helvetica Neue"/>
               </a:rPr>
-              <a:t>Cocaine-Positive Samples, UNC Street Drug Analysis Lab (Drug Checking) Data: {{STAT:latest_month}}*</a:t>
+              <a:t>Cocaine-Positive Samples, UNC Street Drug Analysis Lab (Drug Checking) Data: Aug 2026*</a:t>
             </a:r>
           </a:p>
         </p:txBody>
@@ -10500,6 +9453,55 @@
           </a:p>
         </p:txBody>
       </p:sp>
+      <p:sp>
+        <p:nvSpPr>
+          <p:cNvPr id="3" name=""/>
+          <p:cNvSpPr>
+            <a:spLocks noGrp="1"/>
+          </p:cNvSpPr>
+          <p:nvPr>
+            <p:ph/>
+          </p:nvPr>
+        </p:nvSpPr>
+        <p:spPr>
+          <a:xfrm>
+            <a:off x="698500" y="1511300"/>
+            <a:ext cx="10795000" cy="4584700"/>
+          </a:xfrm>
+        </p:spPr>
+        <p:txBody>
+          <a:bodyPr/>
+          <a:lstStyle/>
+          <a:p>
+            <a:pPr algn="l" marL="0" marR="0">
+              <a:lnSpc>
+                <a:spcPct val="100000"/>
+              </a:lnSpc>
+              <a:spcBef>
+                <a:spcPts val="0"/>
+              </a:spcBef>
+              <a:spcAft>
+                <a:spcPts val="0"/>
+              </a:spcAft>
+              <a:buNone/>
+            </a:pPr>
+            <a:r>
+              <a:rPr cap="none" sz="1400" i="0" b="0" u="none" strike="noStrike">
+                <a:solidFill>
+                  <a:srgbClr val="5B6770">
+                    <a:alpha val="100000"/>
+                  </a:srgbClr>
+                </a:solidFill>
+                <a:latin typeface="Helvetica Neue"/>
+                <a:cs typeface="Helvetica Neue"/>
+                <a:ea typeface="Helvetica Neue"/>
+                <a:sym typeface="Helvetica Neue"/>
+              </a:rPr>
+              <a:t>North Carolina in three regions — eastern, central, western — assigned by county of sample collection. For each key substance: prevalence per 1,000 samples last quarter, and the change from the quarter before.</a:t>
+            </a:r>
+          </a:p>
+        </p:txBody>
+      </p:sp>
     </p:spTree>
   </p:cSld>
   <p:clrMapOvr>
@@ -10569,7 +9571,7 @@
                 <a:ea typeface="Helvetica Neue"/>
                 <a:sym typeface="Helvetica Neue"/>
               </a:rPr>
-              <a:t>Fentanyl by Region, UNC Street Drug Analysis Lab (Drug Checking) Data: {{STAT:latest_q}}</a:t>
+              <a:t>Fentanyl by Region, UNC Street Drug Analysis Lab (Drug Checking) Data: 2026Q2</a:t>
             </a:r>
           </a:p>
         </p:txBody>
@@ -10670,7 +9672,7 @@
                 <a:ea typeface="Helvetica Neue"/>
                 <a:sym typeface="Helvetica Neue"/>
               </a:rPr>
-              <a:t>Fentanyl-positive (any abundance) per 1,000 samples completed in the region, {{STAT:latest_q}}</a:t>
+              <a:t>Fentanyl-positive (any abundance) per 1,000 samples completed in the region, 2026Q2</a:t>
             </a:r>
           </a:p>
         </p:txBody>
@@ -10744,7 +9746,7 @@
                 <a:ea typeface="Helvetica Neue"/>
                 <a:sym typeface="Helvetica Neue"/>
               </a:rPr>
-              <a:t>Xylazine by Region, UNC Street Drug Analysis Lab (Drug Checking) Data: {{STAT:latest_q}}</a:t>
+              <a:t>Xylazine by Region, UNC Street Drug Analysis Lab (Drug Checking) Data: 2026Q2</a:t>
             </a:r>
           </a:p>
         </p:txBody>
@@ -10845,7 +9847,7 @@
                 <a:ea typeface="Helvetica Neue"/>
                 <a:sym typeface="Helvetica Neue"/>
               </a:rPr>
-              <a:t>Xylazine-positive (any abundance) per 1,000 samples completed in the region, {{STAT:latest_q}}</a:t>
+              <a:t>Xylazine-positive (any abundance) per 1,000 samples completed in the region, 2026Q2</a:t>
             </a:r>
           </a:p>
         </p:txBody>
@@ -10919,7 +9921,7 @@
                 <a:ea typeface="Helvetica Neue"/>
                 <a:sym typeface="Helvetica Neue"/>
               </a:rPr>
-              <a:t>Methamphetamine by Region, UNC Street Drug Analysis Lab (Drug Checking) Data: {{STAT:latest_q}}</a:t>
+              <a:t>Methamphetamine by Region, UNC Street Drug Analysis Lab (Drug Checking) Data: 2026Q2</a:t>
             </a:r>
           </a:p>
         </p:txBody>
@@ -11020,7 +10022,7 @@
                 <a:ea typeface="Helvetica Neue"/>
                 <a:sym typeface="Helvetica Neue"/>
               </a:rPr>
-              <a:t>Methamphetamine-positive (any abundance) per 1,000 samples completed in the region, {{STAT:latest_q}}</a:t>
+              <a:t>Methamphetamine-positive (any abundance) per 1,000 samples completed in the region, 2026Q2</a:t>
             </a:r>
           </a:p>
         </p:txBody>
@@ -11094,7 +10096,7 @@
                 <a:ea typeface="Helvetica Neue"/>
                 <a:sym typeface="Helvetica Neue"/>
               </a:rPr>
-              <a:t>Cocaine by Region, UNC Street Drug Analysis Lab (Drug Checking) Data: {{STAT:latest_q}}</a:t>
+              <a:t>Cocaine by Region, UNC Street Drug Analysis Lab (Drug Checking) Data: 2026Q2</a:t>
             </a:r>
           </a:p>
         </p:txBody>
@@ -11195,7 +10197,7 @@
                 <a:ea typeface="Helvetica Neue"/>
                 <a:sym typeface="Helvetica Neue"/>
               </a:rPr>
-              <a:t>Cocaine-positive (any abundance) per 1,000 samples completed in the region, {{STAT:latest_q}}</a:t>
+              <a:t>Cocaine-positive (any abundance) per 1,000 samples completed in the region, 2026Q2</a:t>
             </a:r>
           </a:p>
         </p:txBody>
@@ -11326,6 +10328,55 @@
       <p:sp>
         <p:nvSpPr>
           <p:cNvPr id="4" name=""/>
+          <p:cNvSpPr>
+            <a:spLocks noGrp="1"/>
+          </p:cNvSpPr>
+          <p:nvPr>
+            <p:ph/>
+          </p:nvPr>
+        </p:nvSpPr>
+        <p:spPr>
+          <a:xfrm>
+            <a:off x="698500" y="1511300"/>
+            <a:ext cx="10795000" cy="4584700"/>
+          </a:xfrm>
+        </p:spPr>
+        <p:txBody>
+          <a:bodyPr/>
+          <a:lstStyle/>
+          <a:p>
+            <a:pPr algn="l" marL="0" marR="0">
+              <a:lnSpc>
+                <a:spcPct val="100000"/>
+              </a:lnSpc>
+              <a:spcBef>
+                <a:spcPts val="0"/>
+              </a:spcBef>
+              <a:spcAft>
+                <a:spcPts val="0"/>
+              </a:spcAft>
+              <a:buNone/>
+            </a:pPr>
+            <a:r>
+              <a:rPr cap="none" sz="1400" i="0" b="0" u="none" strike="noStrike">
+                <a:solidFill>
+                  <a:srgbClr val="5B6770">
+                    <a:alpha val="100000"/>
+                  </a:srgbClr>
+                </a:solidFill>
+                <a:latin typeface="Helvetica Neue"/>
+                <a:cs typeface="Helvetica Neue"/>
+                <a:ea typeface="Helvetica Neue"/>
+                <a:sym typeface="Helvetica Neue"/>
+              </a:rPr>
+              <a:t>1 Voluntary Samples are provided voluntarily to a partnering organization — never collected covertly. 2 Anonymous Individual sample donors are anonymous to the UNC lab; no identifying information travels with a sample. 3 Donor gets results first Results must be returned to the sample donor in a timely manner — before any aggregate reporting. Who submits Health-serving organizations: harm reduction programs, drug user unions, public health agencies, and universities. How samples travel Collected as powders, pill fragments, swabs, or used cottons; dissolved in acetonitrile and shipped with a prepaid return envelope — under established harm reduction exemptions in state controlled-substance law and federal small-quantity hazardous-materials regulations. Collection and shipping protocol details in the Supplemental Material Static slide — reviewed by lab staff, not regenerated nightly</a:t>
+            </a:r>
+          </a:p>
+        </p:txBody>
+      </p:sp>
+      <p:sp>
+        <p:nvSpPr>
+          <p:cNvPr id="5" name=""/>
           <p:cNvSpPr>
             <a:spLocks noGrp="1"/>
           </p:cNvSpPr>
@@ -11446,6 +10497,55 @@
           </a:p>
         </p:txBody>
       </p:sp>
+      <p:sp>
+        <p:nvSpPr>
+          <p:cNvPr id="3" name=""/>
+          <p:cNvSpPr>
+            <a:spLocks noGrp="1"/>
+          </p:cNvSpPr>
+          <p:nvPr>
+            <p:ph/>
+          </p:nvPr>
+        </p:nvSpPr>
+        <p:spPr>
+          <a:xfrm>
+            <a:off x="698500" y="1511300"/>
+            <a:ext cx="10795000" cy="4584700"/>
+          </a:xfrm>
+        </p:spPr>
+        <p:txBody>
+          <a:bodyPr/>
+          <a:lstStyle/>
+          <a:p>
+            <a:pPr algn="l" marL="0" marR="0">
+              <a:lnSpc>
+                <a:spcPct val="100000"/>
+              </a:lnSpc>
+              <a:spcBef>
+                <a:spcPts val="0"/>
+              </a:spcBef>
+              <a:spcAft>
+                <a:spcPts val="0"/>
+              </a:spcAft>
+              <a:buNone/>
+            </a:pPr>
+            <a:r>
+              <a:rPr cap="none" sz="1400" i="0" b="0" u="none" strike="noStrike">
+                <a:solidFill>
+                  <a:srgbClr val="5B6770">
+                    <a:alpha val="100000"/>
+                  </a:srgbClr>
+                </a:solidFill>
+                <a:latin typeface="Helvetica Neue"/>
+                <a:cs typeface="Helvetica Neue"/>
+                <a:ea typeface="Helvetica Neue"/>
+                <a:sym typeface="Helvetica Neue"/>
+              </a:rPr>
+              <a:t>Substances appearing in North Carolina for the first time ever, surfaced within the last three months of lab completions.</a:t>
+            </a:r>
+          </a:p>
+        </p:txBody>
+      </p:sp>
     </p:spTree>
   </p:cSld>
   <p:clrMapOvr>
@@ -15571,6 +14671,55 @@
         </p:nvSpPr>
         <p:spPr>
           <a:xfrm>
+            <a:off x="698500" y="1511300"/>
+            <a:ext cx="10795000" cy="4584700"/>
+          </a:xfrm>
+        </p:spPr>
+        <p:txBody>
+          <a:bodyPr/>
+          <a:lstStyle/>
+          <a:p>
+            <a:pPr algn="l" marL="0" marR="0">
+              <a:lnSpc>
+                <a:spcPct val="100000"/>
+              </a:lnSpc>
+              <a:spcBef>
+                <a:spcPts val="0"/>
+              </a:spcBef>
+              <a:spcAft>
+                <a:spcPts val="0"/>
+              </a:spcAft>
+              <a:buNone/>
+            </a:pPr>
+            <a:r>
+              <a:rPr cap="none" sz="1400" i="0" b="0" u="none" strike="noStrike">
+                <a:solidFill>
+                  <a:srgbClr val="5B6770">
+                    <a:alpha val="100000"/>
+                  </a:srgbClr>
+                </a:solidFill>
+                <a:latin typeface="Helvetica Neue"/>
+                <a:cs typeface="Helvetica Neue"/>
+                <a:ea typeface="Helvetica Neue"/>
+                <a:sym typeface="Helvetica Neue"/>
+              </a:rPr>
+              <a:t>MedetomidineFastest-growing adulterant; harder to reverse than xylazine with standard protocols.First NC detection: 2024Q4 · slide 20 BTMPSIndustrial chemical of unknown toxicity, now routine in fentanyl samples nationally.First NC detection: 2024Q4 · slide 26 Nitazene analoguesNew analogues keep appearing; potency varies wildly across the class.Newest analogue: Aug 2026 · slide 25 Curated by lab staff — the one slide reviewed by a human rather than regenerated nightly</a:t>
+            </a:r>
+          </a:p>
+        </p:txBody>
+      </p:sp>
+      <p:sp>
+        <p:nvSpPr>
+          <p:cNvPr id="5" name=""/>
+          <p:cNvSpPr>
+            <a:spLocks noGrp="1"/>
+          </p:cNvSpPr>
+          <p:nvPr>
+            <p:ph/>
+          </p:nvPr>
+        </p:nvSpPr>
+        <p:spPr>
+          <a:xfrm>
             <a:off x="698500" y="6248400"/>
             <a:ext cx="10795000" cy="381000"/>
           </a:xfrm>
@@ -15682,6 +14831,55 @@
           </a:p>
         </p:txBody>
       </p:sp>
+      <p:sp>
+        <p:nvSpPr>
+          <p:cNvPr id="3" name=""/>
+          <p:cNvSpPr>
+            <a:spLocks noGrp="1"/>
+          </p:cNvSpPr>
+          <p:nvPr>
+            <p:ph/>
+          </p:nvPr>
+        </p:nvSpPr>
+        <p:spPr>
+          <a:xfrm>
+            <a:off x="698500" y="1511300"/>
+            <a:ext cx="10795000" cy="4584700"/>
+          </a:xfrm>
+        </p:spPr>
+        <p:txBody>
+          <a:bodyPr/>
+          <a:lstStyle/>
+          <a:p>
+            <a:pPr algn="l" marL="0" marR="0">
+              <a:lnSpc>
+                <a:spcPct val="100000"/>
+              </a:lnSpc>
+              <a:spcBef>
+                <a:spcPts val="0"/>
+              </a:spcBef>
+              <a:spcAft>
+                <a:spcPts val="0"/>
+              </a:spcAft>
+              <a:buNone/>
+            </a:pPr>
+            <a:r>
+              <a:rPr cap="none" sz="1400" i="0" b="0" u="none" strike="noStrike">
+                <a:solidFill>
+                  <a:srgbClr val="5B6770">
+                    <a:alpha val="100000"/>
+                  </a:srgbClr>
+                </a:solidFill>
+                <a:latin typeface="Helvetica Neue"/>
+                <a:cs typeface="Helvetica Neue"/>
+                <a:ea typeface="Helvetica Neue"/>
+                <a:sym typeface="Helvetica Neue"/>
+              </a:rPr>
+              <a:t>What these data can and cannot say — read before citing any number in this deck.</a:t>
+            </a:r>
+          </a:p>
+        </p:txBody>
+      </p:sp>
     </p:spTree>
   </p:cSld>
   <p:clrMapOvr>
@@ -15808,6 +15006,55 @@
       <p:sp>
         <p:nvSpPr>
           <p:cNvPr id="4" name=""/>
+          <p:cNvSpPr>
+            <a:spLocks noGrp="1"/>
+          </p:cNvSpPr>
+          <p:nvPr>
+            <p:ph/>
+          </p:nvPr>
+        </p:nvSpPr>
+        <p:spPr>
+          <a:xfrm>
+            <a:off x="698500" y="1511300"/>
+            <a:ext cx="10795000" cy="4584700"/>
+          </a:xfrm>
+        </p:spPr>
+        <p:txBody>
+          <a:bodyPr/>
+          <a:lstStyle/>
+          <a:p>
+            <a:pPr algn="l" marL="0" marR="0">
+              <a:lnSpc>
+                <a:spcPct val="100000"/>
+              </a:lnSpc>
+              <a:spcBef>
+                <a:spcPts val="0"/>
+              </a:spcBef>
+              <a:spcAft>
+                <a:spcPts val="0"/>
+              </a:spcAft>
+              <a:buNone/>
+            </a:pPr>
+            <a:r>
+              <a:rPr cap="none" sz="1400" i="0" b="0" u="none" strike="noStrike">
+                <a:solidFill>
+                  <a:srgbClr val="5B6770">
+                    <a:alpha val="100000"/>
+                  </a:srgbClr>
+                </a:solidFill>
+                <a:latin typeface="Helvetica Neue"/>
+                <a:cs typeface="Helvetica Neue"/>
+                <a:ea typeface="Helvetica Neue"/>
+                <a:sym typeface="Helvetica Neue"/>
+              </a:rPr>
+              <a:t>· ~70% of samples are post-consumption — drugs often arrive because they caused unexpected reactions, inflating unusual findings · Point-of-care FTIR programs test first and may mail us their most complex samples · This is a convenience sample — rates per 1,000 samples are not population prevalence · GCMS abundance is qualitative: trace ≠ quantified concentration, and no purity is measured · Locations geocode to city/county centroids and default to the program's mailing city when blank · The current quarter is always partial; overdose involvement is only known when reported Full methods and variable notes: technical_details.md + codebook in the opioiddatalab/drugchecking repository</a:t>
+            </a:r>
+          </a:p>
+        </p:txBody>
+      </p:sp>
+      <p:sp>
+        <p:nvSpPr>
+          <p:cNvPr id="5" name=""/>
           <p:cNvSpPr>
             <a:spLocks noGrp="1"/>
           </p:cNvSpPr>
@@ -15989,6 +15236,55 @@
         </p:nvSpPr>
         <p:spPr>
           <a:xfrm>
+            <a:off x="698500" y="1511300"/>
+            <a:ext cx="10795000" cy="4584700"/>
+          </a:xfrm>
+        </p:spPr>
+        <p:txBody>
+          <a:bodyPr/>
+          <a:lstStyle/>
+          <a:p>
+            <a:pPr algn="l" marL="0" marR="0">
+              <a:lnSpc>
+                <a:spcPct val="100000"/>
+              </a:lnSpc>
+              <a:spcBef>
+                <a:spcPts val="0"/>
+              </a:spcBef>
+              <a:spcAft>
+                <a:spcPts val="0"/>
+              </a:spcAft>
+              <a:buNone/>
+            </a:pPr>
+            <a:r>
+              <a:rPr cap="none" sz="1400" i="0" b="0" u="none" strike="noStrike">
+                <a:solidFill>
+                  <a:srgbClr val="5B6770">
+                    <a:alpha val="100000"/>
+                  </a:srgbClr>
+                </a:solidFill>
+                <a:latin typeface="Helvetica Neue"/>
+                <a:cs typeface="Helvetica Neue"/>
+                <a:ea typeface="Helvetica Neue"/>
+                <a:sym typeface="Helvetica Neue"/>
+              </a:rPr>
+              <a:t>Card variables expectedsubstance · expect_* sensations · sen_* color · bright_color · texture overdose · od · overdose_notes sampletype · collection · consumed location · county · state · countyfips Derived lab flags lab_&amp;lt;drug&amp;gt; = primary lab_&amp;lt;drug&amp;gt;_any = primary or trace lab_&amp;lt;drug&amp;gt;_trace = trace only lab_num_substances(_any) lab_null · primary · trace lab_fentanyl_impurity lab_detail columns sampleid · substance · method abundance (blank = primary) chemical-class flags PubChem CID · CAS · UNII date_complete Full codebook (96 variables): github.com/opioiddatalab/drugchecking → datasets/unc_druchecking_codebook.txt</a:t>
+            </a:r>
+          </a:p>
+        </p:txBody>
+      </p:sp>
+      <p:sp>
+        <p:nvSpPr>
+          <p:cNvPr id="5" name=""/>
+          <p:cNvSpPr>
+            <a:spLocks noGrp="1"/>
+          </p:cNvSpPr>
+          <p:nvPr>
+            <p:ph/>
+          </p:nvPr>
+        </p:nvSpPr>
+        <p:spPr>
+          <a:xfrm>
             <a:off x="698500" y="6248400"/>
             <a:ext cx="10795000" cy="381000"/>
           </a:xfrm>
@@ -16161,6 +15457,55 @@
         </p:nvSpPr>
         <p:spPr>
           <a:xfrm>
+            <a:off x="698500" y="1511300"/>
+            <a:ext cx="10795000" cy="4584700"/>
+          </a:xfrm>
+        </p:spPr>
+        <p:txBody>
+          <a:bodyPr/>
+          <a:lstStyle/>
+          <a:p>
+            <a:pPr algn="l" marL="0" marR="0">
+              <a:lnSpc>
+                <a:spcPct val="100000"/>
+              </a:lnSpc>
+              <a:spcBef>
+                <a:spcPts val="0"/>
+              </a:spcBef>
+              <a:spcAft>
+                <a:spcPts val="0"/>
+              </a:spcAft>
+              <a:buNone/>
+            </a:pPr>
+            <a:r>
+              <a:rPr cap="none" sz="1400" i="0" b="0" u="none" strike="noStrike">
+                <a:solidFill>
+                  <a:srgbClr val="5B6770">
+                    <a:alpha val="100000"/>
+                  </a:srgbClr>
+                </a:solidFill>
+                <a:latin typeface="Helvetica Neue"/>
+                <a:cs typeface="Helvetica Neue"/>
+                <a:ea typeface="Helvetica Neue"/>
+                <a:sym typeface="Helvetica Neue"/>
+              </a:rPr>
+              <a:t>NC extractsdata.streetsafe.supply/datasets/NC/analysis_dataset.csv data.streetsafe.supply/datasets/NC/lab_detail.csv RefreshDaily · four formats (CSV, Stata, Excel, SAS) · link on sampleid DocumentationCodebook + technical_details.md in github.com/opioiddatalab/drugchecking Sample recordsPublic, human-readable result pages at results.streetsafe.supply TermsData Use &amp; Protection Statement at results.streetsafe.supply/data-use Questions about access or additional chemical classifications: contact the lab via opioiddata.org Data and code released under CC0 1.0 (public domain dedication). Attribution is not required, but is requested: UNC Street Drug Analysis Lab · OpioidData.org.</a:t>
+            </a:r>
+          </a:p>
+        </p:txBody>
+      </p:sp>
+      <p:sp>
+        <p:nvSpPr>
+          <p:cNvPr id="5" name=""/>
+          <p:cNvSpPr>
+            <a:spLocks noGrp="1"/>
+          </p:cNvSpPr>
+          <p:nvPr>
+            <p:ph/>
+          </p:nvPr>
+        </p:nvSpPr>
+        <p:spPr>
+          <a:xfrm>
             <a:off x="698500" y="6248400"/>
             <a:ext cx="10795000" cy="381000"/>
           </a:xfrm>
@@ -16272,6 +15617,55 @@
           </a:p>
         </p:txBody>
       </p:sp>
+      <p:sp>
+        <p:nvSpPr>
+          <p:cNvPr id="3" name=""/>
+          <p:cNvSpPr>
+            <a:spLocks noGrp="1"/>
+          </p:cNvSpPr>
+          <p:nvPr>
+            <p:ph/>
+          </p:nvPr>
+        </p:nvSpPr>
+        <p:spPr>
+          <a:xfrm>
+            <a:off x="698500" y="1511300"/>
+            <a:ext cx="10795000" cy="4584700"/>
+          </a:xfrm>
+        </p:spPr>
+        <p:txBody>
+          <a:bodyPr/>
+          <a:lstStyle/>
+          <a:p>
+            <a:pPr algn="l" marL="0" marR="0">
+              <a:lnSpc>
+                <a:spcPct val="100000"/>
+              </a:lnSpc>
+              <a:spcBef>
+                <a:spcPts val="0"/>
+              </a:spcBef>
+              <a:spcAft>
+                <a:spcPts val="0"/>
+              </a:spcAft>
+              <a:buNone/>
+            </a:pPr>
+            <a:r>
+              <a:rPr cap="none" sz="1400" i="0" b="0" u="none" strike="noStrike">
+                <a:solidFill>
+                  <a:srgbClr val="5B6770">
+                    <a:alpha val="100000"/>
+                  </a:srgbClr>
+                </a:solidFill>
+                <a:latin typeface="Helvetica Neue"/>
+                <a:cs typeface="Helvetica Neue"/>
+                <a:ea typeface="Helvetica Neue"/>
+                <a:sym typeface="Helvetica Neue"/>
+              </a:rPr>
+              <a:t>The numbers behind the key charts, as accessible tables — regenerated nightly with the figures. Chart slides point here from their footers.</a:t>
+            </a:r>
+          </a:p>
+        </p:txBody>
+      </p:sp>
     </p:spTree>
   </p:cSld>
   <p:clrMapOvr>
@@ -20617,6 +20011,55 @@
         </p:nvSpPr>
         <p:spPr>
           <a:xfrm>
+            <a:off x="698500" y="1511300"/>
+            <a:ext cx="10795000" cy="4584700"/>
+          </a:xfrm>
+        </p:spPr>
+        <p:txBody>
+          <a:bodyPr/>
+          <a:lstStyle/>
+          <a:p>
+            <a:pPr algn="l" marL="0" marR="0">
+              <a:lnSpc>
+                <a:spcPct val="100000"/>
+              </a:lnSpc>
+              <a:spcBef>
+                <a:spcPts val="0"/>
+              </a:spcBef>
+              <a:spcAft>
+                <a:spcPts val="0"/>
+              </a:spcAft>
+              <a:buNone/>
+            </a:pPr>
+            <a:r>
+              <a:rPr cap="none" sz="1400" i="0" b="0" u="none" strike="noStrike">
+                <a:solidFill>
+                  <a:srgbClr val="5B6770">
+                    <a:alpha val="100000"/>
+                  </a:srgbClr>
+                </a:solidFill>
+                <a:latin typeface="Helvetica Neue"/>
+                <a:cs typeface="Helvetica Neue"/>
+                <a:ea typeface="Helvetica Neue"/>
+                <a:sym typeface="Helvetica Neue"/>
+              </a:rPr>
+              <a:t>1 Dissolve &amp; mail. Samples dissolved in acetonitrile and mailed to the lab in compliance with federal regulations. 2 Separate. Gas chromatography on a Thermo TraceGOLD TG-5SilMS column (30 m × 0.25 mm × 0.25 μm). 3 Detect. GCMS with an electron ionization source; qualitative results from a Thermo Scientific Q Exactive GC Orbitrap. 4 Identify. Untargeted search in Xcalibur Qual Browser 4.5, with fragmentation analysis against three libraries of drug standards. 5 Confirm. Every detected substance positively identified and confirmed with pure, commercially available reference standards. 6 Classify. Reported as primary or trace abundance — trace = less than 5% chromatogram peak height relative to the most abundant substance. Qualitative GCMS — abundance is not concentration · full protocol and library details in the Supplemental Material Static slide — reviewed by lab staff, not regenerated nightly</a:t>
+            </a:r>
+          </a:p>
+        </p:txBody>
+      </p:sp>
+      <p:sp>
+        <p:nvSpPr>
+          <p:cNvPr id="5" name=""/>
+          <p:cNvSpPr>
+            <a:spLocks noGrp="1"/>
+          </p:cNvSpPr>
+          <p:nvPr>
+            <p:ph/>
+          </p:nvPr>
+        </p:nvSpPr>
+        <p:spPr>
+          <a:xfrm>
             <a:off x="698500" y="6248400"/>
             <a:ext cx="10795000" cy="381000"/>
           </a:xfrm>
@@ -29011,6 +28454,55 @@
           <a:chExt cx="0" cy="0"/>
         </a:xfrm>
       </p:grpSpPr>
+      <p:sp>
+        <p:nvSpPr>
+          <p:cNvPr id="2" name=""/>
+          <p:cNvSpPr>
+            <a:spLocks noGrp="1"/>
+          </p:cNvSpPr>
+          <p:nvPr>
+            <p:ph/>
+          </p:nvPr>
+        </p:nvSpPr>
+        <p:spPr>
+          <a:xfrm>
+            <a:off x="698500" y="1511300"/>
+            <a:ext cx="10795000" cy="4584700"/>
+          </a:xfrm>
+        </p:spPr>
+        <p:txBody>
+          <a:bodyPr/>
+          <a:lstStyle/>
+          <a:p>
+            <a:pPr algn="l" marL="0" marR="0">
+              <a:lnSpc>
+                <a:spcPct val="100000"/>
+              </a:lnSpc>
+              <a:spcBef>
+                <a:spcPts val="0"/>
+              </a:spcBef>
+              <a:spcAft>
+                <a:spcPts val="0"/>
+              </a:spcAft>
+              <a:buNone/>
+            </a:pPr>
+            <a:r>
+              <a:rPr cap="none" sz="1400" i="0" b="0" u="none" strike="noStrike">
+                <a:solidFill>
+                  <a:srgbClr val="5B6770">
+                    <a:alpha val="100000"/>
+                  </a:srgbClr>
+                </a:solidFill>
+                <a:latin typeface="Helvetica Neue"/>
+                <a:cs typeface="Helvetica Neue"/>
+                <a:ea typeface="Helvetica Neue"/>
+                <a:sym typeface="Helvetica Neue"/>
+              </a:rPr>
+              <a:t>UNC Street Drug Analysis Lab OpioidData.org · results.streetsafe.supply Samples gathered by North Carolina harm reduction programs and analyzed by the UNC Opioid Data Lab. This brief regenerates nightly; cite the generation date on the title slide. Data and code released under CC0 1.0 (public domain dedication). Attribution is not required, but is requested: UNC Street Drug Analysis Lab · OpioidData.org.</a:t>
+            </a:r>
+          </a:p>
+        </p:txBody>
+      </p:sp>
     </p:spTree>
   </p:cSld>
   <p:clrMapOvr>
@@ -29137,6 +28629,55 @@
       <p:sp>
         <p:nvSpPr>
           <p:cNvPr id="4" name=""/>
+          <p:cNvSpPr>
+            <a:spLocks noGrp="1"/>
+          </p:cNvSpPr>
+          <p:nvPr>
+            <p:ph/>
+          </p:nvPr>
+        </p:nvSpPr>
+        <p:spPr>
+          <a:xfrm>
+            <a:off x="698500" y="1511300"/>
+            <a:ext cx="10795000" cy="4584700"/>
+          </a:xfrm>
+        </p:spPr>
+        <p:txBody>
+          <a:bodyPr/>
+          <a:lstStyle/>
+          <a:p>
+            <a:pPr algn="l" marL="0" marR="0">
+              <a:lnSpc>
+                <a:spcPct val="100000"/>
+              </a:lnSpc>
+              <a:spcBef>
+                <a:spcPts val="0"/>
+              </a:spcBef>
+              <a:spcAft>
+                <a:spcPts val="0"/>
+              </a:spcAft>
+              <a:buNone/>
+            </a:pPr>
+            <a:r>
+              <a:rPr cap="none" sz="1400" i="0" b="0" u="none" strike="noStrike">
+                <a:solidFill>
+                  <a:srgbClr val="5B6770">
+                    <a:alpha val="100000"/>
+                  </a:srgbClr>
+                </a:solidFill>
+                <a:latin typeface="Helvetica Neue"/>
+                <a:cs typeface="Helvetica Neue"/>
+                <a:ea typeface="Helvetica Neue"/>
+                <a:sym typeface="Helvetica Neue"/>
+              </a:rPr>
+              <a:t>analysis_dataset.csv Wide · one row per sample. Everything from the card — location, dates, expected substance, sensations, overdose involvement — plus ~60 derived lab_* 1/0 flags. 96 variables · quarterly denominators come from here data.streetsafe.supply/datasets/NC/analysis_dataset.csv sampleid ⟷ lab_detail.csv Long · one row per substance per sample. Standardized substance name, method (GCMS), abundance (blank = primary, "trace"), chemical-class flags, PubChem CID / CAS / UNII. Source for substance-level counts and new detections data.streetsafe.supply/datasets/NC/lab_detail.csv Direct downloads above · refreshed daily · also in Stata, Excel, SAS at data.streetsafe.supply/datasets/NC/ r/data.R::load_nc()</a:t>
+            </a:r>
+          </a:p>
+        </p:txBody>
+      </p:sp>
+      <p:sp>
+        <p:nvSpPr>
+          <p:cNvPr id="5" name=""/>
           <p:cNvSpPr>
             <a:spLocks noGrp="1"/>
           </p:cNvSpPr>
@@ -29318,6 +28859,55 @@
         </p:nvSpPr>
         <p:spPr>
           <a:xfrm>
+            <a:off x="698500" y="1511300"/>
+            <a:ext cx="10795000" cy="4584700"/>
+          </a:xfrm>
+        </p:spPr>
+        <p:txBody>
+          <a:bodyPr/>
+          <a:lstStyle/>
+          <a:p>
+            <a:pPr algn="l" marL="0" marR="0">
+              <a:lnSpc>
+                <a:spcPct val="100000"/>
+              </a:lnSpc>
+              <a:spcBef>
+                <a:spcPts val="0"/>
+              </a:spcBef>
+              <a:spcAft>
+                <a:spcPts val="0"/>
+              </a:spcAft>
+              <a:buNone/>
+            </a:pPr>
+            <a:r>
+              <a:rPr cap="none" sz="1400" i="0" b="0" u="none" strike="noStrike">
+                <a:solidFill>
+                  <a:srgbClr val="5B6770">
+                    <a:alpha val="100000"/>
+                  </a:srgbClr>
+                </a:solidFill>
+                <a:latin typeface="Helvetica Neue"/>
+                <a:cs typeface="Helvetica Neue"/>
+                <a:ea typeface="Helvetica Neue"/>
+                <a:sym typeface="Helvetica Neue"/>
+              </a:rPr>
+              <a:t>lab_xylazine = 1 Detected as a primary constituent lab_xylazine_any = 1 Detected in any abundance — primary or trace trace-only = any − primary The light-blue increment stacked on every chart Example sample A powder sample contains xylazine in trace abundance: lab_xylazine = 0 lab_xylazine_any = 1 Trace defined as less than 5% peak height of the most abundant molecule on the GCMS chromatogram. Abundance is qualitative — trace ≠ quantified concentration and never implies purity. Convention documented in technical_details.md · every following chart is stacked primary + trace-only r/data.R::quarterly_rate()</a:t>
+            </a:r>
+          </a:p>
+        </p:txBody>
+      </p:sp>
+      <p:sp>
+        <p:nvSpPr>
+          <p:cNvPr id="5" name=""/>
+          <p:cNvSpPr>
+            <a:spLocks noGrp="1"/>
+          </p:cNvSpPr>
+          <p:nvPr>
+            <p:ph/>
+          </p:nvPr>
+        </p:nvSpPr>
+        <p:spPr>
+          <a:xfrm>
             <a:off x="698500" y="6248400"/>
             <a:ext cx="10795000" cy="381000"/>
           </a:xfrm>
@@ -29481,6 +29071,55 @@
       <p:sp>
         <p:nvSpPr>
           <p:cNvPr id="4" name=""/>
+          <p:cNvSpPr>
+            <a:spLocks noGrp="1"/>
+          </p:cNvSpPr>
+          <p:nvPr>
+            <p:ph/>
+          </p:nvPr>
+        </p:nvSpPr>
+        <p:spPr>
+          <a:xfrm>
+            <a:off x="698500" y="1511300"/>
+            <a:ext cx="10795000" cy="4584700"/>
+          </a:xfrm>
+        </p:spPr>
+        <p:txBody>
+          <a:bodyPr/>
+          <a:lstStyle/>
+          <a:p>
+            <a:pPr algn="l" marL="0" marR="0">
+              <a:lnSpc>
+                <a:spcPct val="100000"/>
+              </a:lnSpc>
+              <a:spcBef>
+                <a:spcPts val="0"/>
+              </a:spcBef>
+              <a:spcAft>
+                <a:spcPts val="0"/>
+              </a:spcAft>
+              <a:buNone/>
+            </a:pPr>
+            <a:r>
+              <a:rPr cap="none" sz="1400" i="0" b="0" u="none" strike="noStrike">
+                <a:solidFill>
+                  <a:srgbClr val="5B6770">
+                    <a:alpha val="100000"/>
+                  </a:srgbClr>
+                </a:solidFill>
+                <a:latin typeface="Helvetica Neue"/>
+                <a:cs typeface="Helvetica Neue"/>
+                <a:ea typeface="Helvetica Neue"/>
+                <a:sym typeface="Helvetica Neue"/>
+              </a:rPr>
+              <a:t>This deck conforms to WCAG 2.2 Level AA, the level required by UNC's Accessibility of Digital Content and Materials Standard and ADA Title II. · Contrast-checked palette — text ≥ 4.5:1, chart marks ≥ 3:1 · Alt text regenerates nightly with each figure, from the same data · Full data tables for key charts in the Appendix (end of deck) · No color-only encoding — segments labeled directly, partial quarters striped · Logical heading structure and reading order on every slide Found a barrier? Report it to the UNC Digital Accessibility Office: digital_accessibility@unc.edu digitalaccessibility.unc.edu/report 919-962-7636 Static slide — reviewed by lab staff, not regenerated nightly</a:t>
+            </a:r>
+          </a:p>
+        </p:txBody>
+      </p:sp>
+      <p:sp>
+        <p:nvSpPr>
+          <p:cNvPr id="5" name=""/>
           <p:cNvSpPr>
             <a:spLocks noGrp="1"/>
           </p:cNvSpPr>

</xml_diff>

<commit_message>
nightly deck: data through 2026-08-27
</commit_message>
<xml_diff>
--- a/docs/nc-drug-checking-latest.pptx
+++ b/docs/nc-drug-checking-latest.pptx
@@ -2418,7 +2418,7 @@
                 <a:ea typeface="Helvetica Neue"/>
                 <a:sym typeface="Helvetica Neue"/>
               </a:rPr>
-              <a:t>Generated Wednesday, August 26, 2026 · 5:38 PM ET UNC Street Drug Analysis Lab · OpioidData.org · results.streetsafe.supply Download as PowerPoint</a:t>
+              <a:t>Generated Thursday, August 27, 2026 · 2:22 PM ET UNC Street Drug Analysis Lab · OpioidData.org · results.streetsafe.supply Download as PowerPoint</a:t>
             </a:r>
           </a:p>
         </p:txBody>
@@ -2713,7 +2713,7 @@
                 <a:ea typeface="Helvetica Neue"/>
                 <a:sym typeface="Helvetica Neue"/>
               </a:rPr>
-              <a:t>PLACEHOLDER · figs/stats.json January 2022 to Wednesday, August 26, 2026 N = 2,767 NC samples analyzed Mailed in from 86 harm reduction programs Collected across 57 counties 243 distinct substances detected to date Unique samples = n_distinct(sampleid) · substances from lab_detail.substance · includes samples with date_complete 26 Jan 2022 – 26 Aug 2026 r/build_nightly.R → figs/stats.json</a:t>
+              <a:t>PLACEHOLDER · figs/stats.json January 2022 to Thursday, August 27, 2026 N = 2,775 NC samples analyzed Mailed in from 86 harm reduction programs Collected across 57 counties 243 distinct substances detected to date Unique samples = n_distinct(sampleid) · substances from lab_detail.substance · includes samples with date_complete 26 Jan 2022 – 27 Aug 2026 r/build_nightly.R → figs/stats.json</a:t>
             </a:r>
           </a:p>
         </p:txBody>
@@ -2762,7 +2762,7 @@
                 <a:ea typeface="Helvetica Neue"/>
                 <a:sym typeface="Helvetica Neue"/>
               </a:rPr>
-              <a:t>Unique samples = n_distinct(sampleid) · substances from lab_detail.substance · includes samples with date_complete 26 Jan 2022 – 26 Aug 2026</a:t>
+              <a:t>Unique samples = n_distinct(sampleid) · substances from lab_detail.substance · includes samples with date_complete 26 Jan 2022 – 27 Aug 2026</a:t>
             </a:r>
           </a:p>
         </p:txBody>
@@ -3184,7 +3184,7 @@
                 <a:ea typeface="Helvetica Neue"/>
                 <a:sym typeface="Helvetica Neue"/>
               </a:rPr>
-              <a:t>County = samplecounty · left: ≥1 completed analysis ever · right: unique samples per county (sqrt color scale) · all time: 26 Jan 2022 – 26 Aug 2026 · last 12 months: 26 Aug 2025 – 26 Aug 2026* · coverage reflects participation, not prevalence</a:t>
+              <a:t>County = samplecounty · left: ≥1 completed analysis ever · right: unique samples per county (sqrt color scale) · all time: 26 Jan 2022 – 27 Aug 2026 · last 12 months: 27 Aug 2025 – 27 Aug 2026* · coverage reflects participation, not prevalence</a:t>
             </a:r>
           </a:p>
         </p:txBody>
@@ -3505,7 +3505,7 @@
                 <a:ea typeface="Helvetica Neue"/>
                 <a:sym typeface="Helvetica Neue"/>
               </a:rPr>
-              <a:t>expectedsubstance (verbatim card write-in, semicolon lists split) · derived flags: expect_opioid, expect_fentanyl, expect_meth, expect_cocaine, expect_stimulant… · includes samples with date_complete 26 Jan 2022 – 26 Aug 2026 · data table: Appendix A2</a:t>
+              <a:t>expectedsubstance (verbatim card write-in, semicolon lists split) · derived flags: expect_opioid, expect_fentanyl, expect_meth, expect_cocaine, expect_stimulant… · includes samples with date_complete 26 Jan 2022 – 27 Aug 2026 · data table: Appendix A2</a:t>
             </a:r>
           </a:p>
         </p:txBody>
@@ -3703,7 +3703,7 @@
                 <a:ea typeface="Helvetica Neue"/>
                 <a:sym typeface="Helvetica Neue"/>
               </a:rPr>
-              <a:t>Numerator uses lab_*_any (primary or trace) among samples with expect_* = 1 · includes samples with date_complete 26 Jan 2022 – 26 Aug 2026 · data table: Appendix A3</a:t>
+              <a:t>Numerator uses lab_*_any (primary or trace) among samples with expect_* = 1 · includes samples with date_complete 26 Jan 2022 – 27 Aug 2026 · data table: Appendix A3</a:t>
             </a:r>
           </a:p>
         </p:txBody>
@@ -3901,7 +3901,7 @@
                 <a:ea typeface="Helvetica Neue"/>
                 <a:sym typeface="Helvetica Neue"/>
               </a:rPr>
-              <a:t>sensations (circled on card, semicolon lists split) · post-consumption samples only (consumed = 1) · includes samples with date_complete 26 Jan 2022 – 26 Aug 2026</a:t>
+              <a:t>sensations (circled on card, semicolon lists split) · post-consumption samples only (consumed = 1) · includes samples with date_complete 26 Jan 2022 – 27 Aug 2026</a:t>
             </a:r>
           </a:p>
         </p:txBody>
@@ -4125,7 +4125,7 @@
                 <a:ea typeface="Helvetica Neue"/>
                 <a:sym typeface="Helvetica Neue"/>
               </a:rPr>
-              <a:t>sensations semicolon lists parsed per report · consumed = 1 only · denominator: consumed samples with lab_*_any = 1 · includes samples with date_complete 26 Jan 2022 – 26 Aug 2026</a:t>
+              <a:t>sensations semicolon lists parsed per report · consumed = 1 only · denominator: consumed samples with lab_*_any = 1 · includes samples with date_complete 26 Jan 2022 – 27 Aug 2026</a:t>
             </a:r>
           </a:p>
         </p:txBody>
@@ -4323,7 +4323,7 @@
                 <a:ea typeface="Helvetica Neue"/>
                 <a:sym typeface="Helvetica Neue"/>
               </a:rPr>
-              <a:t>Samples with methamphetamine or cocaine detected (any abundance); samples in both classes appear on both slides · sensations semicolon lists parsed + sen_strength (own denominator) · consumed = 1 only · before: 26 Jan 2022 – 26 Aug 2025 · past 12 months: 26 Aug 2025 – 26 Aug 2026* · Δ in percentage points</a:t>
+              <a:t>Samples with methamphetamine or cocaine detected (any abundance); samples in both classes appear on both slides · sensations semicolon lists parsed + sen_strength (own denominator) · consumed = 1 only · before: 26 Jan 2022 – 27 Aug 2025 · past 12 months: 27 Aug 2025 – 27 Aug 2026* · Δ in percentage points</a:t>
             </a:r>
           </a:p>
         </p:txBody>
@@ -4742,7 +4742,7 @@
                 <a:ea typeface="Helvetica Neue"/>
                 <a:sym typeface="Helvetica Neue"/>
               </a:rPr>
-              <a:t>Samples with an opioid (fentanyl, heroin) or benzodiazepine detected (any abundance); samples in both classes appear on both slides · sensations semicolon lists parsed + sen_strength (own denominator) · consumed = 1 only · before: 26 Jan 2022 – 26 Aug 2025 · past 12 months: 26 Aug 2025 – 26 Aug 2026* · Δ in percentage points</a:t>
+              <a:t>Samples with an opioid (fentanyl, heroin) or benzodiazepine detected (any abundance); samples in both classes appear on both slides · sensations semicolon lists parsed + sen_strength (own denominator) · consumed = 1 only · before: 26 Jan 2022 – 27 Aug 2025 · past 12 months: 27 Aug 2025 – 27 Aug 2026* · Δ in percentage points</a:t>
             </a:r>
           </a:p>
         </p:txBody>
@@ -5138,7 +5138,7 @@
                 <a:ea typeface="Helvetica Neue"/>
                 <a:sym typeface="Helvetica Neue"/>
               </a:rPr>
-              <a:t>color, texture (card v3+, semicolon lists split) · derived: bright_color excludes white/tan/brown family — orange bar above · includes samples with date_complete 26 Jan 2022 – 26 Aug 2026</a:t>
+              <a:t>color, texture (card v3+, semicolon lists split) · derived: bright_color excludes white/tan/brown family — orange bar above · includes samples with date_complete 26 Jan 2022 – 27 Aug 2026</a:t>
             </a:r>
           </a:p>
         </p:txBody>
@@ -5459,7 +5459,7 @@
                 <a:ea typeface="Helvetica Neue"/>
                 <a:sym typeface="Helvetica Neue"/>
               </a:rPr>
-              <a:t>Distribution of substances detected per sample, both definitions shown side by side · includes samples with date_complete 26 Jan 2022 – 26 Aug 2026</a:t>
+              <a:t>Distribution of substances detected per sample, both definitions shown side by side · includes samples with date_complete 26 Jan 2022 – 27 Aug 2026</a:t>
             </a:r>
           </a:p>
         </p:txBody>
@@ -5657,7 +5657,7 @@
                 <a:ea typeface="Helvetica Neue"/>
                 <a:sym typeface="Helvetica Neue"/>
               </a:rPr>
-              <a:t>lab_detail.substance counts · solid = primary abundance, light = trace · standardized names (PubChem-linked) · includes samples with date_complete 26 Jan 2022 – 26 Aug 2026</a:t>
+              <a:t>lab_detail.substance counts · solid = primary abundance, light = trace · standardized names (PubChem-linked) · includes samples with date_complete 26 Jan 2022 – 27 Aug 2026</a:t>
             </a:r>
           </a:p>
         </p:txBody>
@@ -5855,7 +5855,7 @@
                 <a:ea typeface="Helvetica Neue"/>
                 <a:sym typeface="Helvetica Neue"/>
               </a:rPr>
-              <a:t>lab_detail.substance counts · solid = primary abundance, light = trace · standardized names (PubChem-linked) · window: date_complete 26 Aug 2025 – 26 Aug 2026* (trailing 12 months, current month partial)</a:t>
+              <a:t>lab_detail.substance counts · solid = primary abundance, light = trace · standardized names (PubChem-linked) · window: date_complete 27 Aug 2025 – 27 Aug 2026* (trailing 12 months, current month partial)</a:t>
             </a:r>
           </a:p>
         </p:txBody>
@@ -6053,7 +6053,7 @@
                 <a:ea typeface="Helvetica Neue"/>
                 <a:sym typeface="Helvetica Neue"/>
               </a:rPr>
-              <a:t>Distribution of substances detected per sample, both definitions shown side by side · window: date_complete 26 Aug 2025 – 26 Aug 2026* (trailing 12 months, current month partial)</a:t>
+              <a:t>Distribution of substances detected per sample, both definitions shown side by side · window: date_complete 27 Aug 2025 – 27 Aug 2026* (trailing 12 months, current month partial)</a:t>
             </a:r>
           </a:p>
         </p:txBody>
@@ -18510,7 +18510,7 @@
                           <a:ea typeface="Helvetica Neue"/>
                           <a:sym typeface="Helvetica Neue"/>
                         </a:rPr>
-                        <a:t>1,412</a:t>
+                        <a:t>1,416</a:t>
                       </a:r>
                     </a:p>
                   </a:txBody>
@@ -18626,7 +18626,7 @@
                           <a:ea typeface="Helvetica Neue"/>
                           <a:sym typeface="Helvetica Neue"/>
                         </a:rPr>
-                        <a:t>428</a:t>
+                        <a:t>432</a:t>
                       </a:r>
                     </a:p>
                   </a:txBody>
@@ -20591,7 +20591,7 @@
                           <a:ea typeface="Helvetica Neue"/>
                           <a:sym typeface="Helvetica Neue"/>
                         </a:rPr>
-                        <a:t>1,620</a:t>
+                        <a:t>1,624</a:t>
                       </a:r>
                     </a:p>
                   </a:txBody>
@@ -20821,7 +20821,7 @@
                           <a:ea typeface="Helvetica Neue"/>
                           <a:sym typeface="Helvetica Neue"/>
                         </a:rPr>
-                        <a:t>491</a:t>
+                        <a:t>495</a:t>
                       </a:r>
                     </a:p>
                   </a:txBody>
@@ -20878,7 +20878,7 @@
                           <a:ea typeface="Helvetica Neue"/>
                           <a:sym typeface="Helvetica Neue"/>
                         </a:rPr>
-                        <a:t>90%</a:t>
+                        <a:t>91%</a:t>
                       </a:r>
                     </a:p>
                   </a:txBody>

</xml_diff>

<commit_message>
nightly deck: data through 2026-08-28
</commit_message>
<xml_diff>
--- a/docs/nc-drug-checking-latest.pptx
+++ b/docs/nc-drug-checking-latest.pptx
@@ -2418,7 +2418,7 @@
                 <a:ea typeface="Helvetica Neue"/>
                 <a:sym typeface="Helvetica Neue"/>
               </a:rPr>
-              <a:t>Generated Thursday, August 27, 2026 · 2:22 PM ET UNC Street Drug Analysis Lab · OpioidData.org · results.streetsafe.supply Download as PowerPoint</a:t>
+              <a:t>Generated Friday, August 28, 2026 · 3:31 PM ET UNC Street Drug Analysis Lab · OpioidData.org · results.streetsafe.supply Download as PowerPoint</a:t>
             </a:r>
           </a:p>
         </p:txBody>
@@ -3184,7 +3184,7 @@
                 <a:ea typeface="Helvetica Neue"/>
                 <a:sym typeface="Helvetica Neue"/>
               </a:rPr>
-              <a:t>County = samplecounty · left: ≥1 completed analysis ever · right: unique samples per county (sqrt color scale) · all time: 26 Jan 2022 – 27 Aug 2026 · last 12 months: 27 Aug 2025 – 27 Aug 2026* · coverage reflects participation, not prevalence</a:t>
+              <a:t>County = samplecounty · left: ≥1 completed analysis ever · right: unique samples per county (sqrt color scale) · all time: 26 Jan 2022 – 27 Aug 2026 · last 12 months: 28 Aug 2025 – 27 Aug 2026* · coverage reflects participation, not prevalence</a:t>
             </a:r>
           </a:p>
         </p:txBody>
@@ -4323,7 +4323,7 @@
                 <a:ea typeface="Helvetica Neue"/>
                 <a:sym typeface="Helvetica Neue"/>
               </a:rPr>
-              <a:t>Samples with methamphetamine or cocaine detected (any abundance); samples in both classes appear on both slides · sensations semicolon lists parsed + sen_strength (own denominator) · consumed = 1 only · before: 26 Jan 2022 – 27 Aug 2025 · past 12 months: 27 Aug 2025 – 27 Aug 2026* · Δ in percentage points</a:t>
+              <a:t>Samples with methamphetamine or cocaine detected (any abundance); samples in both classes appear on both slides · sensations semicolon lists parsed + sen_strength (own denominator) · consumed = 1 only · before: 26 Jan 2022 – 27 Aug 2025 · past 12 months: 28 Aug 2025 – 27 Aug 2026* · Δ in percentage points</a:t>
             </a:r>
           </a:p>
         </p:txBody>
@@ -4742,7 +4742,7 @@
                 <a:ea typeface="Helvetica Neue"/>
                 <a:sym typeface="Helvetica Neue"/>
               </a:rPr>
-              <a:t>Samples with an opioid (fentanyl, heroin) or benzodiazepine detected (any abundance); samples in both classes appear on both slides · sensations semicolon lists parsed + sen_strength (own denominator) · consumed = 1 only · before: 26 Jan 2022 – 27 Aug 2025 · past 12 months: 27 Aug 2025 – 27 Aug 2026* · Δ in percentage points</a:t>
+              <a:t>Samples with an opioid (fentanyl, heroin) or benzodiazepine detected (any abundance); samples in both classes appear on both slides · sensations semicolon lists parsed + sen_strength (own denominator) · consumed = 1 only · before: 26 Jan 2022 – 27 Aug 2025 · past 12 months: 28 Aug 2025 – 27 Aug 2026* · Δ in percentage points</a:t>
             </a:r>
           </a:p>
         </p:txBody>
@@ -5855,7 +5855,7 @@
                 <a:ea typeface="Helvetica Neue"/>
                 <a:sym typeface="Helvetica Neue"/>
               </a:rPr>
-              <a:t>lab_detail.substance counts · solid = primary abundance, light = trace · standardized names (PubChem-linked) · window: date_complete 27 Aug 2025 – 27 Aug 2026* (trailing 12 months, current month partial)</a:t>
+              <a:t>lab_detail.substance counts · solid = primary abundance, light = trace · standardized names (PubChem-linked) · window: date_complete 28 Aug 2025 – 27 Aug 2026* (trailing 12 months, current month partial)</a:t>
             </a:r>
           </a:p>
         </p:txBody>
@@ -6053,7 +6053,7 @@
                 <a:ea typeface="Helvetica Neue"/>
                 <a:sym typeface="Helvetica Neue"/>
               </a:rPr>
-              <a:t>Distribution of substances detected per sample, both definitions shown side by side · window: date_complete 27 Aug 2025 – 27 Aug 2026* (trailing 12 months, current month partial)</a:t>
+              <a:t>Distribution of substances detected per sample, both definitions shown side by side · window: date_complete 28 Aug 2025 – 27 Aug 2026* (trailing 12 months, current month partial)</a:t>
             </a:r>
           </a:p>
         </p:txBody>
@@ -13803,7 +13803,7 @@
                           <a:ea typeface="Helvetica Neue"/>
                           <a:sym typeface="Helvetica Neue"/>
                         </a:rPr>
-                        <a:t>18</a:t>
+                        <a:t>19</a:t>
                       </a:r>
                     </a:p>
                   </a:txBody>
@@ -27696,7 +27696,7 @@
                           <a:ea typeface="Helvetica Neue"/>
                           <a:sym typeface="Helvetica Neue"/>
                         </a:rPr>
-                        <a:t>18</a:t>
+                        <a:t>19</a:t>
                       </a:r>
                     </a:p>
                   </a:txBody>

</xml_diff>

<commit_message>
nightly deck: data through 2026-08-29
</commit_message>
<xml_diff>
--- a/docs/nc-drug-checking-latest.pptx
+++ b/docs/nc-drug-checking-latest.pptx
@@ -2418,7 +2418,7 @@
                 <a:ea typeface="Helvetica Neue"/>
                 <a:sym typeface="Helvetica Neue"/>
               </a:rPr>
-              <a:t>Generated Friday, August 28, 2026 · 3:31 PM ET UNC Street Drug Analysis Lab · OpioidData.org · results.streetsafe.supply Download as PowerPoint</a:t>
+              <a:t>Generated Saturday, August 29, 2026 · 9:16 AM ET UNC Street Drug Analysis Lab · OpioidData.org · results.streetsafe.supply Download as PowerPoint</a:t>
             </a:r>
           </a:p>
         </p:txBody>
@@ -3184,7 +3184,7 @@
                 <a:ea typeface="Helvetica Neue"/>
                 <a:sym typeface="Helvetica Neue"/>
               </a:rPr>
-              <a:t>County = samplecounty · left: ≥1 completed analysis ever · right: unique samples per county (sqrt color scale) · all time: 26 Jan 2022 – 27 Aug 2026 · last 12 months: 28 Aug 2025 – 27 Aug 2026* · coverage reflects participation, not prevalence</a:t>
+              <a:t>County = samplecounty · left: ≥1 completed analysis ever · right: unique samples per county (sqrt color scale) · all time: 26 Jan 2022 – 27 Aug 2026 · last 12 months: 29 Aug 2025 – 27 Aug 2026* · coverage reflects participation, not prevalence</a:t>
             </a:r>
           </a:p>
         </p:txBody>
@@ -4323,7 +4323,7 @@
                 <a:ea typeface="Helvetica Neue"/>
                 <a:sym typeface="Helvetica Neue"/>
               </a:rPr>
-              <a:t>Samples with methamphetamine or cocaine detected (any abundance); samples in both classes appear on both slides · sensations semicolon lists parsed + sen_strength (own denominator) · consumed = 1 only · before: 26 Jan 2022 – 27 Aug 2025 · past 12 months: 28 Aug 2025 – 27 Aug 2026* · Δ in percentage points</a:t>
+              <a:t>Samples with methamphetamine or cocaine detected (any abundance); samples in both classes appear on both slides · sensations semicolon lists parsed + sen_strength (own denominator) · consumed = 1 only · before: 26 Jan 2022 – 27 Aug 2025 · past 12 months: 29 Aug 2025 – 27 Aug 2026* · Δ in percentage points</a:t>
             </a:r>
           </a:p>
         </p:txBody>
@@ -4742,7 +4742,7 @@
                 <a:ea typeface="Helvetica Neue"/>
                 <a:sym typeface="Helvetica Neue"/>
               </a:rPr>
-              <a:t>Samples with an opioid (fentanyl, heroin) or benzodiazepine detected (any abundance); samples in both classes appear on both slides · sensations semicolon lists parsed + sen_strength (own denominator) · consumed = 1 only · before: 26 Jan 2022 – 27 Aug 2025 · past 12 months: 28 Aug 2025 – 27 Aug 2026* · Δ in percentage points</a:t>
+              <a:t>Samples with an opioid (fentanyl, heroin) or benzodiazepine detected (any abundance); samples in both classes appear on both slides · sensations semicolon lists parsed + sen_strength (own denominator) · consumed = 1 only · before: 26 Jan 2022 – 27 Aug 2025 · past 12 months: 29 Aug 2025 – 27 Aug 2026* · Δ in percentage points</a:t>
             </a:r>
           </a:p>
         </p:txBody>
@@ -5855,7 +5855,7 @@
                 <a:ea typeface="Helvetica Neue"/>
                 <a:sym typeface="Helvetica Neue"/>
               </a:rPr>
-              <a:t>lab_detail.substance counts · solid = primary abundance, light = trace · standardized names (PubChem-linked) · window: date_complete 28 Aug 2025 – 27 Aug 2026* (trailing 12 months, current month partial)</a:t>
+              <a:t>lab_detail.substance counts · solid = primary abundance, light = trace · standardized names (PubChem-linked) · window: date_complete 29 Aug 2025 – 27 Aug 2026* (trailing 12 months, current month partial)</a:t>
             </a:r>
           </a:p>
         </p:txBody>
@@ -6053,7 +6053,7 @@
                 <a:ea typeface="Helvetica Neue"/>
                 <a:sym typeface="Helvetica Neue"/>
               </a:rPr>
-              <a:t>Distribution of substances detected per sample, both definitions shown side by side · window: date_complete 28 Aug 2025 – 27 Aug 2026* (trailing 12 months, current month partial)</a:t>
+              <a:t>Distribution of substances detected per sample, both definitions shown side by side · window: date_complete 29 Aug 2025 – 27 Aug 2026* (trailing 12 months, current month partial)</a:t>
             </a:r>
           </a:p>
         </p:txBody>

</xml_diff>

<commit_message>
nightly deck: data through 2026-08-30
</commit_message>
<xml_diff>
--- a/docs/nc-drug-checking-latest.pptx
+++ b/docs/nc-drug-checking-latest.pptx
@@ -2418,7 +2418,7 @@
                 <a:ea typeface="Helvetica Neue"/>
                 <a:sym typeface="Helvetica Neue"/>
               </a:rPr>
-              <a:t>Generated Saturday, August 29, 2026 · 9:16 AM ET UNC Street Drug Analysis Lab · OpioidData.org · results.streetsafe.supply Download as PowerPoint</a:t>
+              <a:t>Generated Sunday, August 30, 2026 · 9:04 AM ET UNC Street Drug Analysis Lab · OpioidData.org · results.streetsafe.supply Download as PowerPoint</a:t>
             </a:r>
           </a:p>
         </p:txBody>
@@ -3184,7 +3184,7 @@
                 <a:ea typeface="Helvetica Neue"/>
                 <a:sym typeface="Helvetica Neue"/>
               </a:rPr>
-              <a:t>County = samplecounty · left: ≥1 completed analysis ever · right: unique samples per county (sqrt color scale) · all time: 26 Jan 2022 – 27 Aug 2026 · last 12 months: 29 Aug 2025 – 27 Aug 2026* · coverage reflects participation, not prevalence</a:t>
+              <a:t>County = samplecounty · left: ≥1 completed analysis ever · right: unique samples per county (sqrt color scale) · all time: 26 Jan 2022 – 27 Aug 2026 · last 12 months: 30 Aug 2025 – 27 Aug 2026* · coverage reflects participation, not prevalence</a:t>
             </a:r>
           </a:p>
         </p:txBody>
@@ -4323,7 +4323,7 @@
                 <a:ea typeface="Helvetica Neue"/>
                 <a:sym typeface="Helvetica Neue"/>
               </a:rPr>
-              <a:t>Samples with methamphetamine or cocaine detected (any abundance); samples in both classes appear on both slides · sensations semicolon lists parsed + sen_strength (own denominator) · consumed = 1 only · before: 26 Jan 2022 – 27 Aug 2025 · past 12 months: 29 Aug 2025 – 27 Aug 2026* · Δ in percentage points</a:t>
+              <a:t>Samples with methamphetamine or cocaine detected (any abundance); samples in both classes appear on both slides · sensations semicolon lists parsed + sen_strength (own denominator) · consumed = 1 only · before: 26 Jan 2022 – 27 Aug 2025 · past 12 months: 30 Aug 2025 – 27 Aug 2026* · Δ in percentage points</a:t>
             </a:r>
           </a:p>
         </p:txBody>
@@ -4742,7 +4742,7 @@
                 <a:ea typeface="Helvetica Neue"/>
                 <a:sym typeface="Helvetica Neue"/>
               </a:rPr>
-              <a:t>Samples with an opioid (fentanyl, heroin) or benzodiazepine detected (any abundance); samples in both classes appear on both slides · sensations semicolon lists parsed + sen_strength (own denominator) · consumed = 1 only · before: 26 Jan 2022 – 27 Aug 2025 · past 12 months: 29 Aug 2025 – 27 Aug 2026* · Δ in percentage points</a:t>
+              <a:t>Samples with an opioid (fentanyl, heroin) or benzodiazepine detected (any abundance); samples in both classes appear on both slides · sensations semicolon lists parsed + sen_strength (own denominator) · consumed = 1 only · before: 26 Jan 2022 – 27 Aug 2025 · past 12 months: 30 Aug 2025 – 27 Aug 2026* · Δ in percentage points</a:t>
             </a:r>
           </a:p>
         </p:txBody>
@@ -5855,7 +5855,7 @@
                 <a:ea typeface="Helvetica Neue"/>
                 <a:sym typeface="Helvetica Neue"/>
               </a:rPr>
-              <a:t>lab_detail.substance counts · solid = primary abundance, light = trace · standardized names (PubChem-linked) · window: date_complete 29 Aug 2025 – 27 Aug 2026* (trailing 12 months, current month partial)</a:t>
+              <a:t>lab_detail.substance counts · solid = primary abundance, light = trace · standardized names (PubChem-linked) · window: date_complete 30 Aug 2025 – 27 Aug 2026* (trailing 12 months, current month partial)</a:t>
             </a:r>
           </a:p>
         </p:txBody>
@@ -6053,7 +6053,7 @@
                 <a:ea typeface="Helvetica Neue"/>
                 <a:sym typeface="Helvetica Neue"/>
               </a:rPr>
-              <a:t>Distribution of substances detected per sample, both definitions shown side by side · window: date_complete 29 Aug 2025 – 27 Aug 2026* (trailing 12 months, current month partial)</a:t>
+              <a:t>Distribution of substances detected per sample, both definitions shown side by side · window: date_complete 30 Aug 2025 – 27 Aug 2026* (trailing 12 months, current month partial)</a:t>
             </a:r>
           </a:p>
         </p:txBody>

</xml_diff>

<commit_message>
nightly deck: data through 2026-09-01
</commit_message>
<xml_diff>
--- a/docs/nc-drug-checking-latest.pptx
+++ b/docs/nc-drug-checking-latest.pptx
@@ -2418,7 +2418,7 @@
                 <a:ea typeface="Helvetica Neue"/>
                 <a:sym typeface="Helvetica Neue"/>
               </a:rPr>
-              <a:t>Generated Monday, August 31, 2026 · 11:15 AM ET UNC Street Drug Analysis Lab · OpioidData.org · results.streetsafe.supply Download as PowerPoint</a:t>
+              <a:t>Generated Tuesday, September 01, 2026 · 8:39 AM ET UNC Street Drug Analysis Lab · OpioidData.org · results.streetsafe.supply Download as PowerPoint</a:t>
             </a:r>
           </a:p>
         </p:txBody>
@@ -3184,7 +3184,7 @@
                 <a:ea typeface="Helvetica Neue"/>
                 <a:sym typeface="Helvetica Neue"/>
               </a:rPr>
-              <a:t>County = samplecounty · left: ≥1 completed analysis ever · right: unique samples per county (sqrt color scale) · all time: 26 Jan 2022 – 27 Aug 2026 · last 12 months: 31 Aug 2025 – 27 Aug 2026* · coverage reflects participation, not prevalence</a:t>
+              <a:t>County = samplecounty · left: ≥1 completed analysis ever · right: unique samples per county (sqrt color scale) · all time: 26 Jan 2022 – 27 Aug 2026 · last 12 months: 01 Sep 2025 – 27 Aug 2026* · coverage reflects participation, not prevalence</a:t>
             </a:r>
           </a:p>
         </p:txBody>
@@ -4323,7 +4323,7 @@
                 <a:ea typeface="Helvetica Neue"/>
                 <a:sym typeface="Helvetica Neue"/>
               </a:rPr>
-              <a:t>Samples with methamphetamine or cocaine detected (any abundance); samples in both classes appear on both slides · sensations semicolon lists parsed + sen_strength (own denominator) · consumed = 1 only · before: 26 Jan 2022 – 27 Aug 2025 · past 12 months: 31 Aug 2025 – 27 Aug 2026* · Δ in percentage points</a:t>
+              <a:t>Samples with methamphetamine or cocaine detected (any abundance); samples in both classes appear on both slides · sensations semicolon lists parsed + sen_strength (own denominator) · consumed = 1 only · before: 26 Jan 2022 – 27 Aug 2025 · past 12 months: 01 Sep 2025 – 27 Aug 2026* · Δ in percentage points</a:t>
             </a:r>
           </a:p>
         </p:txBody>
@@ -4742,7 +4742,7 @@
                 <a:ea typeface="Helvetica Neue"/>
                 <a:sym typeface="Helvetica Neue"/>
               </a:rPr>
-              <a:t>Samples with an opioid (fentanyl, heroin) or benzodiazepine detected (any abundance); samples in both classes appear on both slides · sensations semicolon lists parsed + sen_strength (own denominator) · consumed = 1 only · before: 26 Jan 2022 – 27 Aug 2025 · past 12 months: 31 Aug 2025 – 27 Aug 2026* · Δ in percentage points</a:t>
+              <a:t>Samples with an opioid (fentanyl, heroin) or benzodiazepine detected (any abundance); samples in both classes appear on both slides · sensations semicolon lists parsed + sen_strength (own denominator) · consumed = 1 only · before: 26 Jan 2022 – 27 Aug 2025 · past 12 months: 01 Sep 2025 – 27 Aug 2026* · Δ in percentage points</a:t>
             </a:r>
           </a:p>
         </p:txBody>
@@ -5855,7 +5855,7 @@
                 <a:ea typeface="Helvetica Neue"/>
                 <a:sym typeface="Helvetica Neue"/>
               </a:rPr>
-              <a:t>lab_detail.substance counts · solid = primary abundance, light = trace · standardized names (PubChem-linked) · window: date_complete 31 Aug 2025 – 27 Aug 2026* (trailing 12 months, current month partial)</a:t>
+              <a:t>lab_detail.substance counts · solid = primary abundance, light = trace · standardized names (PubChem-linked) · window: date_complete 01 Sep 2025 – 27 Aug 2026* (trailing 12 months, current month partial)</a:t>
             </a:r>
           </a:p>
         </p:txBody>
@@ -6053,7 +6053,7 @@
                 <a:ea typeface="Helvetica Neue"/>
                 <a:sym typeface="Helvetica Neue"/>
               </a:rPr>
-              <a:t>Distribution of substances detected per sample, both definitions shown side by side · window: date_complete 31 Aug 2025 – 27 Aug 2026* (trailing 12 months, current month partial)</a:t>
+              <a:t>Distribution of substances detected per sample, both definitions shown side by side · window: date_complete 01 Sep 2025 – 27 Aug 2026* (trailing 12 months, current month partial)</a:t>
             </a:r>
           </a:p>
         </p:txBody>

</xml_diff>

<commit_message>
nightly deck: data through 2026-09-02
</commit_message>
<xml_diff>
--- a/docs/nc-drug-checking-latest.pptx
+++ b/docs/nc-drug-checking-latest.pptx
@@ -2418,7 +2418,7 @@
                 <a:ea typeface="Helvetica Neue"/>
                 <a:sym typeface="Helvetica Neue"/>
               </a:rPr>
-              <a:t>Generated Tuesday, September 01, 2026 · 8:39 AM ET UNC Street Drug Analysis Lab · OpioidData.org · results.streetsafe.supply Download as PowerPoint</a:t>
+              <a:t>Generated Wednesday, September 02, 2026 · 8:13 AM ET UNC Street Drug Analysis Lab · OpioidData.org · results.streetsafe.supply Download as PowerPoint</a:t>
             </a:r>
           </a:p>
         </p:txBody>
@@ -2713,7 +2713,7 @@
                 <a:ea typeface="Helvetica Neue"/>
                 <a:sym typeface="Helvetica Neue"/>
               </a:rPr>
-              <a:t>PLACEHOLDER · figs/stats.json January 2022 to Thursday, August 27, 2026 N = 2,775 NC samples analyzed Mailed in from 86 harm reduction programs Collected across 57 counties 243 distinct substances detected to date Unique samples = n_distinct(sampleid) · substances from lab_detail.substance · includes samples with date_complete 26 Jan 2022 – 27 Aug 2026 r/build_nightly.R → figs/stats.json</a:t>
+              <a:t>PLACEHOLDER · figs/stats.json January 2022 to Tuesday, September 01, 2026 N = 2,778 NC samples analyzed Mailed in from 86 harm reduction programs Collected across 57 counties 243 distinct substances detected to date Unique samples = n_distinct(sampleid) · substances from lab_detail.substance · includes samples with date_complete 26 Jan 2022 – 01 Sep 2026 r/build_nightly.R → figs/stats.json</a:t>
             </a:r>
           </a:p>
         </p:txBody>
@@ -2762,7 +2762,7 @@
                 <a:ea typeface="Helvetica Neue"/>
                 <a:sym typeface="Helvetica Neue"/>
               </a:rPr>
-              <a:t>Unique samples = n_distinct(sampleid) · substances from lab_detail.substance · includes samples with date_complete 26 Jan 2022 – 27 Aug 2026</a:t>
+              <a:t>Unique samples = n_distinct(sampleid) · substances from lab_detail.substance · includes samples with date_complete 26 Jan 2022 – 01 Sep 2026</a:t>
             </a:r>
           </a:p>
         </p:txBody>
@@ -3184,7 +3184,7 @@
                 <a:ea typeface="Helvetica Neue"/>
                 <a:sym typeface="Helvetica Neue"/>
               </a:rPr>
-              <a:t>County = samplecounty · left: ≥1 completed analysis ever · right: unique samples per county (sqrt color scale) · all time: 26 Jan 2022 – 27 Aug 2026 · last 12 months: 01 Sep 2025 – 27 Aug 2026* · coverage reflects participation, not prevalence</a:t>
+              <a:t>County = samplecounty · left: ≥1 completed analysis ever · right: unique samples per county (sqrt color scale) · all time: 26 Jan 2022 – 01 Sep 2026 · last 12 months: 02 Sep 2025 – 01 Sep 2026* · coverage reflects participation, not prevalence</a:t>
             </a:r>
           </a:p>
         </p:txBody>
@@ -3505,7 +3505,7 @@
                 <a:ea typeface="Helvetica Neue"/>
                 <a:sym typeface="Helvetica Neue"/>
               </a:rPr>
-              <a:t>expectedsubstance (verbatim card write-in, semicolon lists split) · derived flags: expect_opioid, expect_fentanyl, expect_meth, expect_cocaine, expect_stimulant… · includes samples with date_complete 26 Jan 2022 – 27 Aug 2026 · data table: Appendix A2</a:t>
+              <a:t>expectedsubstance (verbatim card write-in, semicolon lists split) · derived flags: expect_opioid, expect_fentanyl, expect_meth, expect_cocaine, expect_stimulant… · includes samples with date_complete 26 Jan 2022 – 01 Sep 2026 · data table: Appendix A2</a:t>
             </a:r>
           </a:p>
         </p:txBody>
@@ -3703,7 +3703,7 @@
                 <a:ea typeface="Helvetica Neue"/>
                 <a:sym typeface="Helvetica Neue"/>
               </a:rPr>
-              <a:t>Numerator uses lab_*_any (primary or trace) among samples with expect_* = 1 · includes samples with date_complete 26 Jan 2022 – 27 Aug 2026 · data table: Appendix A3</a:t>
+              <a:t>Numerator uses lab_*_any (primary or trace) among samples with expect_* = 1 · includes samples with date_complete 26 Jan 2022 – 01 Sep 2026 · data table: Appendix A3</a:t>
             </a:r>
           </a:p>
         </p:txBody>
@@ -3901,7 +3901,7 @@
                 <a:ea typeface="Helvetica Neue"/>
                 <a:sym typeface="Helvetica Neue"/>
               </a:rPr>
-              <a:t>sensations (circled on card, semicolon lists split) · post-consumption samples only (consumed = 1) · includes samples with date_complete 26 Jan 2022 – 27 Aug 2026</a:t>
+              <a:t>sensations (circled on card, semicolon lists split) · post-consumption samples only (consumed = 1) · includes samples with date_complete 26 Jan 2022 – 01 Sep 2026</a:t>
             </a:r>
           </a:p>
         </p:txBody>
@@ -4125,7 +4125,7 @@
                 <a:ea typeface="Helvetica Neue"/>
                 <a:sym typeface="Helvetica Neue"/>
               </a:rPr>
-              <a:t>sensations semicolon lists parsed per report · consumed = 1 only · denominator: consumed samples with lab_*_any = 1 · includes samples with date_complete 26 Jan 2022 – 27 Aug 2026</a:t>
+              <a:t>sensations semicolon lists parsed per report · consumed = 1 only · denominator: consumed samples with lab_*_any = 1 · includes samples with date_complete 26 Jan 2022 – 01 Sep 2026</a:t>
             </a:r>
           </a:p>
         </p:txBody>
@@ -4323,7 +4323,7 @@
                 <a:ea typeface="Helvetica Neue"/>
                 <a:sym typeface="Helvetica Neue"/>
               </a:rPr>
-              <a:t>Samples with methamphetamine or cocaine detected (any abundance); samples in both classes appear on both slides · sensations semicolon lists parsed + sen_strength (own denominator) · consumed = 1 only · before: 26 Jan 2022 – 27 Aug 2025 · past 12 months: 01 Sep 2025 – 27 Aug 2026* · Δ in percentage points</a:t>
+              <a:t>Samples with methamphetamine or cocaine detected (any abundance); samples in both classes appear on both slides · sensations semicolon lists parsed + sen_strength (own denominator) · consumed = 1 only · before: 26 Jan 2022 – 01 Sep 2025 · past 12 months: 02 Sep 2025 – 01 Sep 2026* · Δ in percentage points</a:t>
             </a:r>
           </a:p>
         </p:txBody>
@@ -4742,7 +4742,7 @@
                 <a:ea typeface="Helvetica Neue"/>
                 <a:sym typeface="Helvetica Neue"/>
               </a:rPr>
-              <a:t>Samples with an opioid (fentanyl, heroin) or benzodiazepine detected (any abundance); samples in both classes appear on both slides · sensations semicolon lists parsed + sen_strength (own denominator) · consumed = 1 only · before: 26 Jan 2022 – 27 Aug 2025 · past 12 months: 01 Sep 2025 – 27 Aug 2026* · Δ in percentage points</a:t>
+              <a:t>Samples with an opioid (fentanyl, heroin) or benzodiazepine detected (any abundance); samples in both classes appear on both slides · sensations semicolon lists parsed + sen_strength (own denominator) · consumed = 1 only · before: 26 Jan 2022 – 01 Sep 2025 · past 12 months: 02 Sep 2025 – 01 Sep 2026* · Δ in percentage points</a:t>
             </a:r>
           </a:p>
         </p:txBody>
@@ -5138,7 +5138,7 @@
                 <a:ea typeface="Helvetica Neue"/>
                 <a:sym typeface="Helvetica Neue"/>
               </a:rPr>
-              <a:t>color, texture (card v3+, semicolon lists split) · derived: bright_color excludes white/tan/brown family — orange bar above · includes samples with date_complete 26 Jan 2022 – 27 Aug 2026</a:t>
+              <a:t>color, texture (card v3+, semicolon lists split) · derived: bright_color excludes white/tan/brown family — orange bar above · includes samples with date_complete 26 Jan 2022 – 01 Sep 2026</a:t>
             </a:r>
           </a:p>
         </p:txBody>
@@ -5459,7 +5459,7 @@
                 <a:ea typeface="Helvetica Neue"/>
                 <a:sym typeface="Helvetica Neue"/>
               </a:rPr>
-              <a:t>Distribution of substances detected per sample, both definitions shown side by side · includes samples with date_complete 26 Jan 2022 – 27 Aug 2026</a:t>
+              <a:t>Distribution of substances detected per sample, both definitions shown side by side · includes samples with date_complete 26 Jan 2022 – 01 Sep 2026</a:t>
             </a:r>
           </a:p>
         </p:txBody>
@@ -5657,7 +5657,7 @@
                 <a:ea typeface="Helvetica Neue"/>
                 <a:sym typeface="Helvetica Neue"/>
               </a:rPr>
-              <a:t>lab_detail.substance counts · solid = primary abundance, light = trace · standardized names (PubChem-linked) · includes samples with date_complete 26 Jan 2022 – 27 Aug 2026</a:t>
+              <a:t>lab_detail.substance counts · solid = primary abundance, light = trace · standardized names (PubChem-linked) · includes samples with date_complete 26 Jan 2022 – 01 Sep 2026</a:t>
             </a:r>
           </a:p>
         </p:txBody>
@@ -5855,7 +5855,7 @@
                 <a:ea typeface="Helvetica Neue"/>
                 <a:sym typeface="Helvetica Neue"/>
               </a:rPr>
-              <a:t>lab_detail.substance counts · solid = primary abundance, light = trace · standardized names (PubChem-linked) · window: date_complete 01 Sep 2025 – 27 Aug 2026* (trailing 12 months, current month partial)</a:t>
+              <a:t>lab_detail.substance counts · solid = primary abundance, light = trace · standardized names (PubChem-linked) · window: date_complete 02 Sep 2025 – 01 Sep 2026* (trailing 12 months, current month partial)</a:t>
             </a:r>
           </a:p>
         </p:txBody>
@@ -6053,7 +6053,7 @@
                 <a:ea typeface="Helvetica Neue"/>
                 <a:sym typeface="Helvetica Neue"/>
               </a:rPr>
-              <a:t>Distribution of substances detected per sample, both definitions shown side by side · window: date_complete 01 Sep 2025 – 27 Aug 2026* (trailing 12 months, current month partial)</a:t>
+              <a:t>Distribution of substances detected per sample, both definitions shown side by side · window: date_complete 02 Sep 2025 – 01 Sep 2026* (trailing 12 months, current month partial)</a:t>
             </a:r>
           </a:p>
         </p:txBody>
@@ -8944,7 +8944,7 @@
                 <a:ea typeface="Helvetica Neue"/>
                 <a:sym typeface="Helvetica Neue"/>
               </a:rPr>
-              <a:t>Fentanyl-Positive Samples, UNC Street Drug Analysis Lab (Drug Checking) Data: Aug 2026*</a:t>
+              <a:t>Fentanyl-Positive Samples, UNC Street Drug Analysis Lab (Drug Checking) Data: Sep 2026*</a:t>
             </a:r>
           </a:p>
         </p:txBody>
@@ -9070,7 +9070,7 @@
                 <a:ea typeface="Helvetica Neue"/>
                 <a:sym typeface="Helvetica Neue"/>
               </a:rPr>
-              <a:t>Xylazine-Positive Samples, UNC Street Drug Analysis Lab (Drug Checking) Data: Aug 2026*</a:t>
+              <a:t>Xylazine-Positive Samples, UNC Street Drug Analysis Lab (Drug Checking) Data: Sep 2026*</a:t>
             </a:r>
           </a:p>
         </p:txBody>
@@ -9196,7 +9196,7 @@
                 <a:ea typeface="Helvetica Neue"/>
                 <a:sym typeface="Helvetica Neue"/>
               </a:rPr>
-              <a:t>Methamphetamine-Positive Samples, UNC Street Drug Analysis Lab (Drug Checking) Data: Aug 2026*</a:t>
+              <a:t>Methamphetamine-Positive Samples, UNC Street Drug Analysis Lab (Drug Checking) Data: Sep 2026*</a:t>
             </a:r>
           </a:p>
         </p:txBody>
@@ -9322,7 +9322,7 @@
                 <a:ea typeface="Helvetica Neue"/>
                 <a:sym typeface="Helvetica Neue"/>
               </a:rPr>
-              <a:t>Cocaine-Positive Samples, UNC Street Drug Analysis Lab (Drug Checking) Data: Aug 2026*</a:t>
+              <a:t>Cocaine-Positive Samples, UNC Street Drug Analysis Lab (Drug Checking) Data: Sep 2026*</a:t>
             </a:r>
           </a:p>
         </p:txBody>
@@ -18510,7 +18510,7 @@
                           <a:ea typeface="Helvetica Neue"/>
                           <a:sym typeface="Helvetica Neue"/>
                         </a:rPr>
-                        <a:t>1,416</a:t>
+                        <a:t>1,417</a:t>
                       </a:r>
                     </a:p>
                   </a:txBody>
@@ -19497,7 +19497,7 @@
                           <a:ea typeface="Helvetica Neue"/>
                           <a:sym typeface="Helvetica Neue"/>
                         </a:rPr>
-                        <a:t>ketamine</a:t>
+                        <a:t>fentanyl, methamphetamine</a:t>
                       </a:r>
                     </a:p>
                   </a:txBody>
@@ -19613,7 +19613,7 @@
                           <a:ea typeface="Helvetica Neue"/>
                           <a:sym typeface="Helvetica Neue"/>
                         </a:rPr>
-                        <a:t>fentanyl, methamphetamine</a:t>
+                        <a:t>ketamine</a:t>
                       </a:r>
                     </a:p>
                   </a:txBody>
@@ -19670,7 +19670,7 @@
                           <a:ea typeface="Helvetica Neue"/>
                           <a:sym typeface="Helvetica Neue"/>
                         </a:rPr>
-                        <a:t>49</a:t>
+                        <a:t>50</a:t>
                       </a:r>
                     </a:p>
                   </a:txBody>
@@ -20591,7 +20591,7 @@
                           <a:ea typeface="Helvetica Neue"/>
                           <a:sym typeface="Helvetica Neue"/>
                         </a:rPr>
-                        <a:t>1,624</a:t>
+                        <a:t>1,627</a:t>
                       </a:r>
                     </a:p>
                   </a:txBody>
@@ -20821,7 +20821,7 @@
                           <a:ea typeface="Helvetica Neue"/>
                           <a:sym typeface="Helvetica Neue"/>
                         </a:rPr>
-                        <a:t>495</a:t>
+                        <a:t>496</a:t>
                       </a:r>
                     </a:p>
                   </a:txBody>
@@ -21051,7 +21051,7 @@
                           <a:ea typeface="Helvetica Neue"/>
                           <a:sym typeface="Helvetica Neue"/>
                         </a:rPr>
-                        <a:t>139</a:t>
+                        <a:t>140</a:t>
                       </a:r>
                     </a:p>
                   </a:txBody>
@@ -22151,7 +22151,7 @@
                           <a:ea typeface="Helvetica Neue"/>
                           <a:sym typeface="Helvetica Neue"/>
                         </a:rPr>
-                        <a:t>167 / month</a:t>
+                        <a:t>98 / month</a:t>
                       </a:r>
                     </a:p>
                   </a:txBody>
@@ -22208,7 +22208,7 @@
                           <a:ea typeface="Helvetica Neue"/>
                           <a:sym typeface="Helvetica Neue"/>
                         </a:rPr>
-                        <a:t>+53%</a:t>
+                        <a:t>-41%</a:t>
                       </a:r>
                     </a:p>
                   </a:txBody>
@@ -22324,7 +22324,7 @@
                           <a:ea typeface="Helvetica Neue"/>
                           <a:sym typeface="Helvetica Neue"/>
                         </a:rPr>
-                        <a:t>665</a:t>
+                        <a:t>714</a:t>
                       </a:r>
                     </a:p>
                   </a:txBody>
@@ -22381,7 +22381,7 @@
                           <a:ea typeface="Helvetica Neue"/>
                           <a:sym typeface="Helvetica Neue"/>
                         </a:rPr>
-                        <a:t>+5%</a:t>
+                        <a:t>+7%</a:t>
                       </a:r>
                     </a:p>
                   </a:txBody>
@@ -22497,7 +22497,7 @@
                           <a:ea typeface="Helvetica Neue"/>
                           <a:sym typeface="Helvetica Neue"/>
                         </a:rPr>
-                        <a:t>605</a:t>
+                        <a:t>714</a:t>
                       </a:r>
                     </a:p>
                   </a:txBody>
@@ -22554,7 +22554,7 @@
                           <a:ea typeface="Helvetica Neue"/>
                           <a:sym typeface="Helvetica Neue"/>
                         </a:rPr>
-                        <a:t>+1%</a:t>
+                        <a:t>+18%</a:t>
                       </a:r>
                     </a:p>
                   </a:txBody>
@@ -22670,7 +22670,7 @@
                           <a:ea typeface="Helvetica Neue"/>
                           <a:sym typeface="Helvetica Neue"/>
                         </a:rPr>
-                        <a:t>60</a:t>
+                        <a:t>41</a:t>
                       </a:r>
                     </a:p>
                   </a:txBody>
@@ -22727,7 +22727,7 @@
                           <a:ea typeface="Helvetica Neue"/>
                           <a:sym typeface="Helvetica Neue"/>
                         </a:rPr>
-                        <a:t>-7%</a:t>
+                        <a:t>-32%</a:t>
                       </a:r>
                     </a:p>
                   </a:txBody>
@@ -22843,7 +22843,7 @@
                           <a:ea typeface="Helvetica Neue"/>
                           <a:sym typeface="Helvetica Neue"/>
                         </a:rPr>
-                        <a:t>90</a:t>
+                        <a:t>51</a:t>
                       </a:r>
                     </a:p>
                   </a:txBody>
@@ -22900,7 +22900,7 @@
                           <a:ea typeface="Helvetica Neue"/>
                           <a:sym typeface="Helvetica Neue"/>
                         </a:rPr>
-                        <a:t>+40%</a:t>
+                        <a:t>-43%</a:t>
                       </a:r>
                     </a:p>
                   </a:txBody>
@@ -23020,7 +23020,7 @@
                           <a:ea typeface="Helvetica Neue"/>
                           <a:sym typeface="Helvetica Neue"/>
                         </a:rPr>
-                        <a:t>287</a:t>
+                        <a:t>418</a:t>
                       </a:r>
                     </a:p>
                   </a:txBody>
@@ -23081,7 +23081,7 @@
                           <a:ea typeface="Helvetica Neue"/>
                           <a:sym typeface="Helvetica Neue"/>
                         </a:rPr>
-                        <a:t>-22%</a:t>
+                        <a:t>+46%</a:t>
                       </a:r>
                     </a:p>
                   </a:txBody>
@@ -23480,7 +23480,7 @@
                           <a:ea typeface="Helvetica Neue"/>
                           <a:sym typeface="Helvetica Neue"/>
                         </a:rPr>
-                        <a:t>+59%</a:t>
+                        <a:t>+0%</a:t>
                       </a:r>
                     </a:p>
                   </a:txBody>
@@ -23653,7 +23653,7 @@
                           <a:ea typeface="Helvetica Neue"/>
                           <a:sym typeface="Helvetica Neue"/>
                         </a:rPr>
-                        <a:t>-100%</a:t>
+                        <a:t>n/a</a:t>
                       </a:r>
                     </a:p>
                   </a:txBody>
@@ -24115,7 +24115,7 @@
                           <a:ea typeface="Helvetica Neue"/>
                           <a:sym typeface="Helvetica Neue"/>
                         </a:rPr>
-                        <a:t>18</a:t>
+                        <a:t>31</a:t>
                       </a:r>
                     </a:p>
                   </a:txBody>
@@ -24172,7 +24172,7 @@
                           <a:ea typeface="Helvetica Neue"/>
                           <a:sym typeface="Helvetica Neue"/>
                         </a:rPr>
-                        <a:t>-35%</a:t>
+                        <a:t>+70%</a:t>
                       </a:r>
                     </a:p>
                   </a:txBody>
@@ -24292,7 +24292,7 @@
                           <a:ea typeface="Helvetica Neue"/>
                           <a:sym typeface="Helvetica Neue"/>
                         </a:rPr>
-                        <a:t>50</a:t>
+                        <a:t>48</a:t>
                       </a:r>
                     </a:p>
                   </a:txBody>
@@ -24353,7 +24353,7 @@
                           <a:ea typeface="Helvetica Neue"/>
                           <a:sym typeface="Helvetica Neue"/>
                         </a:rPr>
-                        <a:t>-58%</a:t>
+                        <a:t>-5%</a:t>
                       </a:r>
                     </a:p>
                   </a:txBody>

</xml_diff>

<commit_message>
nightly deck: data through 2026-09-03
</commit_message>
<xml_diff>
--- a/docs/nc-drug-checking-latest.pptx
+++ b/docs/nc-drug-checking-latest.pptx
@@ -2418,7 +2418,7 @@
                 <a:ea typeface="Helvetica Neue"/>
                 <a:sym typeface="Helvetica Neue"/>
               </a:rPr>
-              <a:t>Generated Wednesday, September 02, 2026 · 8:13 AM ET UNC Street Drug Analysis Lab · OpioidData.org · results.streetsafe.supply Download as PowerPoint</a:t>
+              <a:t>Generated Thursday, September 03, 2026 · 8:11 AM ET UNC Street Drug Analysis Lab · OpioidData.org · results.streetsafe.supply Download as PowerPoint</a:t>
             </a:r>
           </a:p>
         </p:txBody>
@@ -2713,7 +2713,7 @@
                 <a:ea typeface="Helvetica Neue"/>
                 <a:sym typeface="Helvetica Neue"/>
               </a:rPr>
-              <a:t>PLACEHOLDER · figs/stats.json January 2022 to Tuesday, September 01, 2026 N = 2,778 NC samples analyzed Mailed in from 86 harm reduction programs Collected across 57 counties 243 distinct substances detected to date Unique samples = n_distinct(sampleid) · substances from lab_detail.substance · includes samples with date_complete 26 Jan 2022 – 01 Sep 2026 r/build_nightly.R → figs/stats.json</a:t>
+              <a:t>PLACEHOLDER · figs/stats.json January 2022 to Wednesday, September 02, 2026 N = 2,786 NC samples analyzed Mailed in from 86 harm reduction programs Collected across 57 counties 244 distinct substances detected to date Unique samples = n_distinct(sampleid) · substances from lab_detail.substance · includes samples with date_complete 26 Jan 2022 – 02 Sep 2026 r/build_nightly.R → figs/stats.json</a:t>
             </a:r>
           </a:p>
         </p:txBody>
@@ -2762,7 +2762,7 @@
                 <a:ea typeface="Helvetica Neue"/>
                 <a:sym typeface="Helvetica Neue"/>
               </a:rPr>
-              <a:t>Unique samples = n_distinct(sampleid) · substances from lab_detail.substance · includes samples with date_complete 26 Jan 2022 – 01 Sep 2026</a:t>
+              <a:t>Unique samples = n_distinct(sampleid) · substances from lab_detail.substance · includes samples with date_complete 26 Jan 2022 – 02 Sep 2026</a:t>
             </a:r>
           </a:p>
         </p:txBody>
@@ -3184,7 +3184,7 @@
                 <a:ea typeface="Helvetica Neue"/>
                 <a:sym typeface="Helvetica Neue"/>
               </a:rPr>
-              <a:t>County = samplecounty · left: ≥1 completed analysis ever · right: unique samples per county (sqrt color scale) · all time: 26 Jan 2022 – 01 Sep 2026 · last 12 months: 02 Sep 2025 – 01 Sep 2026* · coverage reflects participation, not prevalence</a:t>
+              <a:t>County = samplecounty · left: ≥1 completed analysis ever · right: unique samples per county (sqrt color scale) · all time: 26 Jan 2022 – 02 Sep 2026 · last 12 months: 03 Sep 2025 – 02 Sep 2026* · coverage reflects participation, not prevalence</a:t>
             </a:r>
           </a:p>
         </p:txBody>
@@ -3505,7 +3505,7 @@
                 <a:ea typeface="Helvetica Neue"/>
                 <a:sym typeface="Helvetica Neue"/>
               </a:rPr>
-              <a:t>expectedsubstance (verbatim card write-in, semicolon lists split) · derived flags: expect_opioid, expect_fentanyl, expect_meth, expect_cocaine, expect_stimulant… · includes samples with date_complete 26 Jan 2022 – 01 Sep 2026 · data table: Appendix A2</a:t>
+              <a:t>expectedsubstance (verbatim card write-in, semicolon lists split) · derived flags: expect_opioid, expect_fentanyl, expect_meth, expect_cocaine, expect_stimulant… · includes samples with date_complete 26 Jan 2022 – 02 Sep 2026 · data table: Appendix A2</a:t>
             </a:r>
           </a:p>
         </p:txBody>
@@ -3703,7 +3703,7 @@
                 <a:ea typeface="Helvetica Neue"/>
                 <a:sym typeface="Helvetica Neue"/>
               </a:rPr>
-              <a:t>Numerator uses lab_*_any (primary or trace) among samples with expect_* = 1 · includes samples with date_complete 26 Jan 2022 – 01 Sep 2026 · data table: Appendix A3</a:t>
+              <a:t>Numerator uses lab_*_any (primary or trace) among samples with expect_* = 1 · includes samples with date_complete 26 Jan 2022 – 02 Sep 2026 · data table: Appendix A3</a:t>
             </a:r>
           </a:p>
         </p:txBody>
@@ -3901,7 +3901,7 @@
                 <a:ea typeface="Helvetica Neue"/>
                 <a:sym typeface="Helvetica Neue"/>
               </a:rPr>
-              <a:t>sensations (circled on card, semicolon lists split) · post-consumption samples only (consumed = 1) · includes samples with date_complete 26 Jan 2022 – 01 Sep 2026</a:t>
+              <a:t>sensations (circled on card, semicolon lists split) · post-consumption samples only (consumed = 1) · includes samples with date_complete 26 Jan 2022 – 02 Sep 2026</a:t>
             </a:r>
           </a:p>
         </p:txBody>
@@ -4125,7 +4125,7 @@
                 <a:ea typeface="Helvetica Neue"/>
                 <a:sym typeface="Helvetica Neue"/>
               </a:rPr>
-              <a:t>sensations semicolon lists parsed per report · consumed = 1 only · denominator: consumed samples with lab_*_any = 1 · includes samples with date_complete 26 Jan 2022 – 01 Sep 2026</a:t>
+              <a:t>sensations semicolon lists parsed per report · consumed = 1 only · denominator: consumed samples with lab_*_any = 1 · includes samples with date_complete 26 Jan 2022 – 02 Sep 2026</a:t>
             </a:r>
           </a:p>
         </p:txBody>
@@ -4323,7 +4323,7 @@
                 <a:ea typeface="Helvetica Neue"/>
                 <a:sym typeface="Helvetica Neue"/>
               </a:rPr>
-              <a:t>Samples with methamphetamine or cocaine detected (any abundance); samples in both classes appear on both slides · sensations semicolon lists parsed + sen_strength (own denominator) · consumed = 1 only · before: 26 Jan 2022 – 01 Sep 2025 · past 12 months: 02 Sep 2025 – 01 Sep 2026* · Δ in percentage points</a:t>
+              <a:t>Samples with methamphetamine or cocaine detected (any abundance); samples in both classes appear on both slides · sensations semicolon lists parsed + sen_strength (own denominator) · consumed = 1 only · before: 26 Jan 2022 – 02 Sep 2025 · past 12 months: 03 Sep 2025 – 02 Sep 2026* · Δ in percentage points</a:t>
             </a:r>
           </a:p>
         </p:txBody>
@@ -4742,7 +4742,7 @@
                 <a:ea typeface="Helvetica Neue"/>
                 <a:sym typeface="Helvetica Neue"/>
               </a:rPr>
-              <a:t>Samples with an opioid (fentanyl, heroin) or benzodiazepine detected (any abundance); samples in both classes appear on both slides · sensations semicolon lists parsed + sen_strength (own denominator) · consumed = 1 only · before: 26 Jan 2022 – 01 Sep 2025 · past 12 months: 02 Sep 2025 – 01 Sep 2026* · Δ in percentage points</a:t>
+              <a:t>Samples with an opioid (fentanyl, heroin) or benzodiazepine detected (any abundance); samples in both classes appear on both slides · sensations semicolon lists parsed + sen_strength (own denominator) · consumed = 1 only · before: 26 Jan 2022 – 02 Sep 2025 · past 12 months: 03 Sep 2025 – 02 Sep 2026* · Δ in percentage points</a:t>
             </a:r>
           </a:p>
         </p:txBody>
@@ -5138,7 +5138,7 @@
                 <a:ea typeface="Helvetica Neue"/>
                 <a:sym typeface="Helvetica Neue"/>
               </a:rPr>
-              <a:t>color, texture (card v3+, semicolon lists split) · derived: bright_color excludes white/tan/brown family — orange bar above · includes samples with date_complete 26 Jan 2022 – 01 Sep 2026</a:t>
+              <a:t>color, texture (card v3+, semicolon lists split) · derived: bright_color excludes white/tan/brown family — orange bar above · includes samples with date_complete 26 Jan 2022 – 02 Sep 2026</a:t>
             </a:r>
           </a:p>
         </p:txBody>
@@ -5459,7 +5459,7 @@
                 <a:ea typeface="Helvetica Neue"/>
                 <a:sym typeface="Helvetica Neue"/>
               </a:rPr>
-              <a:t>Distribution of substances detected per sample, both definitions shown side by side · includes samples with date_complete 26 Jan 2022 – 01 Sep 2026</a:t>
+              <a:t>Distribution of substances detected per sample, both definitions shown side by side · includes samples with date_complete 26 Jan 2022 – 02 Sep 2026</a:t>
             </a:r>
           </a:p>
         </p:txBody>
@@ -5657,7 +5657,7 @@
                 <a:ea typeface="Helvetica Neue"/>
                 <a:sym typeface="Helvetica Neue"/>
               </a:rPr>
-              <a:t>lab_detail.substance counts · solid = primary abundance, light = trace · standardized names (PubChem-linked) · includes samples with date_complete 26 Jan 2022 – 01 Sep 2026</a:t>
+              <a:t>lab_detail.substance counts · solid = primary abundance, light = trace · standardized names (PubChem-linked) · includes samples with date_complete 26 Jan 2022 – 02 Sep 2026</a:t>
             </a:r>
           </a:p>
         </p:txBody>
@@ -5855,7 +5855,7 @@
                 <a:ea typeface="Helvetica Neue"/>
                 <a:sym typeface="Helvetica Neue"/>
               </a:rPr>
-              <a:t>lab_detail.substance counts · solid = primary abundance, light = trace · standardized names (PubChem-linked) · window: date_complete 02 Sep 2025 – 01 Sep 2026* (trailing 12 months, current month partial)</a:t>
+              <a:t>lab_detail.substance counts · solid = primary abundance, light = trace · standardized names (PubChem-linked) · window: date_complete 03 Sep 2025 – 02 Sep 2026* (trailing 12 months, current month partial)</a:t>
             </a:r>
           </a:p>
         </p:txBody>
@@ -6053,7 +6053,7 @@
                 <a:ea typeface="Helvetica Neue"/>
                 <a:sym typeface="Helvetica Neue"/>
               </a:rPr>
-              <a:t>Distribution of substances detected per sample, both definitions shown side by side · window: date_complete 02 Sep 2025 – 01 Sep 2026* (trailing 12 months, current month partial)</a:t>
+              <a:t>Distribution of substances detected per sample, both definitions shown side by side · window: date_complete 03 Sep 2025 – 02 Sep 2026* (trailing 12 months, current month partial)</a:t>
             </a:r>
           </a:p>
         </p:txBody>
@@ -11049,6 +11049,293 @@
                           <a:ea typeface="Helvetica Neue"/>
                           <a:sym typeface="Helvetica Neue"/>
                         </a:rPr>
+                        <a:t>chlorphenamine</a:t>
+                      </a:r>
+                    </a:p>
+                  </a:txBody>
+                  <a:tcPr anchor="ctr" marB="63500" marT="63500" marR="0" marL="0">
+                    <a:lnL algn="ctr" cmpd="sng" cap="flat" w="0">
+                      <a:noFill/>
+                      <a:prstDash val="solid"/>
+                    </a:lnL>
+                    <a:lnR algn="ctr" cmpd="sng" cap="flat" w="0">
+                      <a:noFill/>
+                      <a:prstDash val="solid"/>
+                    </a:lnR>
+                    <a:lnT algn="ctr" cmpd="sng" cap="flat" w="0">
+                      <a:noFill/>
+                      <a:prstDash val="solid"/>
+                    </a:lnT>
+                    <a:lnB algn="ctr" cmpd="sng" cap="flat" w="0">
+                      <a:noFill/>
+                      <a:prstDash val="solid"/>
+                    </a:lnB>
+                    <a:solidFill>
+                      <a:srgbClr val="FFFFFF">
+                        <a:alpha val="0"/>
+                      </a:srgbClr>
+                    </a:solidFill>
+                  </a:tcPr>
+                </a:tc>
+                <a:tc>
+                  <a:txBody>
+                    <a:bodyPr/>
+                    <a:lstStyle/>
+                    <a:p>
+                      <a:pPr algn="l" marL="63500" marR="63500">
+                        <a:lnSpc>
+                          <a:spcPct val="100000"/>
+                        </a:lnSpc>
+                        <a:spcBef>
+                          <a:spcPts val="500"/>
+                        </a:spcBef>
+                        <a:spcAft>
+                          <a:spcPts val="500"/>
+                        </a:spcAft>
+                        <a:buNone/>
+                      </a:pPr>
+                      <a:r>
+                        <a:rPr cap="none" sz="1200" i="0" b="0" u="none" strike="noStrike">
+                          <a:solidFill>
+                            <a:srgbClr val="5B6770">
+                              <a:alpha val="100000"/>
+                            </a:srgbClr>
+                          </a:solidFill>
+                          <a:latin typeface="Helvetica Neue"/>
+                          <a:cs typeface="Helvetica Neue"/>
+                          <a:ea typeface="Helvetica Neue"/>
+                          <a:sym typeface="Helvetica Neue"/>
+                        </a:rPr>
+                        <a:t>02 Sep 2026</a:t>
+                      </a:r>
+                    </a:p>
+                  </a:txBody>
+                  <a:tcPr anchor="ctr" marB="63500" marT="63500" marR="0" marL="0">
+                    <a:lnL algn="ctr" cmpd="sng" cap="flat" w="0">
+                      <a:noFill/>
+                      <a:prstDash val="solid"/>
+                    </a:lnL>
+                    <a:lnR algn="ctr" cmpd="sng" cap="flat" w="0">
+                      <a:noFill/>
+                      <a:prstDash val="solid"/>
+                    </a:lnR>
+                    <a:lnT algn="ctr" cmpd="sng" cap="flat" w="0">
+                      <a:noFill/>
+                      <a:prstDash val="solid"/>
+                    </a:lnT>
+                    <a:lnB algn="ctr" cmpd="sng" cap="flat" w="0">
+                      <a:noFill/>
+                      <a:prstDash val="solid"/>
+                    </a:lnB>
+                    <a:solidFill>
+                      <a:srgbClr val="FFFFFF">
+                        <a:alpha val="0"/>
+                      </a:srgbClr>
+                    </a:solidFill>
+                  </a:tcPr>
+                </a:tc>
+                <a:tc>
+                  <a:txBody>
+                    <a:bodyPr/>
+                    <a:lstStyle/>
+                    <a:p>
+                      <a:pPr algn="l" marL="63500" marR="63500">
+                        <a:lnSpc>
+                          <a:spcPct val="100000"/>
+                        </a:lnSpc>
+                        <a:spcBef>
+                          <a:spcPts val="500"/>
+                        </a:spcBef>
+                        <a:spcAft>
+                          <a:spcPts val="500"/>
+                        </a:spcAft>
+                        <a:buNone/>
+                      </a:pPr>
+                      <a:r>
+                        <a:rPr cap="none" sz="1200" i="0" b="0" u="none" strike="noStrike">
+                          <a:solidFill>
+                            <a:srgbClr val="5B6770">
+                              <a:alpha val="100000"/>
+                            </a:srgbClr>
+                          </a:solidFill>
+                          <a:latin typeface="Helvetica Neue"/>
+                          <a:cs typeface="Helvetica Neue"/>
+                          <a:ea typeface="Helvetica Neue"/>
+                          <a:sym typeface="Helvetica Neue"/>
+                        </a:rPr>
+                        <a:t>trace</a:t>
+                      </a:r>
+                    </a:p>
+                  </a:txBody>
+                  <a:tcPr anchor="ctr" marB="63500" marT="63500" marR="0" marL="0">
+                    <a:lnL algn="ctr" cmpd="sng" cap="flat" w="0">
+                      <a:noFill/>
+                      <a:prstDash val="solid"/>
+                    </a:lnL>
+                    <a:lnR algn="ctr" cmpd="sng" cap="flat" w="0">
+                      <a:noFill/>
+                      <a:prstDash val="solid"/>
+                    </a:lnR>
+                    <a:lnT algn="ctr" cmpd="sng" cap="flat" w="0">
+                      <a:noFill/>
+                      <a:prstDash val="solid"/>
+                    </a:lnT>
+                    <a:lnB algn="ctr" cmpd="sng" cap="flat" w="0">
+                      <a:noFill/>
+                      <a:prstDash val="solid"/>
+                    </a:lnB>
+                    <a:solidFill>
+                      <a:srgbClr val="FFFFFF">
+                        <a:alpha val="0"/>
+                      </a:srgbClr>
+                    </a:solidFill>
+                  </a:tcPr>
+                </a:tc>
+                <a:tc>
+                  <a:txBody>
+                    <a:bodyPr/>
+                    <a:lstStyle/>
+                    <a:p>
+                      <a:pPr algn="r" marL="63500" marR="63500">
+                        <a:lnSpc>
+                          <a:spcPct val="100000"/>
+                        </a:lnSpc>
+                        <a:spcBef>
+                          <a:spcPts val="500"/>
+                        </a:spcBef>
+                        <a:spcAft>
+                          <a:spcPts val="500"/>
+                        </a:spcAft>
+                        <a:buNone/>
+                      </a:pPr>
+                      <a:r>
+                        <a:rPr cap="none" sz="1200" i="0" b="0" u="none" strike="noStrike">
+                          <a:solidFill>
+                            <a:srgbClr val="5B6770">
+                              <a:alpha val="100000"/>
+                            </a:srgbClr>
+                          </a:solidFill>
+                          <a:latin typeface="Helvetica Neue"/>
+                          <a:cs typeface="Helvetica Neue"/>
+                          <a:ea typeface="Helvetica Neue"/>
+                          <a:sym typeface="Helvetica Neue"/>
+                        </a:rPr>
+                        <a:t>1</a:t>
+                      </a:r>
+                    </a:p>
+                  </a:txBody>
+                  <a:tcPr anchor="ctr" marB="63500" marT="63500" marR="0" marL="0">
+                    <a:lnL algn="ctr" cmpd="sng" cap="flat" w="0">
+                      <a:noFill/>
+                      <a:prstDash val="solid"/>
+                    </a:lnL>
+                    <a:lnR algn="ctr" cmpd="sng" cap="flat" w="0">
+                      <a:noFill/>
+                      <a:prstDash val="solid"/>
+                    </a:lnR>
+                    <a:lnT algn="ctr" cmpd="sng" cap="flat" w="0">
+                      <a:noFill/>
+                      <a:prstDash val="solid"/>
+                    </a:lnT>
+                    <a:lnB algn="ctr" cmpd="sng" cap="flat" w="0">
+                      <a:noFill/>
+                      <a:prstDash val="solid"/>
+                    </a:lnB>
+                    <a:solidFill>
+                      <a:srgbClr val="FFFFFF">
+                        <a:alpha val="0"/>
+                      </a:srgbClr>
+                    </a:solidFill>
+                  </a:tcPr>
+                </a:tc>
+                <a:tc>
+                  <a:txBody>
+                    <a:bodyPr/>
+                    <a:lstStyle/>
+                    <a:p>
+                      <a:pPr algn="l" marL="63500" marR="63500">
+                        <a:lnSpc>
+                          <a:spcPct val="100000"/>
+                        </a:lnSpc>
+                        <a:spcBef>
+                          <a:spcPts val="500"/>
+                        </a:spcBef>
+                        <a:spcAft>
+                          <a:spcPts val="500"/>
+                        </a:spcAft>
+                        <a:buNone/>
+                      </a:pPr>
+                      <a:r>
+                        <a:rPr cap="none" sz="1200" i="0" b="0" u="none" strike="noStrike">
+                          <a:solidFill>
+                            <a:srgbClr val="5B6770">
+                              <a:alpha val="100000"/>
+                            </a:srgbClr>
+                          </a:solidFill>
+                          <a:latin typeface="Helvetica Neue"/>
+                          <a:cs typeface="Helvetica Neue"/>
+                          <a:ea typeface="Helvetica Neue"/>
+                          <a:sym typeface="Helvetica Neue"/>
+                        </a:rPr>
+                        <a:t>605053</a:t>
+                      </a:r>
+                    </a:p>
+                  </a:txBody>
+                  <a:tcPr anchor="ctr" marB="63500" marT="63500" marR="0" marL="0">
+                    <a:lnL algn="ctr" cmpd="sng" cap="flat" w="0">
+                      <a:noFill/>
+                      <a:prstDash val="solid"/>
+                    </a:lnL>
+                    <a:lnR algn="ctr" cmpd="sng" cap="flat" w="0">
+                      <a:noFill/>
+                      <a:prstDash val="solid"/>
+                    </a:lnR>
+                    <a:lnT algn="ctr" cmpd="sng" cap="flat" w="0">
+                      <a:noFill/>
+                      <a:prstDash val="solid"/>
+                    </a:lnT>
+                    <a:lnB algn="ctr" cmpd="sng" cap="flat" w="0">
+                      <a:noFill/>
+                      <a:prstDash val="solid"/>
+                    </a:lnB>
+                    <a:solidFill>
+                      <a:srgbClr val="FFFFFF">
+                        <a:alpha val="0"/>
+                      </a:srgbClr>
+                    </a:solidFill>
+                  </a:tcPr>
+                </a:tc>
+              </a:tr>
+              <a:tr h="401320">
+                <a:tc>
+                  <a:txBody>
+                    <a:bodyPr/>
+                    <a:lstStyle/>
+                    <a:p>
+                      <a:pPr algn="l" marL="63500" marR="63500">
+                        <a:lnSpc>
+                          <a:spcPct val="100000"/>
+                        </a:lnSpc>
+                        <a:spcBef>
+                          <a:spcPts val="500"/>
+                        </a:spcBef>
+                        <a:spcAft>
+                          <a:spcPts val="500"/>
+                        </a:spcAft>
+                        <a:buNone/>
+                      </a:pPr>
+                      <a:r>
+                        <a:rPr cap="none" sz="1200" i="0" b="0" u="none" strike="noStrike">
+                          <a:solidFill>
+                            <a:srgbClr val="5B6770">
+                              <a:alpha val="100000"/>
+                            </a:srgbClr>
+                          </a:solidFill>
+                          <a:latin typeface="Helvetica Neue"/>
+                          <a:cs typeface="Helvetica Neue"/>
+                          <a:ea typeface="Helvetica Neue"/>
+                          <a:sym typeface="Helvetica Neue"/>
+                        </a:rPr>
                         <a:t>delorazepam</a:t>
                       </a:r>
                     </a:p>
@@ -11071,8 +11358,8 @@
                       <a:prstDash val="solid"/>
                     </a:lnB>
                     <a:solidFill>
-                      <a:srgbClr val="FFFFFF">
-                        <a:alpha val="0"/>
+                      <a:srgbClr val="F4F8FB">
+                        <a:alpha val="100000"/>
                       </a:srgbClr>
                     </a:solidFill>
                   </a:tcPr>
@@ -11128,8 +11415,8 @@
                       <a:prstDash val="solid"/>
                     </a:lnB>
                     <a:solidFill>
-                      <a:srgbClr val="FFFFFF">
-                        <a:alpha val="0"/>
+                      <a:srgbClr val="F4F8FB">
+                        <a:alpha val="100000"/>
                       </a:srgbClr>
                     </a:solidFill>
                   </a:tcPr>
@@ -11185,8 +11472,8 @@
                       <a:prstDash val="solid"/>
                     </a:lnB>
                     <a:solidFill>
-                      <a:srgbClr val="FFFFFF">
-                        <a:alpha val="0"/>
+                      <a:srgbClr val="F4F8FB">
+                        <a:alpha val="100000"/>
                       </a:srgbClr>
                     </a:solidFill>
                   </a:tcPr>
@@ -11242,8 +11529,8 @@
                       <a:prstDash val="solid"/>
                     </a:lnB>
                     <a:solidFill>
-                      <a:srgbClr val="FFFFFF">
-                        <a:alpha val="0"/>
+                      <a:srgbClr val="F4F8FB">
+                        <a:alpha val="100000"/>
                       </a:srgbClr>
                     </a:solidFill>
                   </a:tcPr>
@@ -11299,8 +11586,8 @@
                       <a:prstDash val="solid"/>
                     </a:lnB>
                     <a:solidFill>
-                      <a:srgbClr val="FFFFFF">
-                        <a:alpha val="0"/>
+                      <a:srgbClr val="F4F8FB">
+                        <a:alpha val="100000"/>
                       </a:srgbClr>
                     </a:solidFill>
                   </a:tcPr>
@@ -11358,8 +11645,8 @@
                       <a:prstDash val="solid"/>
                     </a:lnB>
                     <a:solidFill>
-                      <a:srgbClr val="F4F8FB">
-                        <a:alpha val="100000"/>
+                      <a:srgbClr val="FFFFFF">
+                        <a:alpha val="0"/>
                       </a:srgbClr>
                     </a:solidFill>
                   </a:tcPr>
@@ -11415,8 +11702,8 @@
                       <a:prstDash val="solid"/>
                     </a:lnB>
                     <a:solidFill>
-                      <a:srgbClr val="F4F8FB">
-                        <a:alpha val="100000"/>
+                      <a:srgbClr val="FFFFFF">
+                        <a:alpha val="0"/>
                       </a:srgbClr>
                     </a:solidFill>
                   </a:tcPr>
@@ -11472,8 +11759,8 @@
                       <a:prstDash val="solid"/>
                     </a:lnB>
                     <a:solidFill>
-                      <a:srgbClr val="F4F8FB">
-                        <a:alpha val="100000"/>
+                      <a:srgbClr val="FFFFFF">
+                        <a:alpha val="0"/>
                       </a:srgbClr>
                     </a:solidFill>
                   </a:tcPr>
@@ -11529,8 +11816,8 @@
                       <a:prstDash val="solid"/>
                     </a:lnB>
                     <a:solidFill>
-                      <a:srgbClr val="F4F8FB">
-                        <a:alpha val="100000"/>
+                      <a:srgbClr val="FFFFFF">
+                        <a:alpha val="0"/>
                       </a:srgbClr>
                     </a:solidFill>
                   </a:tcPr>
@@ -11586,8 +11873,8 @@
                       <a:prstDash val="solid"/>
                     </a:lnB>
                     <a:solidFill>
-                      <a:srgbClr val="F4F8FB">
-                        <a:alpha val="100000"/>
+                      <a:srgbClr val="FFFFFF">
+                        <a:alpha val="0"/>
                       </a:srgbClr>
                     </a:solidFill>
                   </a:tcPr>
@@ -11645,8 +11932,8 @@
                       <a:prstDash val="solid"/>
                     </a:lnB>
                     <a:solidFill>
-                      <a:srgbClr val="FFFFFF">
-                        <a:alpha val="0"/>
+                      <a:srgbClr val="F4F8FB">
+                        <a:alpha val="100000"/>
                       </a:srgbClr>
                     </a:solidFill>
                   </a:tcPr>
@@ -11702,8 +11989,8 @@
                       <a:prstDash val="solid"/>
                     </a:lnB>
                     <a:solidFill>
-                      <a:srgbClr val="FFFFFF">
-                        <a:alpha val="0"/>
+                      <a:srgbClr val="F4F8FB">
+                        <a:alpha val="100000"/>
                       </a:srgbClr>
                     </a:solidFill>
                   </a:tcPr>
@@ -11759,8 +12046,8 @@
                       <a:prstDash val="solid"/>
                     </a:lnB>
                     <a:solidFill>
-                      <a:srgbClr val="FFFFFF">
-                        <a:alpha val="0"/>
+                      <a:srgbClr val="F4F8FB">
+                        <a:alpha val="100000"/>
                       </a:srgbClr>
                     </a:solidFill>
                   </a:tcPr>
@@ -11816,8 +12103,8 @@
                       <a:prstDash val="solid"/>
                     </a:lnB>
                     <a:solidFill>
-                      <a:srgbClr val="FFFFFF">
-                        <a:alpha val="0"/>
+                      <a:srgbClr val="F4F8FB">
+                        <a:alpha val="100000"/>
                       </a:srgbClr>
                     </a:solidFill>
                   </a:tcPr>
@@ -11873,8 +12160,8 @@
                       <a:prstDash val="solid"/>
                     </a:lnB>
                     <a:solidFill>
-                      <a:srgbClr val="FFFFFF">
-                        <a:alpha val="0"/>
+                      <a:srgbClr val="F4F8FB">
+                        <a:alpha val="100000"/>
                       </a:srgbClr>
                     </a:solidFill>
                   </a:tcPr>
@@ -11932,8 +12219,8 @@
                       <a:prstDash val="solid"/>
                     </a:lnB>
                     <a:solidFill>
-                      <a:srgbClr val="F4F8FB">
-                        <a:alpha val="100000"/>
+                      <a:srgbClr val="FFFFFF">
+                        <a:alpha val="0"/>
                       </a:srgbClr>
                     </a:solidFill>
                   </a:tcPr>
@@ -11989,8 +12276,8 @@
                       <a:prstDash val="solid"/>
                     </a:lnB>
                     <a:solidFill>
-                      <a:srgbClr val="F4F8FB">
-                        <a:alpha val="100000"/>
+                      <a:srgbClr val="FFFFFF">
+                        <a:alpha val="0"/>
                       </a:srgbClr>
                     </a:solidFill>
                   </a:tcPr>
@@ -12046,8 +12333,8 @@
                       <a:prstDash val="solid"/>
                     </a:lnB>
                     <a:solidFill>
-                      <a:srgbClr val="F4F8FB">
-                        <a:alpha val="100000"/>
+                      <a:srgbClr val="FFFFFF">
+                        <a:alpha val="0"/>
                       </a:srgbClr>
                     </a:solidFill>
                   </a:tcPr>
@@ -12103,8 +12390,8 @@
                       <a:prstDash val="solid"/>
                     </a:lnB>
                     <a:solidFill>
-                      <a:srgbClr val="F4F8FB">
-                        <a:alpha val="100000"/>
+                      <a:srgbClr val="FFFFFF">
+                        <a:alpha val="0"/>
                       </a:srgbClr>
                     </a:solidFill>
                   </a:tcPr>
@@ -12160,8 +12447,8 @@
                       <a:prstDash val="solid"/>
                     </a:lnB>
                     <a:solidFill>
-                      <a:srgbClr val="F4F8FB">
-                        <a:alpha val="100000"/>
+                      <a:srgbClr val="FFFFFF">
+                        <a:alpha val="0"/>
                       </a:srgbClr>
                     </a:solidFill>
                   </a:tcPr>
@@ -12219,8 +12506,8 @@
                       <a:prstDash val="solid"/>
                     </a:lnB>
                     <a:solidFill>
-                      <a:srgbClr val="FFFFFF">
-                        <a:alpha val="0"/>
+                      <a:srgbClr val="F4F8FB">
+                        <a:alpha val="100000"/>
                       </a:srgbClr>
                     </a:solidFill>
                   </a:tcPr>
@@ -12276,8 +12563,8 @@
                       <a:prstDash val="solid"/>
                     </a:lnB>
                     <a:solidFill>
-                      <a:srgbClr val="FFFFFF">
-                        <a:alpha val="0"/>
+                      <a:srgbClr val="F4F8FB">
+                        <a:alpha val="100000"/>
                       </a:srgbClr>
                     </a:solidFill>
                   </a:tcPr>
@@ -12333,8 +12620,8 @@
                       <a:prstDash val="solid"/>
                     </a:lnB>
                     <a:solidFill>
-                      <a:srgbClr val="FFFFFF">
-                        <a:alpha val="0"/>
+                      <a:srgbClr val="F4F8FB">
+                        <a:alpha val="100000"/>
                       </a:srgbClr>
                     </a:solidFill>
                   </a:tcPr>
@@ -12390,8 +12677,8 @@
                       <a:prstDash val="solid"/>
                     </a:lnB>
                     <a:solidFill>
-                      <a:srgbClr val="FFFFFF">
-                        <a:alpha val="0"/>
+                      <a:srgbClr val="F4F8FB">
+                        <a:alpha val="100000"/>
                       </a:srgbClr>
                     </a:solidFill>
                   </a:tcPr>
@@ -12447,8 +12734,8 @@
                       <a:prstDash val="solid"/>
                     </a:lnB>
                     <a:solidFill>
-                      <a:srgbClr val="FFFFFF">
-                        <a:alpha val="0"/>
+                      <a:srgbClr val="F4F8FB">
+                        <a:alpha val="100000"/>
                       </a:srgbClr>
                     </a:solidFill>
                   </a:tcPr>
@@ -12506,8 +12793,8 @@
                       <a:prstDash val="solid"/>
                     </a:lnB>
                     <a:solidFill>
-                      <a:srgbClr val="F4F8FB">
-                        <a:alpha val="100000"/>
+                      <a:srgbClr val="FFFFFF">
+                        <a:alpha val="0"/>
                       </a:srgbClr>
                     </a:solidFill>
                   </a:tcPr>
@@ -12563,8 +12850,8 @@
                       <a:prstDash val="solid"/>
                     </a:lnB>
                     <a:solidFill>
-                      <a:srgbClr val="F4F8FB">
-                        <a:alpha val="100000"/>
+                      <a:srgbClr val="FFFFFF">
+                        <a:alpha val="0"/>
                       </a:srgbClr>
                     </a:solidFill>
                   </a:tcPr>
@@ -12620,8 +12907,8 @@
                       <a:prstDash val="solid"/>
                     </a:lnB>
                     <a:solidFill>
-                      <a:srgbClr val="F4F8FB">
-                        <a:alpha val="100000"/>
+                      <a:srgbClr val="FFFFFF">
+                        <a:alpha val="0"/>
                       </a:srgbClr>
                     </a:solidFill>
                   </a:tcPr>
@@ -12677,8 +12964,8 @@
                       <a:prstDash val="solid"/>
                     </a:lnB>
                     <a:solidFill>
-                      <a:srgbClr val="F4F8FB">
-                        <a:alpha val="100000"/>
+                      <a:srgbClr val="FFFFFF">
+                        <a:alpha val="0"/>
                       </a:srgbClr>
                     </a:solidFill>
                   </a:tcPr>
@@ -12734,8 +13021,8 @@
                       <a:prstDash val="solid"/>
                     </a:lnB>
                     <a:solidFill>
-                      <a:srgbClr val="F4F8FB">
-                        <a:alpha val="100000"/>
+                      <a:srgbClr val="FFFFFF">
+                        <a:alpha val="0"/>
                       </a:srgbClr>
                     </a:solidFill>
                   </a:tcPr>
@@ -12793,8 +13080,8 @@
                       <a:prstDash val="solid"/>
                     </a:lnB>
                     <a:solidFill>
-                      <a:srgbClr val="FFFFFF">
-                        <a:alpha val="0"/>
+                      <a:srgbClr val="F4F8FB">
+                        <a:alpha val="100000"/>
                       </a:srgbClr>
                     </a:solidFill>
                   </a:tcPr>
@@ -12850,8 +13137,8 @@
                       <a:prstDash val="solid"/>
                     </a:lnB>
                     <a:solidFill>
-                      <a:srgbClr val="FFFFFF">
-                        <a:alpha val="0"/>
+                      <a:srgbClr val="F4F8FB">
+                        <a:alpha val="100000"/>
                       </a:srgbClr>
                     </a:solidFill>
                   </a:tcPr>
@@ -12907,8 +13194,8 @@
                       <a:prstDash val="solid"/>
                     </a:lnB>
                     <a:solidFill>
-                      <a:srgbClr val="FFFFFF">
-                        <a:alpha val="0"/>
+                      <a:srgbClr val="F4F8FB">
+                        <a:alpha val="100000"/>
                       </a:srgbClr>
                     </a:solidFill>
                   </a:tcPr>
@@ -12964,8 +13251,8 @@
                       <a:prstDash val="solid"/>
                     </a:lnB>
                     <a:solidFill>
-                      <a:srgbClr val="FFFFFF">
-                        <a:alpha val="0"/>
+                      <a:srgbClr val="F4F8FB">
+                        <a:alpha val="100000"/>
                       </a:srgbClr>
                     </a:solidFill>
                   </a:tcPr>
@@ -13021,8 +13308,8 @@
                       <a:prstDash val="solid"/>
                     </a:lnB>
                     <a:solidFill>
-                      <a:srgbClr val="FFFFFF">
-                        <a:alpha val="0"/>
+                      <a:srgbClr val="F4F8FB">
+                        <a:alpha val="100000"/>
                       </a:srgbClr>
                     </a:solidFill>
                   </a:tcPr>
@@ -13080,8 +13367,8 @@
                       <a:prstDash val="solid"/>
                     </a:lnB>
                     <a:solidFill>
-                      <a:srgbClr val="F4F8FB">
-                        <a:alpha val="100000"/>
+                      <a:srgbClr val="FFFFFF">
+                        <a:alpha val="0"/>
                       </a:srgbClr>
                     </a:solidFill>
                   </a:tcPr>
@@ -13137,8 +13424,8 @@
                       <a:prstDash val="solid"/>
                     </a:lnB>
                     <a:solidFill>
-                      <a:srgbClr val="F4F8FB">
-                        <a:alpha val="100000"/>
+                      <a:srgbClr val="FFFFFF">
+                        <a:alpha val="0"/>
                       </a:srgbClr>
                     </a:solidFill>
                   </a:tcPr>
@@ -13194,8 +13481,8 @@
                       <a:prstDash val="solid"/>
                     </a:lnB>
                     <a:solidFill>
-                      <a:srgbClr val="F4F8FB">
-                        <a:alpha val="100000"/>
+                      <a:srgbClr val="FFFFFF">
+                        <a:alpha val="0"/>
                       </a:srgbClr>
                     </a:solidFill>
                   </a:tcPr>
@@ -13251,8 +13538,8 @@
                       <a:prstDash val="solid"/>
                     </a:lnB>
                     <a:solidFill>
-                      <a:srgbClr val="F4F8FB">
-                        <a:alpha val="100000"/>
+                      <a:srgbClr val="FFFFFF">
+                        <a:alpha val="0"/>
                       </a:srgbClr>
                     </a:solidFill>
                   </a:tcPr>
@@ -13308,8 +13595,8 @@
                       <a:prstDash val="solid"/>
                     </a:lnB>
                     <a:solidFill>
-                      <a:srgbClr val="F4F8FB">
-                        <a:alpha val="100000"/>
+                      <a:srgbClr val="FFFFFF">
+                        <a:alpha val="0"/>
                       </a:srgbClr>
                     </a:solidFill>
                   </a:tcPr>
@@ -13367,8 +13654,8 @@
                       <a:prstDash val="solid"/>
                     </a:lnB>
                     <a:solidFill>
-                      <a:srgbClr val="FFFFFF">
-                        <a:alpha val="0"/>
+                      <a:srgbClr val="F4F8FB">
+                        <a:alpha val="100000"/>
                       </a:srgbClr>
                     </a:solidFill>
                   </a:tcPr>
@@ -13424,8 +13711,8 @@
                       <a:prstDash val="solid"/>
                     </a:lnB>
                     <a:solidFill>
-                      <a:srgbClr val="FFFFFF">
-                        <a:alpha val="0"/>
+                      <a:srgbClr val="F4F8FB">
+                        <a:alpha val="100000"/>
                       </a:srgbClr>
                     </a:solidFill>
                   </a:tcPr>
@@ -13481,8 +13768,8 @@
                       <a:prstDash val="solid"/>
                     </a:lnB>
                     <a:solidFill>
-                      <a:srgbClr val="FFFFFF">
-                        <a:alpha val="0"/>
+                      <a:srgbClr val="F4F8FB">
+                        <a:alpha val="100000"/>
                       </a:srgbClr>
                     </a:solidFill>
                   </a:tcPr>
@@ -13538,8 +13825,8 @@
                       <a:prstDash val="solid"/>
                     </a:lnB>
                     <a:solidFill>
-                      <a:srgbClr val="FFFFFF">
-                        <a:alpha val="0"/>
+                      <a:srgbClr val="F4F8FB">
+                        <a:alpha val="100000"/>
                       </a:srgbClr>
                     </a:solidFill>
                   </a:tcPr>
@@ -13595,8 +13882,8 @@
                       <a:prstDash val="solid"/>
                     </a:lnB>
                     <a:solidFill>
-                      <a:srgbClr val="FFFFFF">
-                        <a:alpha val="0"/>
+                      <a:srgbClr val="F4F8FB">
+                        <a:alpha val="100000"/>
                       </a:srgbClr>
                     </a:solidFill>
                   </a:tcPr>
@@ -13654,8 +13941,8 @@
                       <a:prstDash val="solid"/>
                     </a:lnB>
                     <a:solidFill>
-                      <a:srgbClr val="F4F8FB">
-                        <a:alpha val="100000"/>
+                      <a:srgbClr val="FFFFFF">
+                        <a:alpha val="0"/>
                       </a:srgbClr>
                     </a:solidFill>
                   </a:tcPr>
@@ -13711,8 +13998,8 @@
                       <a:prstDash val="solid"/>
                     </a:lnB>
                     <a:solidFill>
-                      <a:srgbClr val="F4F8FB">
-                        <a:alpha val="100000"/>
+                      <a:srgbClr val="FFFFFF">
+                        <a:alpha val="0"/>
                       </a:srgbClr>
                     </a:solidFill>
                   </a:tcPr>
@@ -13768,8 +14055,8 @@
                       <a:prstDash val="solid"/>
                     </a:lnB>
                     <a:solidFill>
-                      <a:srgbClr val="F4F8FB">
-                        <a:alpha val="100000"/>
+                      <a:srgbClr val="FFFFFF">
+                        <a:alpha val="0"/>
                       </a:srgbClr>
                     </a:solidFill>
                   </a:tcPr>
@@ -13803,7 +14090,7 @@
                           <a:ea typeface="Helvetica Neue"/>
                           <a:sym typeface="Helvetica Neue"/>
                         </a:rPr>
-                        <a:t>19</a:t>
+                        <a:t>20</a:t>
                       </a:r>
                     </a:p>
                   </a:txBody>
@@ -13825,8 +14112,8 @@
                       <a:prstDash val="solid"/>
                     </a:lnB>
                     <a:solidFill>
-                      <a:srgbClr val="F4F8FB">
-                        <a:alpha val="100000"/>
+                      <a:srgbClr val="FFFFFF">
+                        <a:alpha val="0"/>
                       </a:srgbClr>
                     </a:solidFill>
                   </a:tcPr>
@@ -13882,293 +14169,6 @@
                       <a:prstDash val="solid"/>
                     </a:lnB>
                     <a:solidFill>
-                      <a:srgbClr val="F4F8FB">
-                        <a:alpha val="100000"/>
-                      </a:srgbClr>
-                    </a:solidFill>
-                  </a:tcPr>
-                </a:tc>
-              </a:tr>
-              <a:tr h="401320">
-                <a:tc>
-                  <a:txBody>
-                    <a:bodyPr/>
-                    <a:lstStyle/>
-                    <a:p>
-                      <a:pPr algn="l" marL="63500" marR="63500">
-                        <a:lnSpc>
-                          <a:spcPct val="100000"/>
-                        </a:lnSpc>
-                        <a:spcBef>
-                          <a:spcPts val="500"/>
-                        </a:spcBef>
-                        <a:spcAft>
-                          <a:spcPts val="500"/>
-                        </a:spcAft>
-                        <a:buNone/>
-                      </a:pPr>
-                      <a:r>
-                        <a:rPr cap="none" sz="1200" i="0" b="0" u="none" strike="noStrike">
-                          <a:solidFill>
-                            <a:srgbClr val="5B6770">
-                              <a:alpha val="100000"/>
-                            </a:srgbClr>
-                          </a:solidFill>
-                          <a:latin typeface="Helvetica Neue"/>
-                          <a:cs typeface="Helvetica Neue"/>
-                          <a:ea typeface="Helvetica Neue"/>
-                          <a:sym typeface="Helvetica Neue"/>
-                        </a:rPr>
-                        <a:t>2-fluoro-2-oxo-PCPr</a:t>
-                      </a:r>
-                    </a:p>
-                  </a:txBody>
-                  <a:tcPr anchor="ctr" marB="63500" marT="63500" marR="0" marL="0">
-                    <a:lnL algn="ctr" cmpd="sng" cap="flat" w="0">
-                      <a:noFill/>
-                      <a:prstDash val="solid"/>
-                    </a:lnL>
-                    <a:lnR algn="ctr" cmpd="sng" cap="flat" w="0">
-                      <a:noFill/>
-                      <a:prstDash val="solid"/>
-                    </a:lnR>
-                    <a:lnT algn="ctr" cmpd="sng" cap="flat" w="0">
-                      <a:noFill/>
-                      <a:prstDash val="solid"/>
-                    </a:lnT>
-                    <a:lnB algn="ctr" cmpd="sng" cap="flat" w="0">
-                      <a:noFill/>
-                      <a:prstDash val="solid"/>
-                    </a:lnB>
-                    <a:solidFill>
-                      <a:srgbClr val="FFFFFF">
-                        <a:alpha val="0"/>
-                      </a:srgbClr>
-                    </a:solidFill>
-                  </a:tcPr>
-                </a:tc>
-                <a:tc>
-                  <a:txBody>
-                    <a:bodyPr/>
-                    <a:lstStyle/>
-                    <a:p>
-                      <a:pPr algn="l" marL="63500" marR="63500">
-                        <a:lnSpc>
-                          <a:spcPct val="100000"/>
-                        </a:lnSpc>
-                        <a:spcBef>
-                          <a:spcPts val="500"/>
-                        </a:spcBef>
-                        <a:spcAft>
-                          <a:spcPts val="500"/>
-                        </a:spcAft>
-                        <a:buNone/>
-                      </a:pPr>
-                      <a:r>
-                        <a:rPr cap="none" sz="1200" i="0" b="0" u="none" strike="noStrike">
-                          <a:solidFill>
-                            <a:srgbClr val="5B6770">
-                              <a:alpha val="100000"/>
-                            </a:srgbClr>
-                          </a:solidFill>
-                          <a:latin typeface="Helvetica Neue"/>
-                          <a:cs typeface="Helvetica Neue"/>
-                          <a:ea typeface="Helvetica Neue"/>
-                          <a:sym typeface="Helvetica Neue"/>
-                        </a:rPr>
-                        <a:t>16 Jun 2026</a:t>
-                      </a:r>
-                    </a:p>
-                  </a:txBody>
-                  <a:tcPr anchor="ctr" marB="63500" marT="63500" marR="0" marL="0">
-                    <a:lnL algn="ctr" cmpd="sng" cap="flat" w="0">
-                      <a:noFill/>
-                      <a:prstDash val="solid"/>
-                    </a:lnL>
-                    <a:lnR algn="ctr" cmpd="sng" cap="flat" w="0">
-                      <a:noFill/>
-                      <a:prstDash val="solid"/>
-                    </a:lnR>
-                    <a:lnT algn="ctr" cmpd="sng" cap="flat" w="0">
-                      <a:noFill/>
-                      <a:prstDash val="solid"/>
-                    </a:lnT>
-                    <a:lnB algn="ctr" cmpd="sng" cap="flat" w="0">
-                      <a:noFill/>
-                      <a:prstDash val="solid"/>
-                    </a:lnB>
-                    <a:solidFill>
-                      <a:srgbClr val="FFFFFF">
-                        <a:alpha val="0"/>
-                      </a:srgbClr>
-                    </a:solidFill>
-                  </a:tcPr>
-                </a:tc>
-                <a:tc>
-                  <a:txBody>
-                    <a:bodyPr/>
-                    <a:lstStyle/>
-                    <a:p>
-                      <a:pPr algn="l" marL="63500" marR="63500">
-                        <a:lnSpc>
-                          <a:spcPct val="100000"/>
-                        </a:lnSpc>
-                        <a:spcBef>
-                          <a:spcPts val="500"/>
-                        </a:spcBef>
-                        <a:spcAft>
-                          <a:spcPts val="500"/>
-                        </a:spcAft>
-                        <a:buNone/>
-                      </a:pPr>
-                      <a:r>
-                        <a:rPr cap="none" sz="1200" i="0" b="0" u="none" strike="noStrike">
-                          <a:solidFill>
-                            <a:srgbClr val="5B6770">
-                              <a:alpha val="100000"/>
-                            </a:srgbClr>
-                          </a:solidFill>
-                          <a:latin typeface="Helvetica Neue"/>
-                          <a:cs typeface="Helvetica Neue"/>
-                          <a:ea typeface="Helvetica Neue"/>
-                          <a:sym typeface="Helvetica Neue"/>
-                        </a:rPr>
-                        <a:t>primary</a:t>
-                      </a:r>
-                    </a:p>
-                  </a:txBody>
-                  <a:tcPr anchor="ctr" marB="63500" marT="63500" marR="0" marL="0">
-                    <a:lnL algn="ctr" cmpd="sng" cap="flat" w="0">
-                      <a:noFill/>
-                      <a:prstDash val="solid"/>
-                    </a:lnL>
-                    <a:lnR algn="ctr" cmpd="sng" cap="flat" w="0">
-                      <a:noFill/>
-                      <a:prstDash val="solid"/>
-                    </a:lnR>
-                    <a:lnT algn="ctr" cmpd="sng" cap="flat" w="0">
-                      <a:noFill/>
-                      <a:prstDash val="solid"/>
-                    </a:lnT>
-                    <a:lnB algn="ctr" cmpd="sng" cap="flat" w="0">
-                      <a:noFill/>
-                      <a:prstDash val="solid"/>
-                    </a:lnB>
-                    <a:solidFill>
-                      <a:srgbClr val="FFFFFF">
-                        <a:alpha val="0"/>
-                      </a:srgbClr>
-                    </a:solidFill>
-                  </a:tcPr>
-                </a:tc>
-                <a:tc>
-                  <a:txBody>
-                    <a:bodyPr/>
-                    <a:lstStyle/>
-                    <a:p>
-                      <a:pPr algn="r" marL="63500" marR="63500">
-                        <a:lnSpc>
-                          <a:spcPct val="100000"/>
-                        </a:lnSpc>
-                        <a:spcBef>
-                          <a:spcPts val="500"/>
-                        </a:spcBef>
-                        <a:spcAft>
-                          <a:spcPts val="500"/>
-                        </a:spcAft>
-                        <a:buNone/>
-                      </a:pPr>
-                      <a:r>
-                        <a:rPr cap="none" sz="1200" i="0" b="0" u="none" strike="noStrike">
-                          <a:solidFill>
-                            <a:srgbClr val="5B6770">
-                              <a:alpha val="100000"/>
-                            </a:srgbClr>
-                          </a:solidFill>
-                          <a:latin typeface="Helvetica Neue"/>
-                          <a:cs typeface="Helvetica Neue"/>
-                          <a:ea typeface="Helvetica Neue"/>
-                          <a:sym typeface="Helvetica Neue"/>
-                        </a:rPr>
-                        <a:t>1</a:t>
-                      </a:r>
-                    </a:p>
-                  </a:txBody>
-                  <a:tcPr anchor="ctr" marB="63500" marT="63500" marR="0" marL="0">
-                    <a:lnL algn="ctr" cmpd="sng" cap="flat" w="0">
-                      <a:noFill/>
-                      <a:prstDash val="solid"/>
-                    </a:lnL>
-                    <a:lnR algn="ctr" cmpd="sng" cap="flat" w="0">
-                      <a:noFill/>
-                      <a:prstDash val="solid"/>
-                    </a:lnR>
-                    <a:lnT algn="ctr" cmpd="sng" cap="flat" w="0">
-                      <a:noFill/>
-                      <a:prstDash val="solid"/>
-                    </a:lnT>
-                    <a:lnB algn="ctr" cmpd="sng" cap="flat" w="0">
-                      <a:noFill/>
-                      <a:prstDash val="solid"/>
-                    </a:lnB>
-                    <a:solidFill>
-                      <a:srgbClr val="FFFFFF">
-                        <a:alpha val="0"/>
-                      </a:srgbClr>
-                    </a:solidFill>
-                  </a:tcPr>
-                </a:tc>
-                <a:tc>
-                  <a:txBody>
-                    <a:bodyPr/>
-                    <a:lstStyle/>
-                    <a:p>
-                      <a:pPr algn="l" marL="63500" marR="63500">
-                        <a:lnSpc>
-                          <a:spcPct val="100000"/>
-                        </a:lnSpc>
-                        <a:spcBef>
-                          <a:spcPts val="500"/>
-                        </a:spcBef>
-                        <a:spcAft>
-                          <a:spcPts val="500"/>
-                        </a:spcAft>
-                        <a:buNone/>
-                      </a:pPr>
-                      <a:r>
-                        <a:rPr cap="none" sz="1200" i="0" b="0" u="none" strike="noStrike">
-                          <a:solidFill>
-                            <a:srgbClr val="5B6770">
-                              <a:alpha val="100000"/>
-                            </a:srgbClr>
-                          </a:solidFill>
-                          <a:latin typeface="Helvetica Neue"/>
-                          <a:cs typeface="Helvetica Neue"/>
-                          <a:ea typeface="Helvetica Neue"/>
-                          <a:sym typeface="Helvetica Neue"/>
-                        </a:rPr>
-                        <a:t>603838</a:t>
-                      </a:r>
-                    </a:p>
-                  </a:txBody>
-                  <a:tcPr anchor="ctr" marB="63500" marT="63500" marR="0" marL="0">
-                    <a:lnL algn="ctr" cmpd="sng" cap="flat" w="0">
-                      <a:noFill/>
-                      <a:prstDash val="solid"/>
-                    </a:lnL>
-                    <a:lnR algn="ctr" cmpd="sng" cap="flat" w="0">
-                      <a:noFill/>
-                      <a:prstDash val="solid"/>
-                    </a:lnR>
-                    <a:lnT algn="ctr" cmpd="sng" cap="flat" w="0">
-                      <a:noFill/>
-                      <a:prstDash val="solid"/>
-                    </a:lnT>
-                    <a:lnB algn="ctr" cmpd="sng" cap="flat" w="0">
-                      <a:noFill/>
-                      <a:prstDash val="solid"/>
-                    </a:lnB>
-                    <a:solidFill>
                       <a:srgbClr val="FFFFFF">
                         <a:alpha val="0"/>
                       </a:srgbClr>
@@ -14206,7 +14206,7 @@
                           <a:ea typeface="Helvetica Neue"/>
                           <a:sym typeface="Helvetica Neue"/>
                         </a:rPr>
-                        <a:t>2-oxo-PCE (O-PCE)</a:t>
+                        <a:t>2-fluoro-2-oxo-PCPr</a:t>
                       </a:r>
                     </a:p>
                   </a:txBody>
@@ -18510,7 +18510,7 @@
                           <a:ea typeface="Helvetica Neue"/>
                           <a:sym typeface="Helvetica Neue"/>
                         </a:rPr>
-                        <a:t>1,417</a:t>
+                        <a:t>1,424</a:t>
                       </a:r>
                     </a:p>
                   </a:txBody>
@@ -18626,7 +18626,7 @@
                           <a:ea typeface="Helvetica Neue"/>
                           <a:sym typeface="Helvetica Neue"/>
                         </a:rPr>
-                        <a:t>432</a:t>
+                        <a:t>433</a:t>
                       </a:r>
                     </a:p>
                   </a:txBody>
@@ -20591,7 +20591,7 @@
                           <a:ea typeface="Helvetica Neue"/>
                           <a:sym typeface="Helvetica Neue"/>
                         </a:rPr>
-                        <a:t>1,627</a:t>
+                        <a:t>1,634</a:t>
                       </a:r>
                     </a:p>
                   </a:txBody>
@@ -20821,7 +20821,7 @@
                           <a:ea typeface="Helvetica Neue"/>
                           <a:sym typeface="Helvetica Neue"/>
                         </a:rPr>
-                        <a:t>496</a:t>
+                        <a:t>497</a:t>
                       </a:r>
                     </a:p>
                   </a:txBody>
@@ -22151,7 +22151,7 @@
                           <a:ea typeface="Helvetica Neue"/>
                           <a:sym typeface="Helvetica Neue"/>
                         </a:rPr>
-                        <a:t>98 / month</a:t>
+                        <a:t>100 / month</a:t>
                       </a:r>
                     </a:p>
                   </a:txBody>
@@ -22208,7 +22208,7 @@
                           <a:ea typeface="Helvetica Neue"/>
                           <a:sym typeface="Helvetica Neue"/>
                         </a:rPr>
-                        <a:t>-41%</a:t>
+                        <a:t>-40%</a:t>
                       </a:r>
                     </a:p>
                   </a:txBody>
@@ -22324,7 +22324,7 @@
                           <a:ea typeface="Helvetica Neue"/>
                           <a:sym typeface="Helvetica Neue"/>
                         </a:rPr>
-                        <a:t>714</a:t>
+                        <a:t>720</a:t>
                       </a:r>
                     </a:p>
                   </a:txBody>
@@ -22381,7 +22381,7 @@
                           <a:ea typeface="Helvetica Neue"/>
                           <a:sym typeface="Helvetica Neue"/>
                         </a:rPr>
-                        <a:t>+7%</a:t>
+                        <a:t>+8%</a:t>
                       </a:r>
                     </a:p>
                   </a:txBody>
@@ -22497,7 +22497,7 @@
                           <a:ea typeface="Helvetica Neue"/>
                           <a:sym typeface="Helvetica Neue"/>
                         </a:rPr>
-                        <a:t>714</a:t>
+                        <a:t>720</a:t>
                       </a:r>
                     </a:p>
                   </a:txBody>
@@ -22554,7 +22554,7 @@
                           <a:ea typeface="Helvetica Neue"/>
                           <a:sym typeface="Helvetica Neue"/>
                         </a:rPr>
-                        <a:t>+18%</a:t>
+                        <a:t>+19%</a:t>
                       </a:r>
                     </a:p>
                   </a:txBody>
@@ -22670,7 +22670,7 @@
                           <a:ea typeface="Helvetica Neue"/>
                           <a:sym typeface="Helvetica Neue"/>
                         </a:rPr>
-                        <a:t>41</a:t>
+                        <a:t>40</a:t>
                       </a:r>
                     </a:p>
                   </a:txBody>
@@ -22727,7 +22727,7 @@
                           <a:ea typeface="Helvetica Neue"/>
                           <a:sym typeface="Helvetica Neue"/>
                         </a:rPr>
-                        <a:t>-32%</a:t>
+                        <a:t>-33%</a:t>
                       </a:r>
                     </a:p>
                   </a:txBody>
@@ -22843,7 +22843,7 @@
                           <a:ea typeface="Helvetica Neue"/>
                           <a:sym typeface="Helvetica Neue"/>
                         </a:rPr>
-                        <a:t>51</a:t>
+                        <a:t>50</a:t>
                       </a:r>
                     </a:p>
                   </a:txBody>
@@ -22900,7 +22900,7 @@
                           <a:ea typeface="Helvetica Neue"/>
                           <a:sym typeface="Helvetica Neue"/>
                         </a:rPr>
-                        <a:t>-43%</a:t>
+                        <a:t>-44%</a:t>
                       </a:r>
                     </a:p>
                   </a:txBody>
@@ -23020,7 +23020,7 @@
                           <a:ea typeface="Helvetica Neue"/>
                           <a:sym typeface="Helvetica Neue"/>
                         </a:rPr>
-                        <a:t>418</a:t>
+                        <a:t>420</a:t>
                       </a:r>
                     </a:p>
                   </a:txBody>
@@ -23423,7 +23423,7 @@
                           <a:ea typeface="Helvetica Neue"/>
                           <a:sym typeface="Helvetica Neue"/>
                         </a:rPr>
-                        <a:t>102</a:t>
+                        <a:t>110</a:t>
                       </a:r>
                     </a:p>
                   </a:txBody>
@@ -23480,7 +23480,7 @@
                           <a:ea typeface="Helvetica Neue"/>
                           <a:sym typeface="Helvetica Neue"/>
                         </a:rPr>
-                        <a:t>+0%</a:t>
+                        <a:t>+8%</a:t>
                       </a:r>
                     </a:p>
                   </a:txBody>
@@ -24115,7 +24115,7 @@
                           <a:ea typeface="Helvetica Neue"/>
                           <a:sym typeface="Helvetica Neue"/>
                         </a:rPr>
-                        <a:t>31</a:t>
+                        <a:t>30</a:t>
                       </a:r>
                     </a:p>
                   </a:txBody>
@@ -24172,7 +24172,7 @@
                           <a:ea typeface="Helvetica Neue"/>
                           <a:sym typeface="Helvetica Neue"/>
                         </a:rPr>
-                        <a:t>+70%</a:t>
+                        <a:t>+67%</a:t>
                       </a:r>
                     </a:p>
                   </a:txBody>
@@ -24292,7 +24292,7 @@
                           <a:ea typeface="Helvetica Neue"/>
                           <a:sym typeface="Helvetica Neue"/>
                         </a:rPr>
-                        <a:t>48</a:t>
+                        <a:t>47</a:t>
                       </a:r>
                     </a:p>
                   </a:txBody>
@@ -24353,7 +24353,7 @@
                           <a:ea typeface="Helvetica Neue"/>
                           <a:sym typeface="Helvetica Neue"/>
                         </a:rPr>
-                        <a:t>-5%</a:t>
+                        <a:t>-8%</a:t>
                       </a:r>
                     </a:p>
                   </a:txBody>
@@ -24942,6 +24942,293 @@
                           <a:ea typeface="Helvetica Neue"/>
                           <a:sym typeface="Helvetica Neue"/>
                         </a:rPr>
+                        <a:t>chlorphenamine</a:t>
+                      </a:r>
+                    </a:p>
+                  </a:txBody>
+                  <a:tcPr anchor="ctr" marB="63500" marT="63500" marR="0" marL="0">
+                    <a:lnL algn="ctr" cmpd="sng" cap="flat" w="0">
+                      <a:noFill/>
+                      <a:prstDash val="solid"/>
+                    </a:lnL>
+                    <a:lnR algn="ctr" cmpd="sng" cap="flat" w="0">
+                      <a:noFill/>
+                      <a:prstDash val="solid"/>
+                    </a:lnR>
+                    <a:lnT algn="ctr" cmpd="sng" cap="flat" w="0">
+                      <a:noFill/>
+                      <a:prstDash val="solid"/>
+                    </a:lnT>
+                    <a:lnB algn="ctr" cmpd="sng" cap="flat" w="0">
+                      <a:noFill/>
+                      <a:prstDash val="solid"/>
+                    </a:lnB>
+                    <a:solidFill>
+                      <a:srgbClr val="FFFFFF">
+                        <a:alpha val="0"/>
+                      </a:srgbClr>
+                    </a:solidFill>
+                  </a:tcPr>
+                </a:tc>
+                <a:tc>
+                  <a:txBody>
+                    <a:bodyPr/>
+                    <a:lstStyle/>
+                    <a:p>
+                      <a:pPr algn="l" marL="63500" marR="63500">
+                        <a:lnSpc>
+                          <a:spcPct val="100000"/>
+                        </a:lnSpc>
+                        <a:spcBef>
+                          <a:spcPts val="500"/>
+                        </a:spcBef>
+                        <a:spcAft>
+                          <a:spcPts val="500"/>
+                        </a:spcAft>
+                        <a:buNone/>
+                      </a:pPr>
+                      <a:r>
+                        <a:rPr cap="none" sz="1200" i="0" b="0" u="none" strike="noStrike">
+                          <a:solidFill>
+                            <a:srgbClr val="5B6770">
+                              <a:alpha val="100000"/>
+                            </a:srgbClr>
+                          </a:solidFill>
+                          <a:latin typeface="Helvetica Neue"/>
+                          <a:cs typeface="Helvetica Neue"/>
+                          <a:ea typeface="Helvetica Neue"/>
+                          <a:sym typeface="Helvetica Neue"/>
+                        </a:rPr>
+                        <a:t>02 Sep 2026</a:t>
+                      </a:r>
+                    </a:p>
+                  </a:txBody>
+                  <a:tcPr anchor="ctr" marB="63500" marT="63500" marR="0" marL="0">
+                    <a:lnL algn="ctr" cmpd="sng" cap="flat" w="0">
+                      <a:noFill/>
+                      <a:prstDash val="solid"/>
+                    </a:lnL>
+                    <a:lnR algn="ctr" cmpd="sng" cap="flat" w="0">
+                      <a:noFill/>
+                      <a:prstDash val="solid"/>
+                    </a:lnR>
+                    <a:lnT algn="ctr" cmpd="sng" cap="flat" w="0">
+                      <a:noFill/>
+                      <a:prstDash val="solid"/>
+                    </a:lnT>
+                    <a:lnB algn="ctr" cmpd="sng" cap="flat" w="0">
+                      <a:noFill/>
+                      <a:prstDash val="solid"/>
+                    </a:lnB>
+                    <a:solidFill>
+                      <a:srgbClr val="FFFFFF">
+                        <a:alpha val="0"/>
+                      </a:srgbClr>
+                    </a:solidFill>
+                  </a:tcPr>
+                </a:tc>
+                <a:tc>
+                  <a:txBody>
+                    <a:bodyPr/>
+                    <a:lstStyle/>
+                    <a:p>
+                      <a:pPr algn="l" marL="63500" marR="63500">
+                        <a:lnSpc>
+                          <a:spcPct val="100000"/>
+                        </a:lnSpc>
+                        <a:spcBef>
+                          <a:spcPts val="500"/>
+                        </a:spcBef>
+                        <a:spcAft>
+                          <a:spcPts val="500"/>
+                        </a:spcAft>
+                        <a:buNone/>
+                      </a:pPr>
+                      <a:r>
+                        <a:rPr cap="none" sz="1200" i="0" b="0" u="none" strike="noStrike">
+                          <a:solidFill>
+                            <a:srgbClr val="5B6770">
+                              <a:alpha val="100000"/>
+                            </a:srgbClr>
+                          </a:solidFill>
+                          <a:latin typeface="Helvetica Neue"/>
+                          <a:cs typeface="Helvetica Neue"/>
+                          <a:ea typeface="Helvetica Neue"/>
+                          <a:sym typeface="Helvetica Neue"/>
+                        </a:rPr>
+                        <a:t>trace</a:t>
+                      </a:r>
+                    </a:p>
+                  </a:txBody>
+                  <a:tcPr anchor="ctr" marB="63500" marT="63500" marR="0" marL="0">
+                    <a:lnL algn="ctr" cmpd="sng" cap="flat" w="0">
+                      <a:noFill/>
+                      <a:prstDash val="solid"/>
+                    </a:lnL>
+                    <a:lnR algn="ctr" cmpd="sng" cap="flat" w="0">
+                      <a:noFill/>
+                      <a:prstDash val="solid"/>
+                    </a:lnR>
+                    <a:lnT algn="ctr" cmpd="sng" cap="flat" w="0">
+                      <a:noFill/>
+                      <a:prstDash val="solid"/>
+                    </a:lnT>
+                    <a:lnB algn="ctr" cmpd="sng" cap="flat" w="0">
+                      <a:noFill/>
+                      <a:prstDash val="solid"/>
+                    </a:lnB>
+                    <a:solidFill>
+                      <a:srgbClr val="FFFFFF">
+                        <a:alpha val="0"/>
+                      </a:srgbClr>
+                    </a:solidFill>
+                  </a:tcPr>
+                </a:tc>
+                <a:tc>
+                  <a:txBody>
+                    <a:bodyPr/>
+                    <a:lstStyle/>
+                    <a:p>
+                      <a:pPr algn="r" marL="63500" marR="63500">
+                        <a:lnSpc>
+                          <a:spcPct val="100000"/>
+                        </a:lnSpc>
+                        <a:spcBef>
+                          <a:spcPts val="500"/>
+                        </a:spcBef>
+                        <a:spcAft>
+                          <a:spcPts val="500"/>
+                        </a:spcAft>
+                        <a:buNone/>
+                      </a:pPr>
+                      <a:r>
+                        <a:rPr cap="none" sz="1200" i="0" b="0" u="none" strike="noStrike">
+                          <a:solidFill>
+                            <a:srgbClr val="5B6770">
+                              <a:alpha val="100000"/>
+                            </a:srgbClr>
+                          </a:solidFill>
+                          <a:latin typeface="Helvetica Neue"/>
+                          <a:cs typeface="Helvetica Neue"/>
+                          <a:ea typeface="Helvetica Neue"/>
+                          <a:sym typeface="Helvetica Neue"/>
+                        </a:rPr>
+                        <a:t>1</a:t>
+                      </a:r>
+                    </a:p>
+                  </a:txBody>
+                  <a:tcPr anchor="ctr" marB="63500" marT="63500" marR="0" marL="0">
+                    <a:lnL algn="ctr" cmpd="sng" cap="flat" w="0">
+                      <a:noFill/>
+                      <a:prstDash val="solid"/>
+                    </a:lnL>
+                    <a:lnR algn="ctr" cmpd="sng" cap="flat" w="0">
+                      <a:noFill/>
+                      <a:prstDash val="solid"/>
+                    </a:lnR>
+                    <a:lnT algn="ctr" cmpd="sng" cap="flat" w="0">
+                      <a:noFill/>
+                      <a:prstDash val="solid"/>
+                    </a:lnT>
+                    <a:lnB algn="ctr" cmpd="sng" cap="flat" w="0">
+                      <a:noFill/>
+                      <a:prstDash val="solid"/>
+                    </a:lnB>
+                    <a:solidFill>
+                      <a:srgbClr val="FFFFFF">
+                        <a:alpha val="0"/>
+                      </a:srgbClr>
+                    </a:solidFill>
+                  </a:tcPr>
+                </a:tc>
+                <a:tc>
+                  <a:txBody>
+                    <a:bodyPr/>
+                    <a:lstStyle/>
+                    <a:p>
+                      <a:pPr algn="l" marL="63500" marR="63500">
+                        <a:lnSpc>
+                          <a:spcPct val="100000"/>
+                        </a:lnSpc>
+                        <a:spcBef>
+                          <a:spcPts val="500"/>
+                        </a:spcBef>
+                        <a:spcAft>
+                          <a:spcPts val="500"/>
+                        </a:spcAft>
+                        <a:buNone/>
+                      </a:pPr>
+                      <a:r>
+                        <a:rPr cap="none" sz="1200" i="0" b="0" u="none" strike="noStrike">
+                          <a:solidFill>
+                            <a:srgbClr val="5B6770">
+                              <a:alpha val="100000"/>
+                            </a:srgbClr>
+                          </a:solidFill>
+                          <a:latin typeface="Helvetica Neue"/>
+                          <a:cs typeface="Helvetica Neue"/>
+                          <a:ea typeface="Helvetica Neue"/>
+                          <a:sym typeface="Helvetica Neue"/>
+                        </a:rPr>
+                        <a:t>605053</a:t>
+                      </a:r>
+                    </a:p>
+                  </a:txBody>
+                  <a:tcPr anchor="ctr" marB="63500" marT="63500" marR="0" marL="0">
+                    <a:lnL algn="ctr" cmpd="sng" cap="flat" w="0">
+                      <a:noFill/>
+                      <a:prstDash val="solid"/>
+                    </a:lnL>
+                    <a:lnR algn="ctr" cmpd="sng" cap="flat" w="0">
+                      <a:noFill/>
+                      <a:prstDash val="solid"/>
+                    </a:lnR>
+                    <a:lnT algn="ctr" cmpd="sng" cap="flat" w="0">
+                      <a:noFill/>
+                      <a:prstDash val="solid"/>
+                    </a:lnT>
+                    <a:lnB algn="ctr" cmpd="sng" cap="flat" w="0">
+                      <a:noFill/>
+                      <a:prstDash val="solid"/>
+                    </a:lnB>
+                    <a:solidFill>
+                      <a:srgbClr val="FFFFFF">
+                        <a:alpha val="0"/>
+                      </a:srgbClr>
+                    </a:solidFill>
+                  </a:tcPr>
+                </a:tc>
+              </a:tr>
+              <a:tr h="401320">
+                <a:tc>
+                  <a:txBody>
+                    <a:bodyPr/>
+                    <a:lstStyle/>
+                    <a:p>
+                      <a:pPr algn="l" marL="63500" marR="63500">
+                        <a:lnSpc>
+                          <a:spcPct val="100000"/>
+                        </a:lnSpc>
+                        <a:spcBef>
+                          <a:spcPts val="500"/>
+                        </a:spcBef>
+                        <a:spcAft>
+                          <a:spcPts val="500"/>
+                        </a:spcAft>
+                        <a:buNone/>
+                      </a:pPr>
+                      <a:r>
+                        <a:rPr cap="none" sz="1200" i="0" b="0" u="none" strike="noStrike">
+                          <a:solidFill>
+                            <a:srgbClr val="5B6770">
+                              <a:alpha val="100000"/>
+                            </a:srgbClr>
+                          </a:solidFill>
+                          <a:latin typeface="Helvetica Neue"/>
+                          <a:cs typeface="Helvetica Neue"/>
+                          <a:ea typeface="Helvetica Neue"/>
+                          <a:sym typeface="Helvetica Neue"/>
+                        </a:rPr>
                         <a:t>delorazepam</a:t>
                       </a:r>
                     </a:p>
@@ -24964,8 +25251,8 @@
                       <a:prstDash val="solid"/>
                     </a:lnB>
                     <a:solidFill>
-                      <a:srgbClr val="FFFFFF">
-                        <a:alpha val="0"/>
+                      <a:srgbClr val="F4F8FB">
+                        <a:alpha val="100000"/>
                       </a:srgbClr>
                     </a:solidFill>
                   </a:tcPr>
@@ -25021,8 +25308,8 @@
                       <a:prstDash val="solid"/>
                     </a:lnB>
                     <a:solidFill>
-                      <a:srgbClr val="FFFFFF">
-                        <a:alpha val="0"/>
+                      <a:srgbClr val="F4F8FB">
+                        <a:alpha val="100000"/>
                       </a:srgbClr>
                     </a:solidFill>
                   </a:tcPr>
@@ -25078,8 +25365,8 @@
                       <a:prstDash val="solid"/>
                     </a:lnB>
                     <a:solidFill>
-                      <a:srgbClr val="FFFFFF">
-                        <a:alpha val="0"/>
+                      <a:srgbClr val="F4F8FB">
+                        <a:alpha val="100000"/>
                       </a:srgbClr>
                     </a:solidFill>
                   </a:tcPr>
@@ -25135,8 +25422,8 @@
                       <a:prstDash val="solid"/>
                     </a:lnB>
                     <a:solidFill>
-                      <a:srgbClr val="FFFFFF">
-                        <a:alpha val="0"/>
+                      <a:srgbClr val="F4F8FB">
+                        <a:alpha val="100000"/>
                       </a:srgbClr>
                     </a:solidFill>
                   </a:tcPr>
@@ -25192,8 +25479,8 @@
                       <a:prstDash val="solid"/>
                     </a:lnB>
                     <a:solidFill>
-                      <a:srgbClr val="FFFFFF">
-                        <a:alpha val="0"/>
+                      <a:srgbClr val="F4F8FB">
+                        <a:alpha val="100000"/>
                       </a:srgbClr>
                     </a:solidFill>
                   </a:tcPr>
@@ -25251,8 +25538,8 @@
                       <a:prstDash val="solid"/>
                     </a:lnB>
                     <a:solidFill>
-                      <a:srgbClr val="F4F8FB">
-                        <a:alpha val="100000"/>
+                      <a:srgbClr val="FFFFFF">
+                        <a:alpha val="0"/>
                       </a:srgbClr>
                     </a:solidFill>
                   </a:tcPr>
@@ -25308,8 +25595,8 @@
                       <a:prstDash val="solid"/>
                     </a:lnB>
                     <a:solidFill>
-                      <a:srgbClr val="F4F8FB">
-                        <a:alpha val="100000"/>
+                      <a:srgbClr val="FFFFFF">
+                        <a:alpha val="0"/>
                       </a:srgbClr>
                     </a:solidFill>
                   </a:tcPr>
@@ -25365,8 +25652,8 @@
                       <a:prstDash val="solid"/>
                     </a:lnB>
                     <a:solidFill>
-                      <a:srgbClr val="F4F8FB">
-                        <a:alpha val="100000"/>
+                      <a:srgbClr val="FFFFFF">
+                        <a:alpha val="0"/>
                       </a:srgbClr>
                     </a:solidFill>
                   </a:tcPr>
@@ -25422,8 +25709,8 @@
                       <a:prstDash val="solid"/>
                     </a:lnB>
                     <a:solidFill>
-                      <a:srgbClr val="F4F8FB">
-                        <a:alpha val="100000"/>
+                      <a:srgbClr val="FFFFFF">
+                        <a:alpha val="0"/>
                       </a:srgbClr>
                     </a:solidFill>
                   </a:tcPr>
@@ -25479,8 +25766,8 @@
                       <a:prstDash val="solid"/>
                     </a:lnB>
                     <a:solidFill>
-                      <a:srgbClr val="F4F8FB">
-                        <a:alpha val="100000"/>
+                      <a:srgbClr val="FFFFFF">
+                        <a:alpha val="0"/>
                       </a:srgbClr>
                     </a:solidFill>
                   </a:tcPr>
@@ -25538,8 +25825,8 @@
                       <a:prstDash val="solid"/>
                     </a:lnB>
                     <a:solidFill>
-                      <a:srgbClr val="FFFFFF">
-                        <a:alpha val="0"/>
+                      <a:srgbClr val="F4F8FB">
+                        <a:alpha val="100000"/>
                       </a:srgbClr>
                     </a:solidFill>
                   </a:tcPr>
@@ -25595,8 +25882,8 @@
                       <a:prstDash val="solid"/>
                     </a:lnB>
                     <a:solidFill>
-                      <a:srgbClr val="FFFFFF">
-                        <a:alpha val="0"/>
+                      <a:srgbClr val="F4F8FB">
+                        <a:alpha val="100000"/>
                       </a:srgbClr>
                     </a:solidFill>
                   </a:tcPr>
@@ -25652,8 +25939,8 @@
                       <a:prstDash val="solid"/>
                     </a:lnB>
                     <a:solidFill>
-                      <a:srgbClr val="FFFFFF">
-                        <a:alpha val="0"/>
+                      <a:srgbClr val="F4F8FB">
+                        <a:alpha val="100000"/>
                       </a:srgbClr>
                     </a:solidFill>
                   </a:tcPr>
@@ -25709,8 +25996,8 @@
                       <a:prstDash val="solid"/>
                     </a:lnB>
                     <a:solidFill>
-                      <a:srgbClr val="FFFFFF">
-                        <a:alpha val="0"/>
+                      <a:srgbClr val="F4F8FB">
+                        <a:alpha val="100000"/>
                       </a:srgbClr>
                     </a:solidFill>
                   </a:tcPr>
@@ -25766,8 +26053,8 @@
                       <a:prstDash val="solid"/>
                     </a:lnB>
                     <a:solidFill>
-                      <a:srgbClr val="FFFFFF">
-                        <a:alpha val="0"/>
+                      <a:srgbClr val="F4F8FB">
+                        <a:alpha val="100000"/>
                       </a:srgbClr>
                     </a:solidFill>
                   </a:tcPr>
@@ -25825,8 +26112,8 @@
                       <a:prstDash val="solid"/>
                     </a:lnB>
                     <a:solidFill>
-                      <a:srgbClr val="F4F8FB">
-                        <a:alpha val="100000"/>
+                      <a:srgbClr val="FFFFFF">
+                        <a:alpha val="0"/>
                       </a:srgbClr>
                     </a:solidFill>
                   </a:tcPr>
@@ -25882,8 +26169,8 @@
                       <a:prstDash val="solid"/>
                     </a:lnB>
                     <a:solidFill>
-                      <a:srgbClr val="F4F8FB">
-                        <a:alpha val="100000"/>
+                      <a:srgbClr val="FFFFFF">
+                        <a:alpha val="0"/>
                       </a:srgbClr>
                     </a:solidFill>
                   </a:tcPr>
@@ -25939,8 +26226,8 @@
                       <a:prstDash val="solid"/>
                     </a:lnB>
                     <a:solidFill>
-                      <a:srgbClr val="F4F8FB">
-                        <a:alpha val="100000"/>
+                      <a:srgbClr val="FFFFFF">
+                        <a:alpha val="0"/>
                       </a:srgbClr>
                     </a:solidFill>
                   </a:tcPr>
@@ -25996,8 +26283,8 @@
                       <a:prstDash val="solid"/>
                     </a:lnB>
                     <a:solidFill>
-                      <a:srgbClr val="F4F8FB">
-                        <a:alpha val="100000"/>
+                      <a:srgbClr val="FFFFFF">
+                        <a:alpha val="0"/>
                       </a:srgbClr>
                     </a:solidFill>
                   </a:tcPr>
@@ -26053,8 +26340,8 @@
                       <a:prstDash val="solid"/>
                     </a:lnB>
                     <a:solidFill>
-                      <a:srgbClr val="F4F8FB">
-                        <a:alpha val="100000"/>
+                      <a:srgbClr val="FFFFFF">
+                        <a:alpha val="0"/>
                       </a:srgbClr>
                     </a:solidFill>
                   </a:tcPr>
@@ -26112,8 +26399,8 @@
                       <a:prstDash val="solid"/>
                     </a:lnB>
                     <a:solidFill>
-                      <a:srgbClr val="FFFFFF">
-                        <a:alpha val="0"/>
+                      <a:srgbClr val="F4F8FB">
+                        <a:alpha val="100000"/>
                       </a:srgbClr>
                     </a:solidFill>
                   </a:tcPr>
@@ -26169,8 +26456,8 @@
                       <a:prstDash val="solid"/>
                     </a:lnB>
                     <a:solidFill>
-                      <a:srgbClr val="FFFFFF">
-                        <a:alpha val="0"/>
+                      <a:srgbClr val="F4F8FB">
+                        <a:alpha val="100000"/>
                       </a:srgbClr>
                     </a:solidFill>
                   </a:tcPr>
@@ -26226,8 +26513,8 @@
                       <a:prstDash val="solid"/>
                     </a:lnB>
                     <a:solidFill>
-                      <a:srgbClr val="FFFFFF">
-                        <a:alpha val="0"/>
+                      <a:srgbClr val="F4F8FB">
+                        <a:alpha val="100000"/>
                       </a:srgbClr>
                     </a:solidFill>
                   </a:tcPr>
@@ -26283,8 +26570,8 @@
                       <a:prstDash val="solid"/>
                     </a:lnB>
                     <a:solidFill>
-                      <a:srgbClr val="FFFFFF">
-                        <a:alpha val="0"/>
+                      <a:srgbClr val="F4F8FB">
+                        <a:alpha val="100000"/>
                       </a:srgbClr>
                     </a:solidFill>
                   </a:tcPr>
@@ -26340,8 +26627,8 @@
                       <a:prstDash val="solid"/>
                     </a:lnB>
                     <a:solidFill>
-                      <a:srgbClr val="FFFFFF">
-                        <a:alpha val="0"/>
+                      <a:srgbClr val="F4F8FB">
+                        <a:alpha val="100000"/>
                       </a:srgbClr>
                     </a:solidFill>
                   </a:tcPr>
@@ -26399,8 +26686,8 @@
                       <a:prstDash val="solid"/>
                     </a:lnB>
                     <a:solidFill>
-                      <a:srgbClr val="F4F8FB">
-                        <a:alpha val="100000"/>
+                      <a:srgbClr val="FFFFFF">
+                        <a:alpha val="0"/>
                       </a:srgbClr>
                     </a:solidFill>
                   </a:tcPr>
@@ -26456,8 +26743,8 @@
                       <a:prstDash val="solid"/>
                     </a:lnB>
                     <a:solidFill>
-                      <a:srgbClr val="F4F8FB">
-                        <a:alpha val="100000"/>
+                      <a:srgbClr val="FFFFFF">
+                        <a:alpha val="0"/>
                       </a:srgbClr>
                     </a:solidFill>
                   </a:tcPr>
@@ -26513,8 +26800,8 @@
                       <a:prstDash val="solid"/>
                     </a:lnB>
                     <a:solidFill>
-                      <a:srgbClr val="F4F8FB">
-                        <a:alpha val="100000"/>
+                      <a:srgbClr val="FFFFFF">
+                        <a:alpha val="0"/>
                       </a:srgbClr>
                     </a:solidFill>
                   </a:tcPr>
@@ -26570,8 +26857,8 @@
                       <a:prstDash val="solid"/>
                     </a:lnB>
                     <a:solidFill>
-                      <a:srgbClr val="F4F8FB">
-                        <a:alpha val="100000"/>
+                      <a:srgbClr val="FFFFFF">
+                        <a:alpha val="0"/>
                       </a:srgbClr>
                     </a:solidFill>
                   </a:tcPr>
@@ -26627,8 +26914,8 @@
                       <a:prstDash val="solid"/>
                     </a:lnB>
                     <a:solidFill>
-                      <a:srgbClr val="F4F8FB">
-                        <a:alpha val="100000"/>
+                      <a:srgbClr val="FFFFFF">
+                        <a:alpha val="0"/>
                       </a:srgbClr>
                     </a:solidFill>
                   </a:tcPr>
@@ -26686,8 +26973,8 @@
                       <a:prstDash val="solid"/>
                     </a:lnB>
                     <a:solidFill>
-                      <a:srgbClr val="FFFFFF">
-                        <a:alpha val="0"/>
+                      <a:srgbClr val="F4F8FB">
+                        <a:alpha val="100000"/>
                       </a:srgbClr>
                     </a:solidFill>
                   </a:tcPr>
@@ -26743,8 +27030,8 @@
                       <a:prstDash val="solid"/>
                     </a:lnB>
                     <a:solidFill>
-                      <a:srgbClr val="FFFFFF">
-                        <a:alpha val="0"/>
+                      <a:srgbClr val="F4F8FB">
+                        <a:alpha val="100000"/>
                       </a:srgbClr>
                     </a:solidFill>
                   </a:tcPr>
@@ -26800,8 +27087,8 @@
                       <a:prstDash val="solid"/>
                     </a:lnB>
                     <a:solidFill>
-                      <a:srgbClr val="FFFFFF">
-                        <a:alpha val="0"/>
+                      <a:srgbClr val="F4F8FB">
+                        <a:alpha val="100000"/>
                       </a:srgbClr>
                     </a:solidFill>
                   </a:tcPr>
@@ -26857,8 +27144,8 @@
                       <a:prstDash val="solid"/>
                     </a:lnB>
                     <a:solidFill>
-                      <a:srgbClr val="FFFFFF">
-                        <a:alpha val="0"/>
+                      <a:srgbClr val="F4F8FB">
+                        <a:alpha val="100000"/>
                       </a:srgbClr>
                     </a:solidFill>
                   </a:tcPr>
@@ -26914,8 +27201,8 @@
                       <a:prstDash val="solid"/>
                     </a:lnB>
                     <a:solidFill>
-                      <a:srgbClr val="FFFFFF">
-                        <a:alpha val="0"/>
+                      <a:srgbClr val="F4F8FB">
+                        <a:alpha val="100000"/>
                       </a:srgbClr>
                     </a:solidFill>
                   </a:tcPr>
@@ -26973,8 +27260,8 @@
                       <a:prstDash val="solid"/>
                     </a:lnB>
                     <a:solidFill>
-                      <a:srgbClr val="F4F8FB">
-                        <a:alpha val="100000"/>
+                      <a:srgbClr val="FFFFFF">
+                        <a:alpha val="0"/>
                       </a:srgbClr>
                     </a:solidFill>
                   </a:tcPr>
@@ -27030,8 +27317,8 @@
                       <a:prstDash val="solid"/>
                     </a:lnB>
                     <a:solidFill>
-                      <a:srgbClr val="F4F8FB">
-                        <a:alpha val="100000"/>
+                      <a:srgbClr val="FFFFFF">
+                        <a:alpha val="0"/>
                       </a:srgbClr>
                     </a:solidFill>
                   </a:tcPr>
@@ -27087,8 +27374,8 @@
                       <a:prstDash val="solid"/>
                     </a:lnB>
                     <a:solidFill>
-                      <a:srgbClr val="F4F8FB">
-                        <a:alpha val="100000"/>
+                      <a:srgbClr val="FFFFFF">
+                        <a:alpha val="0"/>
                       </a:srgbClr>
                     </a:solidFill>
                   </a:tcPr>
@@ -27144,8 +27431,8 @@
                       <a:prstDash val="solid"/>
                     </a:lnB>
                     <a:solidFill>
-                      <a:srgbClr val="F4F8FB">
-                        <a:alpha val="100000"/>
+                      <a:srgbClr val="FFFFFF">
+                        <a:alpha val="0"/>
                       </a:srgbClr>
                     </a:solidFill>
                   </a:tcPr>
@@ -27201,8 +27488,8 @@
                       <a:prstDash val="solid"/>
                     </a:lnB>
                     <a:solidFill>
-                      <a:srgbClr val="F4F8FB">
-                        <a:alpha val="100000"/>
+                      <a:srgbClr val="FFFFFF">
+                        <a:alpha val="0"/>
                       </a:srgbClr>
                     </a:solidFill>
                   </a:tcPr>
@@ -27260,8 +27547,8 @@
                       <a:prstDash val="solid"/>
                     </a:lnB>
                     <a:solidFill>
-                      <a:srgbClr val="FFFFFF">
-                        <a:alpha val="0"/>
+                      <a:srgbClr val="F4F8FB">
+                        <a:alpha val="100000"/>
                       </a:srgbClr>
                     </a:solidFill>
                   </a:tcPr>
@@ -27317,8 +27604,8 @@
                       <a:prstDash val="solid"/>
                     </a:lnB>
                     <a:solidFill>
-                      <a:srgbClr val="FFFFFF">
-                        <a:alpha val="0"/>
+                      <a:srgbClr val="F4F8FB">
+                        <a:alpha val="100000"/>
                       </a:srgbClr>
                     </a:solidFill>
                   </a:tcPr>
@@ -27374,8 +27661,8 @@
                       <a:prstDash val="solid"/>
                     </a:lnB>
                     <a:solidFill>
-                      <a:srgbClr val="FFFFFF">
-                        <a:alpha val="0"/>
+                      <a:srgbClr val="F4F8FB">
+                        <a:alpha val="100000"/>
                       </a:srgbClr>
                     </a:solidFill>
                   </a:tcPr>
@@ -27431,8 +27718,8 @@
                       <a:prstDash val="solid"/>
                     </a:lnB>
                     <a:solidFill>
-                      <a:srgbClr val="FFFFFF">
-                        <a:alpha val="0"/>
+                      <a:srgbClr val="F4F8FB">
+                        <a:alpha val="100000"/>
                       </a:srgbClr>
                     </a:solidFill>
                   </a:tcPr>
@@ -27488,8 +27775,8 @@
                       <a:prstDash val="solid"/>
                     </a:lnB>
                     <a:solidFill>
-                      <a:srgbClr val="FFFFFF">
-                        <a:alpha val="0"/>
+                      <a:srgbClr val="F4F8FB">
+                        <a:alpha val="100000"/>
                       </a:srgbClr>
                     </a:solidFill>
                   </a:tcPr>
@@ -27547,8 +27834,8 @@
                       <a:prstDash val="solid"/>
                     </a:lnB>
                     <a:solidFill>
-                      <a:srgbClr val="F4F8FB">
-                        <a:alpha val="100000"/>
+                      <a:srgbClr val="FFFFFF">
+                        <a:alpha val="0"/>
                       </a:srgbClr>
                     </a:solidFill>
                   </a:tcPr>
@@ -27604,8 +27891,8 @@
                       <a:prstDash val="solid"/>
                     </a:lnB>
                     <a:solidFill>
-                      <a:srgbClr val="F4F8FB">
-                        <a:alpha val="100000"/>
+                      <a:srgbClr val="FFFFFF">
+                        <a:alpha val="0"/>
                       </a:srgbClr>
                     </a:solidFill>
                   </a:tcPr>
@@ -27661,8 +27948,8 @@
                       <a:prstDash val="solid"/>
                     </a:lnB>
                     <a:solidFill>
-                      <a:srgbClr val="F4F8FB">
-                        <a:alpha val="100000"/>
+                      <a:srgbClr val="FFFFFF">
+                        <a:alpha val="0"/>
                       </a:srgbClr>
                     </a:solidFill>
                   </a:tcPr>
@@ -27696,7 +27983,7 @@
                           <a:ea typeface="Helvetica Neue"/>
                           <a:sym typeface="Helvetica Neue"/>
                         </a:rPr>
-                        <a:t>19</a:t>
+                        <a:t>20</a:t>
                       </a:r>
                     </a:p>
                   </a:txBody>
@@ -27718,8 +28005,8 @@
                       <a:prstDash val="solid"/>
                     </a:lnB>
                     <a:solidFill>
-                      <a:srgbClr val="F4F8FB">
-                        <a:alpha val="100000"/>
+                      <a:srgbClr val="FFFFFF">
+                        <a:alpha val="0"/>
                       </a:srgbClr>
                     </a:solidFill>
                   </a:tcPr>
@@ -27775,293 +28062,6 @@
                       <a:prstDash val="solid"/>
                     </a:lnB>
                     <a:solidFill>
-                      <a:srgbClr val="F4F8FB">
-                        <a:alpha val="100000"/>
-                      </a:srgbClr>
-                    </a:solidFill>
-                  </a:tcPr>
-                </a:tc>
-              </a:tr>
-              <a:tr h="401320">
-                <a:tc>
-                  <a:txBody>
-                    <a:bodyPr/>
-                    <a:lstStyle/>
-                    <a:p>
-                      <a:pPr algn="l" marL="63500" marR="63500">
-                        <a:lnSpc>
-                          <a:spcPct val="100000"/>
-                        </a:lnSpc>
-                        <a:spcBef>
-                          <a:spcPts val="500"/>
-                        </a:spcBef>
-                        <a:spcAft>
-                          <a:spcPts val="500"/>
-                        </a:spcAft>
-                        <a:buNone/>
-                      </a:pPr>
-                      <a:r>
-                        <a:rPr cap="none" sz="1200" i="0" b="0" u="none" strike="noStrike">
-                          <a:solidFill>
-                            <a:srgbClr val="5B6770">
-                              <a:alpha val="100000"/>
-                            </a:srgbClr>
-                          </a:solidFill>
-                          <a:latin typeface="Helvetica Neue"/>
-                          <a:cs typeface="Helvetica Neue"/>
-                          <a:ea typeface="Helvetica Neue"/>
-                          <a:sym typeface="Helvetica Neue"/>
-                        </a:rPr>
-                        <a:t>2-fluoro-2-oxo-PCPr</a:t>
-                      </a:r>
-                    </a:p>
-                  </a:txBody>
-                  <a:tcPr anchor="ctr" marB="63500" marT="63500" marR="0" marL="0">
-                    <a:lnL algn="ctr" cmpd="sng" cap="flat" w="0">
-                      <a:noFill/>
-                      <a:prstDash val="solid"/>
-                    </a:lnL>
-                    <a:lnR algn="ctr" cmpd="sng" cap="flat" w="0">
-                      <a:noFill/>
-                      <a:prstDash val="solid"/>
-                    </a:lnR>
-                    <a:lnT algn="ctr" cmpd="sng" cap="flat" w="0">
-                      <a:noFill/>
-                      <a:prstDash val="solid"/>
-                    </a:lnT>
-                    <a:lnB algn="ctr" cmpd="sng" cap="flat" w="0">
-                      <a:noFill/>
-                      <a:prstDash val="solid"/>
-                    </a:lnB>
-                    <a:solidFill>
-                      <a:srgbClr val="FFFFFF">
-                        <a:alpha val="0"/>
-                      </a:srgbClr>
-                    </a:solidFill>
-                  </a:tcPr>
-                </a:tc>
-                <a:tc>
-                  <a:txBody>
-                    <a:bodyPr/>
-                    <a:lstStyle/>
-                    <a:p>
-                      <a:pPr algn="l" marL="63500" marR="63500">
-                        <a:lnSpc>
-                          <a:spcPct val="100000"/>
-                        </a:lnSpc>
-                        <a:spcBef>
-                          <a:spcPts val="500"/>
-                        </a:spcBef>
-                        <a:spcAft>
-                          <a:spcPts val="500"/>
-                        </a:spcAft>
-                        <a:buNone/>
-                      </a:pPr>
-                      <a:r>
-                        <a:rPr cap="none" sz="1200" i="0" b="0" u="none" strike="noStrike">
-                          <a:solidFill>
-                            <a:srgbClr val="5B6770">
-                              <a:alpha val="100000"/>
-                            </a:srgbClr>
-                          </a:solidFill>
-                          <a:latin typeface="Helvetica Neue"/>
-                          <a:cs typeface="Helvetica Neue"/>
-                          <a:ea typeface="Helvetica Neue"/>
-                          <a:sym typeface="Helvetica Neue"/>
-                        </a:rPr>
-                        <a:t>16 Jun 2026</a:t>
-                      </a:r>
-                    </a:p>
-                  </a:txBody>
-                  <a:tcPr anchor="ctr" marB="63500" marT="63500" marR="0" marL="0">
-                    <a:lnL algn="ctr" cmpd="sng" cap="flat" w="0">
-                      <a:noFill/>
-                      <a:prstDash val="solid"/>
-                    </a:lnL>
-                    <a:lnR algn="ctr" cmpd="sng" cap="flat" w="0">
-                      <a:noFill/>
-                      <a:prstDash val="solid"/>
-                    </a:lnR>
-                    <a:lnT algn="ctr" cmpd="sng" cap="flat" w="0">
-                      <a:noFill/>
-                      <a:prstDash val="solid"/>
-                    </a:lnT>
-                    <a:lnB algn="ctr" cmpd="sng" cap="flat" w="0">
-                      <a:noFill/>
-                      <a:prstDash val="solid"/>
-                    </a:lnB>
-                    <a:solidFill>
-                      <a:srgbClr val="FFFFFF">
-                        <a:alpha val="0"/>
-                      </a:srgbClr>
-                    </a:solidFill>
-                  </a:tcPr>
-                </a:tc>
-                <a:tc>
-                  <a:txBody>
-                    <a:bodyPr/>
-                    <a:lstStyle/>
-                    <a:p>
-                      <a:pPr algn="l" marL="63500" marR="63500">
-                        <a:lnSpc>
-                          <a:spcPct val="100000"/>
-                        </a:lnSpc>
-                        <a:spcBef>
-                          <a:spcPts val="500"/>
-                        </a:spcBef>
-                        <a:spcAft>
-                          <a:spcPts val="500"/>
-                        </a:spcAft>
-                        <a:buNone/>
-                      </a:pPr>
-                      <a:r>
-                        <a:rPr cap="none" sz="1200" i="0" b="0" u="none" strike="noStrike">
-                          <a:solidFill>
-                            <a:srgbClr val="5B6770">
-                              <a:alpha val="100000"/>
-                            </a:srgbClr>
-                          </a:solidFill>
-                          <a:latin typeface="Helvetica Neue"/>
-                          <a:cs typeface="Helvetica Neue"/>
-                          <a:ea typeface="Helvetica Neue"/>
-                          <a:sym typeface="Helvetica Neue"/>
-                        </a:rPr>
-                        <a:t>primary</a:t>
-                      </a:r>
-                    </a:p>
-                  </a:txBody>
-                  <a:tcPr anchor="ctr" marB="63500" marT="63500" marR="0" marL="0">
-                    <a:lnL algn="ctr" cmpd="sng" cap="flat" w="0">
-                      <a:noFill/>
-                      <a:prstDash val="solid"/>
-                    </a:lnL>
-                    <a:lnR algn="ctr" cmpd="sng" cap="flat" w="0">
-                      <a:noFill/>
-                      <a:prstDash val="solid"/>
-                    </a:lnR>
-                    <a:lnT algn="ctr" cmpd="sng" cap="flat" w="0">
-                      <a:noFill/>
-                      <a:prstDash val="solid"/>
-                    </a:lnT>
-                    <a:lnB algn="ctr" cmpd="sng" cap="flat" w="0">
-                      <a:noFill/>
-                      <a:prstDash val="solid"/>
-                    </a:lnB>
-                    <a:solidFill>
-                      <a:srgbClr val="FFFFFF">
-                        <a:alpha val="0"/>
-                      </a:srgbClr>
-                    </a:solidFill>
-                  </a:tcPr>
-                </a:tc>
-                <a:tc>
-                  <a:txBody>
-                    <a:bodyPr/>
-                    <a:lstStyle/>
-                    <a:p>
-                      <a:pPr algn="r" marL="63500" marR="63500">
-                        <a:lnSpc>
-                          <a:spcPct val="100000"/>
-                        </a:lnSpc>
-                        <a:spcBef>
-                          <a:spcPts val="500"/>
-                        </a:spcBef>
-                        <a:spcAft>
-                          <a:spcPts val="500"/>
-                        </a:spcAft>
-                        <a:buNone/>
-                      </a:pPr>
-                      <a:r>
-                        <a:rPr cap="none" sz="1200" i="0" b="0" u="none" strike="noStrike">
-                          <a:solidFill>
-                            <a:srgbClr val="5B6770">
-                              <a:alpha val="100000"/>
-                            </a:srgbClr>
-                          </a:solidFill>
-                          <a:latin typeface="Helvetica Neue"/>
-                          <a:cs typeface="Helvetica Neue"/>
-                          <a:ea typeface="Helvetica Neue"/>
-                          <a:sym typeface="Helvetica Neue"/>
-                        </a:rPr>
-                        <a:t>1</a:t>
-                      </a:r>
-                    </a:p>
-                  </a:txBody>
-                  <a:tcPr anchor="ctr" marB="63500" marT="63500" marR="0" marL="0">
-                    <a:lnL algn="ctr" cmpd="sng" cap="flat" w="0">
-                      <a:noFill/>
-                      <a:prstDash val="solid"/>
-                    </a:lnL>
-                    <a:lnR algn="ctr" cmpd="sng" cap="flat" w="0">
-                      <a:noFill/>
-                      <a:prstDash val="solid"/>
-                    </a:lnR>
-                    <a:lnT algn="ctr" cmpd="sng" cap="flat" w="0">
-                      <a:noFill/>
-                      <a:prstDash val="solid"/>
-                    </a:lnT>
-                    <a:lnB algn="ctr" cmpd="sng" cap="flat" w="0">
-                      <a:noFill/>
-                      <a:prstDash val="solid"/>
-                    </a:lnB>
-                    <a:solidFill>
-                      <a:srgbClr val="FFFFFF">
-                        <a:alpha val="0"/>
-                      </a:srgbClr>
-                    </a:solidFill>
-                  </a:tcPr>
-                </a:tc>
-                <a:tc>
-                  <a:txBody>
-                    <a:bodyPr/>
-                    <a:lstStyle/>
-                    <a:p>
-                      <a:pPr algn="l" marL="63500" marR="63500">
-                        <a:lnSpc>
-                          <a:spcPct val="100000"/>
-                        </a:lnSpc>
-                        <a:spcBef>
-                          <a:spcPts val="500"/>
-                        </a:spcBef>
-                        <a:spcAft>
-                          <a:spcPts val="500"/>
-                        </a:spcAft>
-                        <a:buNone/>
-                      </a:pPr>
-                      <a:r>
-                        <a:rPr cap="none" sz="1200" i="0" b="0" u="none" strike="noStrike">
-                          <a:solidFill>
-                            <a:srgbClr val="5B6770">
-                              <a:alpha val="100000"/>
-                            </a:srgbClr>
-                          </a:solidFill>
-                          <a:latin typeface="Helvetica Neue"/>
-                          <a:cs typeface="Helvetica Neue"/>
-                          <a:ea typeface="Helvetica Neue"/>
-                          <a:sym typeface="Helvetica Neue"/>
-                        </a:rPr>
-                        <a:t>603838</a:t>
-                      </a:r>
-                    </a:p>
-                  </a:txBody>
-                  <a:tcPr anchor="ctr" marB="63500" marT="63500" marR="0" marL="0">
-                    <a:lnL algn="ctr" cmpd="sng" cap="flat" w="0">
-                      <a:noFill/>
-                      <a:prstDash val="solid"/>
-                    </a:lnL>
-                    <a:lnR algn="ctr" cmpd="sng" cap="flat" w="0">
-                      <a:noFill/>
-                      <a:prstDash val="solid"/>
-                    </a:lnR>
-                    <a:lnT algn="ctr" cmpd="sng" cap="flat" w="0">
-                      <a:noFill/>
-                      <a:prstDash val="solid"/>
-                    </a:lnT>
-                    <a:lnB algn="ctr" cmpd="sng" cap="flat" w="0">
-                      <a:noFill/>
-                      <a:prstDash val="solid"/>
-                    </a:lnB>
-                    <a:solidFill>
                       <a:srgbClr val="FFFFFF">
                         <a:alpha val="0"/>
                       </a:srgbClr>
@@ -28099,7 +28099,7 @@
                           <a:ea typeface="Helvetica Neue"/>
                           <a:sym typeface="Helvetica Neue"/>
                         </a:rPr>
-                        <a:t>2-oxo-PCE (O-PCE)</a:t>
+                        <a:t>2-fluoro-2-oxo-PCPr</a:t>
                       </a:r>
                     </a:p>
                   </a:txBody>

</xml_diff>

<commit_message>
nightly deck: data through 2026-09-04
</commit_message>
<xml_diff>
--- a/docs/nc-drug-checking-latest.pptx
+++ b/docs/nc-drug-checking-latest.pptx
@@ -2418,7 +2418,7 @@
                 <a:ea typeface="Helvetica Neue"/>
                 <a:sym typeface="Helvetica Neue"/>
               </a:rPr>
-              <a:t>Generated Thursday, September 03, 2026 · 8:11 AM ET UNC Street Drug Analysis Lab · OpioidData.org · results.streetsafe.supply Download as PowerPoint</a:t>
+              <a:t>Generated Friday, September 04, 2026 · 8:13 AM ET UNC Street Drug Analysis Lab · OpioidData.org · results.streetsafe.supply Download as PowerPoint</a:t>
             </a:r>
           </a:p>
         </p:txBody>
@@ -3184,7 +3184,7 @@
                 <a:ea typeface="Helvetica Neue"/>
                 <a:sym typeface="Helvetica Neue"/>
               </a:rPr>
-              <a:t>County = samplecounty · left: ≥1 completed analysis ever · right: unique samples per county (sqrt color scale) · all time: 26 Jan 2022 – 02 Sep 2026 · last 12 months: 03 Sep 2025 – 02 Sep 2026* · coverage reflects participation, not prevalence</a:t>
+              <a:t>County = samplecounty · left: ≥1 completed analysis ever · right: unique samples per county (sqrt color scale) · all time: 26 Jan 2022 – 02 Sep 2026 · last 12 months: 04 Sep 2025 – 02 Sep 2026* · coverage reflects participation, not prevalence</a:t>
             </a:r>
           </a:p>
         </p:txBody>
@@ -4323,7 +4323,7 @@
                 <a:ea typeface="Helvetica Neue"/>
                 <a:sym typeface="Helvetica Neue"/>
               </a:rPr>
-              <a:t>Samples with methamphetamine or cocaine detected (any abundance); samples in both classes appear on both slides · sensations semicolon lists parsed + sen_strength (own denominator) · consumed = 1 only · before: 26 Jan 2022 – 02 Sep 2025 · past 12 months: 03 Sep 2025 – 02 Sep 2026* · Δ in percentage points</a:t>
+              <a:t>Samples with methamphetamine or cocaine detected (any abundance); samples in both classes appear on both slides · sensations semicolon lists parsed + sen_strength (own denominator) · consumed = 1 only · before: 26 Jan 2022 – 02 Sep 2025 · past 12 months: 04 Sep 2025 – 02 Sep 2026* · Δ in percentage points</a:t>
             </a:r>
           </a:p>
         </p:txBody>
@@ -4742,7 +4742,7 @@
                 <a:ea typeface="Helvetica Neue"/>
                 <a:sym typeface="Helvetica Neue"/>
               </a:rPr>
-              <a:t>Samples with an opioid (fentanyl, heroin) or benzodiazepine detected (any abundance); samples in both classes appear on both slides · sensations semicolon lists parsed + sen_strength (own denominator) · consumed = 1 only · before: 26 Jan 2022 – 02 Sep 2025 · past 12 months: 03 Sep 2025 – 02 Sep 2026* · Δ in percentage points</a:t>
+              <a:t>Samples with an opioid (fentanyl, heroin) or benzodiazepine detected (any abundance); samples in both classes appear on both slides · sensations semicolon lists parsed + sen_strength (own denominator) · consumed = 1 only · before: 26 Jan 2022 – 02 Sep 2025 · past 12 months: 04 Sep 2025 – 02 Sep 2026* · Δ in percentage points</a:t>
             </a:r>
           </a:p>
         </p:txBody>
@@ -5855,7 +5855,7 @@
                 <a:ea typeface="Helvetica Neue"/>
                 <a:sym typeface="Helvetica Neue"/>
               </a:rPr>
-              <a:t>lab_detail.substance counts · solid = primary abundance, light = trace · standardized names (PubChem-linked) · window: date_complete 03 Sep 2025 – 02 Sep 2026* (trailing 12 months, current month partial)</a:t>
+              <a:t>lab_detail.substance counts · solid = primary abundance, light = trace · standardized names (PubChem-linked) · window: date_complete 04 Sep 2025 – 02 Sep 2026* (trailing 12 months, current month partial)</a:t>
             </a:r>
           </a:p>
         </p:txBody>
@@ -6053,7 +6053,7 @@
                 <a:ea typeface="Helvetica Neue"/>
                 <a:sym typeface="Helvetica Neue"/>
               </a:rPr>
-              <a:t>Distribution of substances detected per sample, both definitions shown side by side · window: date_complete 03 Sep 2025 – 02 Sep 2026* (trailing 12 months, current month partial)</a:t>
+              <a:t>Distribution of substances detected per sample, both definitions shown side by side · window: date_complete 04 Sep 2025 – 02 Sep 2026* (trailing 12 months, current month partial)</a:t>
             </a:r>
           </a:p>
         </p:txBody>

</xml_diff>

<commit_message>
nightly deck: data through 2026-09-05
</commit_message>
<xml_diff>
--- a/docs/nc-drug-checking-latest.pptx
+++ b/docs/nc-drug-checking-latest.pptx
@@ -2418,7 +2418,7 @@
                 <a:ea typeface="Helvetica Neue"/>
                 <a:sym typeface="Helvetica Neue"/>
               </a:rPr>
-              <a:t>Generated Friday, September 04, 2026 · 8:13 AM ET UNC Street Drug Analysis Lab · OpioidData.org · results.streetsafe.supply Download as PowerPoint</a:t>
+              <a:t>Generated Saturday, September 05, 2026 · 7:20 AM ET UNC Street Drug Analysis Lab · OpioidData.org · results.streetsafe.supply Download as PowerPoint</a:t>
             </a:r>
           </a:p>
         </p:txBody>
@@ -3184,7 +3184,7 @@
                 <a:ea typeface="Helvetica Neue"/>
                 <a:sym typeface="Helvetica Neue"/>
               </a:rPr>
-              <a:t>County = samplecounty · left: ≥1 completed analysis ever · right: unique samples per county (sqrt color scale) · all time: 26 Jan 2022 – 02 Sep 2026 · last 12 months: 04 Sep 2025 – 02 Sep 2026* · coverage reflects participation, not prevalence</a:t>
+              <a:t>County = samplecounty · left: ≥1 completed analysis ever · right: unique samples per county (sqrt color scale) · all time: 26 Jan 2022 – 02 Sep 2026 · last 12 months: 05 Sep 2025 – 02 Sep 2026* · coverage reflects participation, not prevalence</a:t>
             </a:r>
           </a:p>
         </p:txBody>
@@ -4323,7 +4323,7 @@
                 <a:ea typeface="Helvetica Neue"/>
                 <a:sym typeface="Helvetica Neue"/>
               </a:rPr>
-              <a:t>Samples with methamphetamine or cocaine detected (any abundance); samples in both classes appear on both slides · sensations semicolon lists parsed + sen_strength (own denominator) · consumed = 1 only · before: 26 Jan 2022 – 02 Sep 2025 · past 12 months: 04 Sep 2025 – 02 Sep 2026* · Δ in percentage points</a:t>
+              <a:t>Samples with methamphetamine or cocaine detected (any abundance); samples in both classes appear on both slides · sensations semicolon lists parsed + sen_strength (own denominator) · consumed = 1 only · before: 26 Jan 2022 – 02 Sep 2025 · past 12 months: 05 Sep 2025 – 02 Sep 2026* · Δ in percentage points</a:t>
             </a:r>
           </a:p>
         </p:txBody>
@@ -4742,7 +4742,7 @@
                 <a:ea typeface="Helvetica Neue"/>
                 <a:sym typeface="Helvetica Neue"/>
               </a:rPr>
-              <a:t>Samples with an opioid (fentanyl, heroin) or benzodiazepine detected (any abundance); samples in both classes appear on both slides · sensations semicolon lists parsed + sen_strength (own denominator) · consumed = 1 only · before: 26 Jan 2022 – 02 Sep 2025 · past 12 months: 04 Sep 2025 – 02 Sep 2026* · Δ in percentage points</a:t>
+              <a:t>Samples with an opioid (fentanyl, heroin) or benzodiazepine detected (any abundance); samples in both classes appear on both slides · sensations semicolon lists parsed + sen_strength (own denominator) · consumed = 1 only · before: 26 Jan 2022 – 02 Sep 2025 · past 12 months: 05 Sep 2025 – 02 Sep 2026* · Δ in percentage points</a:t>
             </a:r>
           </a:p>
         </p:txBody>
@@ -5855,7 +5855,7 @@
                 <a:ea typeface="Helvetica Neue"/>
                 <a:sym typeface="Helvetica Neue"/>
               </a:rPr>
-              <a:t>lab_detail.substance counts · solid = primary abundance, light = trace · standardized names (PubChem-linked) · window: date_complete 04 Sep 2025 – 02 Sep 2026* (trailing 12 months, current month partial)</a:t>
+              <a:t>lab_detail.substance counts · solid = primary abundance, light = trace · standardized names (PubChem-linked) · window: date_complete 05 Sep 2025 – 02 Sep 2026* (trailing 12 months, current month partial)</a:t>
             </a:r>
           </a:p>
         </p:txBody>
@@ -6053,7 +6053,7 @@
                 <a:ea typeface="Helvetica Neue"/>
                 <a:sym typeface="Helvetica Neue"/>
               </a:rPr>
-              <a:t>Distribution of substances detected per sample, both definitions shown side by side · window: date_complete 04 Sep 2025 – 02 Sep 2026* (trailing 12 months, current month partial)</a:t>
+              <a:t>Distribution of substances detected per sample, both definitions shown side by side · window: date_complete 05 Sep 2025 – 02 Sep 2026* (trailing 12 months, current month partial)</a:t>
             </a:r>
           </a:p>
         </p:txBody>

</xml_diff>